<commit_message>
fix: acentuação pt-BR e remoção de travessões nos artefatos e textos
</commit_message>
<xml_diff>
--- a/slides/seminario_masked_modeling.pptx
+++ b/slides/seminario_masked_modeling.pptx
@@ -4097,7 +4097,7 @@
               <a:defRPr sz="1700"/>
             </a:pPr>
             <a:r>
-              <a:t>Tempo medido por época na RTX 3050 (na condição 75%): 0.85 s</a:t>
+              <a:t>Tempo medido por época na RTX 3050 (na condição 75%): 0.58 s</a:t>
             </a:r>
           </a:p>
           <a:p>
@@ -4210,7 +4210,7 @@
               <a:defRPr sz="1400"/>
             </a:pPr>
             <a:r>
-              <a:t>8 imagens fixas do teste (seed 42): original, mascarada e reconstrucao por condicao</a:t>
+              <a:t>8 imagens fixas do teste (seed 42): original, mascarada e reconstrução por condição</a:t>
             </a:r>
           </a:p>
         </p:txBody>

</xml_diff>

<commit_message>
feat(completar-entrega-seminario): slides didáticos completos e pacote entregue com testes de cobertura
</commit_message>
<xml_diff>
--- a/slides/seminario_masked_modeling.pptx
+++ b/slides/seminario_masked_modeling.pptx
@@ -3192,14 +3192,47 @@
               <a:defRPr sz="3000"/>
             </a:pPr>
             <a:r>
-              <a:t>Resultados: curva de perda de validação</a:t>
+              <a:t>Resultados: reconstruções e curva de perda</a:t>
+            </a:r>
+          </a:p>
+        </p:txBody>
+      </p:sp>
+      <p:sp>
+        <p:nvSpPr>
+          <p:cNvPr id="3" name="TextBox 2"/>
+          <p:cNvSpPr txBox="1"/>
+          <p:nvPr/>
+        </p:nvSpPr>
+        <p:spPr>
+          <a:xfrm>
+            <a:off x="612648" y="1325880"/>
+            <a:ext cx="10972800" cy="310896"/>
+          </a:xfrm>
+          <a:prstGeom prst="rect">
+            <a:avLst/>
+          </a:prstGeom>
+          <a:noFill/>
+        </p:spPr>
+        <p:txBody>
+          <a:bodyPr wrap="square">
+            <a:spAutoFit/>
+          </a:bodyPr>
+          <a:lstStyle/>
+          <a:p>
+            <a:pPr>
+              <a:defRPr sz="1300" b="1">
+                <a:latin typeface="Arial"/>
+              </a:defRPr>
+            </a:pPr>
+            <a:r>
+              <a:t>Reconstruções: 8 imagens fixas do teste (seed 42)</a:t>
             </a:r>
           </a:p>
         </p:txBody>
       </p:sp>
       <p:pic>
         <p:nvPicPr>
-          <p:cNvPr id="3" name="Picture 2" descr="curva_perda.png"/>
+          <p:cNvPr id="4" name="Picture 3" descr="reconstrucoes.png"/>
           <p:cNvPicPr>
             <a:picLocks noChangeAspect="1"/>
           </p:cNvPicPr>
@@ -3213,8 +3246,8 @@
         </p:blipFill>
         <p:spPr>
           <a:xfrm>
-            <a:off x="2218791" y="1371600"/>
-            <a:ext cx="7754112" cy="4846320"/>
+            <a:off x="1295247" y="1876182"/>
+            <a:ext cx="9601200" cy="2182090"/>
           </a:xfrm>
           <a:prstGeom prst="rect">
             <a:avLst/>
@@ -3223,14 +3256,14 @@
       </p:pic>
       <p:sp>
         <p:nvSpPr>
-          <p:cNvPr id="4" name="TextBox 3"/>
+          <p:cNvPr id="5" name="TextBox 4"/>
           <p:cNvSpPr txBox="1"/>
           <p:nvPr/>
         </p:nvSpPr>
         <p:spPr>
           <a:xfrm>
-            <a:off x="612648" y="6355080"/>
-            <a:ext cx="10972800" cy="411480"/>
+            <a:off x="612648" y="4251959"/>
+            <a:ext cx="10972800" cy="310896"/>
           </a:xfrm>
           <a:prstGeom prst="rect">
             <a:avLst/>
@@ -3238,16 +3271,75 @@
           <a:noFill/>
         </p:spPr>
         <p:txBody>
-          <a:bodyPr wrap="none">
+          <a:bodyPr wrap="square">
             <a:spAutoFit/>
           </a:bodyPr>
           <a:lstStyle/>
           <a:p>
             <a:pPr>
-              <a:defRPr sz="1400"/>
-            </a:pPr>
-            <a:r>
-              <a:t>MSE de validação nos patches ocultos por época</a:t>
+              <a:defRPr sz="1300" b="1">
+                <a:latin typeface="Arial"/>
+              </a:defRPr>
+            </a:pPr>
+            <a:r>
+              <a:t>Curva de perda de validação: MSE nos patches ocultos por época</a:t>
+            </a:r>
+          </a:p>
+        </p:txBody>
+      </p:sp>
+      <p:pic>
+        <p:nvPicPr>
+          <p:cNvPr id="6" name="Picture 5" descr="curva_perda.png"/>
+          <p:cNvPicPr>
+            <a:picLocks noChangeAspect="1"/>
+          </p:cNvPicPr>
+          <p:nvPr/>
+        </p:nvPicPr>
+        <p:blipFill>
+          <a:blip r:embed="rId3"/>
+          <a:stretch>
+            <a:fillRect/>
+          </a:stretch>
+        </p:blipFill>
+        <p:spPr>
+          <a:xfrm>
+            <a:off x="4669383" y="4590288"/>
+            <a:ext cx="2852927" cy="1783080"/>
+          </a:xfrm>
+          <a:prstGeom prst="rect">
+            <a:avLst/>
+          </a:prstGeom>
+        </p:spPr>
+      </p:pic>
+      <p:sp>
+        <p:nvSpPr>
+          <p:cNvPr id="7" name="TextBox 6"/>
+          <p:cNvSpPr txBox="1"/>
+          <p:nvPr/>
+        </p:nvSpPr>
+        <p:spPr>
+          <a:xfrm>
+            <a:off x="612648" y="6400800"/>
+            <a:ext cx="10972800" cy="384048"/>
+          </a:xfrm>
+          <a:prstGeom prst="rect">
+            <a:avLst/>
+          </a:prstGeom>
+          <a:noFill/>
+        </p:spPr>
+        <p:txBody>
+          <a:bodyPr wrap="square">
+            <a:spAutoFit/>
+          </a:bodyPr>
+          <a:lstStyle/>
+          <a:p>
+            <a:pPr>
+              <a:defRPr sz="1300" b="0">
+                <a:latin typeface="Arial"/>
+              </a:defRPr>
+            </a:pPr>
+            <a:r>
+              <a:t>Esquerda: original, mascarada e reconstrução por condição; direita: as duas condições no mesmo eixo</a:t>
             </a:r>
           </a:p>
         </p:txBody>
@@ -3289,7 +3381,7 @@
               <a:defRPr sz="3000"/>
             </a:pPr>
             <a:r>
-              <a:t>Lendo os números</a:t>
+              <a:t>Resultados, críticas e próximos passos</a:t>
             </a:r>
           </a:p>
         </p:txBody>
@@ -3321,7 +3413,7 @@
               <a:defRPr sz="1700"/>
             </a:pPr>
             <a:r>
-              <a:t>Épocas, batch e taxa de aprendizado foram igualados; a quantidade de computação por época diverge (4 contra 8 tokens no encoder)</a:t>
+              <a:t>Épocas, batch e lr igualados; a computação por época diverge (4 contra 8 tokens no encoder)</a:t>
             </a:r>
           </a:p>
           <a:p>
@@ -3329,7 +3421,7 @@
               <a:defRPr sz="1700"/>
             </a:pPr>
             <a:r>
-              <a:t>A diferença principal entre condições vem da taxa de ocultação</a:t>
+              <a:t>Máscara aninhada isola o efeito da taxa: os patches ocultos a 50% também estão a 75%</a:t>
             </a:r>
           </a:p>
           <a:p>
@@ -3337,7 +3429,7 @@
               <a:defRPr sz="1700"/>
             </a:pPr>
             <a:r>
-              <a:t>Máscara aninhada isola o efeito da taxa (mesmos patches ocultos a 50%)</a:t>
+              <a:t>Evidência desta configuração: semente única 42, teste fixo de 1.000 imagens e máscara aninhada</a:t>
             </a:r>
           </a:p>
           <a:p>
@@ -3345,7 +3437,31 @@
               <a:defRPr sz="1700"/>
             </a:pPr>
             <a:r>
-              <a:t>Semente única 42: comparação determinística, mas repetição com mais sementes é necessária</a:t>
+              <a:t>Não generalizar: repetir com mais sementes e avaliar downstream antes de concluir</a:t>
+            </a:r>
+          </a:p>
+          <a:p>
+            <a:pPr>
+              <a:defRPr sz="1700"/>
+            </a:pPr>
+            <a:r>
+              <a:t>Qualidade visual da reconstrução não é prova de representações melhores</a:t>
+            </a:r>
+          </a:p>
+          <a:p>
+            <a:pPr>
+              <a:defRPr sz="1700"/>
+            </a:pPr>
+            <a:r>
+              <a:t>Dataset pequeno e didático: qualidade absoluta menor que a do paper</a:t>
+            </a:r>
+          </a:p>
+          <a:p>
+            <a:pPr>
+              <a:defRPr sz="1700"/>
+            </a:pPr>
+            <a:r>
+              <a:t>Linear probing e classificação downstream fora do escopo; próximo passo: linear probing em mais sementes</a:t>
             </a:r>
           </a:p>
         </p:txBody>
@@ -3387,55 +3503,143 @@
               <a:defRPr sz="3000"/>
             </a:pPr>
             <a:r>
-              <a:t>Limitações e próximos passos</a:t>
-            </a:r>
-          </a:p>
-        </p:txBody>
-      </p:sp>
-      <p:sp>
-        <p:nvSpPr>
-          <p:cNvPr id="3" name="Content Placeholder 2"/>
-          <p:cNvSpPr>
-            <a:spLocks noGrp="1"/>
-          </p:cNvSpPr>
-          <p:nvPr>
-            <p:ph idx="1"/>
-          </p:nvPr>
-        </p:nvSpPr>
-        <p:spPr/>
-        <p:txBody>
-          <a:bodyPr/>
-          <a:lstStyle/>
-          <a:p>
-            <a:pPr>
-              <a:defRPr sz="1700"/>
-            </a:pPr>
-            <a:r>
-              <a:t>Dataset pequeno e didático: qualidade absoluta é menor que a do paper</a:t>
-            </a:r>
-          </a:p>
-          <a:p>
-            <a:pPr>
-              <a:defRPr sz="1700"/>
-            </a:pPr>
-            <a:r>
-              <a:t>Linear probing e classificação downstream: fora do escopo deste trabalho</a:t>
-            </a:r>
-          </a:p>
-          <a:p>
-            <a:pPr>
-              <a:defRPr sz="1700"/>
-            </a:pPr>
-            <a:r>
-              <a:t>Próximo passo: avaliar representações com linear probing em mais sementes</a:t>
-            </a:r>
-          </a:p>
-          <a:p>
-            <a:pPr>
-              <a:defRPr sz="1700"/>
-            </a:pPr>
-            <a:r>
-              <a:t>Referência: He et al. (2022), Masked Autoencoders Are Scalable Vision Learners</a:t>
+              <a:t>Aplicações e referências</a:t>
+            </a:r>
+          </a:p>
+        </p:txBody>
+      </p:sp>
+      <p:sp>
+        <p:nvSpPr>
+          <p:cNvPr id="3" name="TextBox 2"/>
+          <p:cNvSpPr txBox="1"/>
+          <p:nvPr/>
+        </p:nvSpPr>
+        <p:spPr>
+          <a:xfrm>
+            <a:off x="612648" y="1371600"/>
+            <a:ext cx="10972800" cy="2103120"/>
+          </a:xfrm>
+          <a:prstGeom prst="rect">
+            <a:avLst/>
+          </a:prstGeom>
+          <a:noFill/>
+        </p:spPr>
+        <p:txBody>
+          <a:bodyPr wrap="square">
+            <a:spAutoFit/>
+          </a:bodyPr>
+          <a:lstStyle/>
+          <a:p>
+            <a:pPr>
+              <a:defRPr sz="1500" b="1">
+                <a:latin typeface="Arial"/>
+              </a:defRPr>
+            </a:pPr>
+            <a:r>
+              <a:t>Aplicações das representações aprendidas:</a:t>
+            </a:r>
+          </a:p>
+          <a:p>
+            <a:pPr>
+              <a:defRPr sz="1400" b="0">
+                <a:latin typeface="Arial"/>
+              </a:defRPr>
+            </a:pPr>
+            <a:r>
+              <a:t>BERT: compreensão de linguagem (busca, classificação e diálogo)</a:t>
+            </a:r>
+          </a:p>
+          <a:p>
+            <a:pPr>
+              <a:defRPr sz="1400" b="0">
+                <a:latin typeface="Arial"/>
+              </a:defRPr>
+            </a:pPr>
+            <a:r>
+              <a:t>MAE: classificação, detecção e segmentação de imagens</a:t>
+            </a:r>
+          </a:p>
+          <a:p>
+            <a:pPr>
+              <a:defRPr sz="1400" b="0">
+                <a:latin typeface="Arial"/>
+              </a:defRPr>
+            </a:pPr>
+            <a:r>
+              <a:t>SimMIM: classificação, detecção e segmentação em imagens</a:t>
+            </a:r>
+          </a:p>
+        </p:txBody>
+      </p:sp>
+      <p:sp>
+        <p:nvSpPr>
+          <p:cNvPr id="4" name="TextBox 3"/>
+          <p:cNvSpPr txBox="1"/>
+          <p:nvPr/>
+        </p:nvSpPr>
+        <p:spPr>
+          <a:xfrm>
+            <a:off x="612648" y="3063240"/>
+            <a:ext cx="10972800" cy="3200400"/>
+          </a:xfrm>
+          <a:prstGeom prst="rect">
+            <a:avLst/>
+          </a:prstGeom>
+          <a:noFill/>
+        </p:spPr>
+        <p:txBody>
+          <a:bodyPr wrap="square">
+            <a:spAutoFit/>
+          </a:bodyPr>
+          <a:lstStyle/>
+          <a:p>
+            <a:pPr>
+              <a:defRPr sz="1500" b="1">
+                <a:latin typeface="Arial"/>
+              </a:defRPr>
+            </a:pPr>
+            <a:r>
+              <a:t>Referências:</a:t>
+            </a:r>
+          </a:p>
+          <a:p>
+            <a:pPr>
+              <a:defRPr sz="1200" b="0">
+                <a:latin typeface="Arial"/>
+              </a:defRPr>
+            </a:pPr>
+            <a:r>
+              <a:t>Devlin, J.; Chang, M.; Lee, K.; Toutanova, K. (2019). BERT: Pre-training of Deep Bidirectional Transformers for Language Understanding. NAACL-HLT.</a:t>
+            </a:r>
+          </a:p>
+          <a:p>
+            <a:pPr>
+              <a:defRPr sz="1200" b="0">
+                <a:latin typeface="Arial"/>
+              </a:defRPr>
+            </a:pPr>
+            <a:r>
+              <a:t>He, K.; Chen, X.; Xie, S.; Li, Y.; Dollár, P.; Girshick, R. (2022). Masked Autoencoders Are Scalable Vision Learners. CVPR.</a:t>
+            </a:r>
+          </a:p>
+          <a:p>
+            <a:pPr>
+              <a:defRPr sz="1200" b="0">
+                <a:latin typeface="Arial"/>
+              </a:defRPr>
+            </a:pPr>
+            <a:r>
+              <a:t>Xie, Z.; Zhang, Z.; Lin, Y.; Bian, J.; Lin, L.; Zeng, D. (2022). SimMIM: A Simple Framework for Masked Image Modeling. CVPR.</a:t>
+            </a:r>
+          </a:p>
+          <a:p>
+            <a:pPr>
+              <a:defRPr sz="1200" b="0">
+                <a:latin typeface="Arial"/>
+              </a:defRPr>
+            </a:pPr>
+            <a:r>
+              <a:t>Krizhevsky, A.; Nair, V.; Hinton, G. (2009). CIFAR-10 (Canadian Institute for Advanced Research). Fonte dos dados, verificado por md5.</a:t>
             </a:r>
           </a:p>
         </p:txBody>
@@ -3517,7 +3721,7 @@
               <a:defRPr sz="1700"/>
             </a:pPr>
             <a:r>
-              <a:t>Arquitetura de um Masked Autoencoder</a:t>
+              <a:t>Fluxo do MAE: diagrama, equação da perda e pseudocódigo</a:t>
             </a:r>
           </a:p>
           <a:p>
@@ -3525,7 +3729,7 @@
               <a:defRPr sz="1700"/>
             </a:pPr>
             <a:r>
-              <a:t>Nossa implementação: patches, máscara aninhada, perda</a:t>
+              <a:t>Arquitetura e nossa implementação</a:t>
             </a:r>
           </a:p>
           <a:p>
@@ -3533,7 +3737,7 @@
               <a:defRPr sz="1700"/>
             </a:pPr>
             <a:r>
-              <a:t>Protocolo e orcamento de treino</a:t>
+              <a:t>Protocolo e orçamento de treino</a:t>
             </a:r>
           </a:p>
           <a:p>
@@ -3550,6 +3754,14 @@
             </a:pPr>
             <a:r>
               <a:t>Resultados, críticas e próximos passos</a:t>
+            </a:r>
+          </a:p>
+          <a:p>
+            <a:pPr>
+              <a:defRPr sz="1700"/>
+            </a:pPr>
+            <a:r>
+              <a:t>Aplicações e referências</a:t>
             </a:r>
           </a:p>
         </p:txBody>
@@ -3694,50 +3906,373 @@
           </a:p>
         </p:txBody>
       </p:sp>
-      <p:sp>
-        <p:nvSpPr>
-          <p:cNvPr id="3" name="Content Placeholder 2"/>
-          <p:cNvSpPr>
-            <a:spLocks noGrp="1"/>
-          </p:cNvSpPr>
-          <p:nvPr>
-            <p:ph idx="1"/>
-          </p:nvPr>
-        </p:nvSpPr>
-        <p:spPr/>
-        <p:txBody>
-          <a:bodyPr/>
-          <a:lstStyle/>
-          <a:p>
-            <a:pPr>
-              <a:defRPr sz="1700"/>
-            </a:pPr>
-            <a:r>
-              <a:t>BERT (2018): mascarar tokens de texto e prever os ocultos</a:t>
-            </a:r>
-          </a:p>
-          <a:p>
-            <a:pPr>
-              <a:defRPr sz="1700"/>
-            </a:pPr>
-            <a:r>
-              <a:t>MAE (He et al., 2022): patches ocultos, encoder assimétrico, decoder leve</a:t>
-            </a:r>
-          </a:p>
-          <a:p>
-            <a:pPr>
-              <a:defRPr sz="1700"/>
-            </a:pPr>
-            <a:r>
-              <a:t>SimMIM (2022): mascarar pixels brutos com decoder simples</a:t>
-            </a:r>
-          </a:p>
-          <a:p>
-            <a:pPr>
-              <a:defRPr sz="1700"/>
-            </a:pPr>
-            <a:r>
-              <a:t>Diferença chave: o quanto se pode ocultar (75% funciona no MAE)</a:t>
+      <p:graphicFrame>
+        <p:nvGraphicFramePr>
+          <p:cNvPr id="3" name="Table 2"/>
+          <p:cNvGraphicFramePr>
+            <a:graphicFrameLocks noGrp="1"/>
+          </p:cNvGraphicFramePr>
+          <p:nvPr/>
+        </p:nvGraphicFramePr>
+        <p:xfrm>
+          <a:off x="502920" y="1371600"/>
+          <a:ext cx="11247120" cy="4023360"/>
+        </p:xfrm>
+        <a:graphic>
+          <a:graphicData uri="http://schemas.openxmlformats.org/drawingml/2006/table">
+            <a:tbl>
+              <a:tblPr firstRow="1" bandRow="1">
+                <a:tableStyleId>{5C22544A-7EE6-4342-B048-85BDC9FD1C3A}</a:tableStyleId>
+              </a:tblPr>
+              <a:tblGrid>
+                <a:gridCol w="1737360"/>
+                <a:gridCol w="3169920"/>
+                <a:gridCol w="3169920"/>
+                <a:gridCol w="3169920"/>
+              </a:tblGrid>
+              <a:tr h="804672">
+                <a:tc>
+                  <a:txBody>
+                    <a:bodyPr/>
+                    <a:lstStyle/>
+                    <a:p>
+                      <a:pPr>
+                        <a:defRPr sz="1500" b="1"/>
+                      </a:pPr>
+                      <a:r>
+                        <a:t>Dimensão</a:t>
+                      </a:r>
+                    </a:p>
+                  </a:txBody>
+                  <a:tcPr/>
+                </a:tc>
+                <a:tc>
+                  <a:txBody>
+                    <a:bodyPr/>
+                    <a:lstStyle/>
+                    <a:p>
+                      <a:pPr>
+                        <a:defRPr sz="1500" b="1"/>
+                      </a:pPr>
+                      <a:r>
+                        <a:t>BERT</a:t>
+                      </a:r>
+                    </a:p>
+                  </a:txBody>
+                  <a:tcPr/>
+                </a:tc>
+                <a:tc>
+                  <a:txBody>
+                    <a:bodyPr/>
+                    <a:lstStyle/>
+                    <a:p>
+                      <a:pPr>
+                        <a:defRPr sz="1500" b="1"/>
+                      </a:pPr>
+                      <a:r>
+                        <a:t>MAE</a:t>
+                      </a:r>
+                    </a:p>
+                  </a:txBody>
+                  <a:tcPr/>
+                </a:tc>
+                <a:tc>
+                  <a:txBody>
+                    <a:bodyPr/>
+                    <a:lstStyle/>
+                    <a:p>
+                      <a:pPr>
+                        <a:defRPr sz="1500" b="1"/>
+                      </a:pPr>
+                      <a:r>
+                        <a:t>SimMIM</a:t>
+                      </a:r>
+                    </a:p>
+                  </a:txBody>
+                  <a:tcPr/>
+                </a:tc>
+              </a:tr>
+              <a:tr h="804672">
+                <a:tc>
+                  <a:txBody>
+                    <a:bodyPr/>
+                    <a:lstStyle/>
+                    <a:p>
+                      <a:pPr>
+                        <a:defRPr sz="1200" b="1"/>
+                      </a:pPr>
+                      <a:r>
+                        <a:t>Modalidade</a:t>
+                      </a:r>
+                    </a:p>
+                  </a:txBody>
+                  <a:tcPr/>
+                </a:tc>
+                <a:tc>
+                  <a:txBody>
+                    <a:bodyPr/>
+                    <a:lstStyle/>
+                    <a:p>
+                      <a:pPr>
+                        <a:defRPr sz="1200" b="0"/>
+                      </a:pPr>
+                      <a:r>
+                        <a:t>Texto (tokens discretos)</a:t>
+                      </a:r>
+                    </a:p>
+                  </a:txBody>
+                  <a:tcPr/>
+                </a:tc>
+                <a:tc>
+                  <a:txBody>
+                    <a:bodyPr/>
+                    <a:lstStyle/>
+                    <a:p>
+                      <a:pPr>
+                        <a:defRPr sz="1200" b="0"/>
+                      </a:pPr>
+                      <a:r>
+                        <a:t>Imagem (patches de pixels)</a:t>
+                      </a:r>
+                    </a:p>
+                  </a:txBody>
+                  <a:tcPr/>
+                </a:tc>
+                <a:tc>
+                  <a:txBody>
+                    <a:bodyPr/>
+                    <a:lstStyle/>
+                    <a:p>
+                      <a:pPr>
+                        <a:defRPr sz="1200" b="0"/>
+                      </a:pPr>
+                      <a:r>
+                        <a:t>Imagem (patches de pixels)</a:t>
+                      </a:r>
+                    </a:p>
+                  </a:txBody>
+                  <a:tcPr/>
+                </a:tc>
+              </a:tr>
+              <a:tr h="804672">
+                <a:tc>
+                  <a:txBody>
+                    <a:bodyPr/>
+                    <a:lstStyle/>
+                    <a:p>
+                      <a:pPr>
+                        <a:defRPr sz="1200" b="1"/>
+                      </a:pPr>
+                      <a:r>
+                        <a:t>Alvo previsto</a:t>
+                      </a:r>
+                    </a:p>
+                  </a:txBody>
+                  <a:tcPr/>
+                </a:tc>
+                <a:tc>
+                  <a:txBody>
+                    <a:bodyPr/>
+                    <a:lstStyle/>
+                    <a:p>
+                      <a:pPr>
+                        <a:defRPr sz="1200" b="0"/>
+                      </a:pPr>
+                      <a:r>
+                        <a:t>Palavras (tokens) ocultas</a:t>
+                      </a:r>
+                    </a:p>
+                  </a:txBody>
+                  <a:tcPr/>
+                </a:tc>
+                <a:tc>
+                  <a:txBody>
+                    <a:bodyPr/>
+                    <a:lstStyle/>
+                    <a:p>
+                      <a:pPr>
+                        <a:defRPr sz="1200" b="0"/>
+                      </a:pPr>
+                      <a:r>
+                        <a:t>Pixels brutos dos patches ocultos</a:t>
+                      </a:r>
+                    </a:p>
+                  </a:txBody>
+                  <a:tcPr/>
+                </a:tc>
+                <a:tc>
+                  <a:txBody>
+                    <a:bodyPr/>
+                    <a:lstStyle/>
+                    <a:p>
+                      <a:pPr>
+                        <a:defRPr sz="1200" b="0"/>
+                      </a:pPr>
+                      <a:r>
+                        <a:t>Pixels brutos dos patches ocultos</a:t>
+                      </a:r>
+                    </a:p>
+                  </a:txBody>
+                  <a:tcPr/>
+                </a:tc>
+              </a:tr>
+              <a:tr h="804672">
+                <a:tc>
+                  <a:txBody>
+                    <a:bodyPr/>
+                    <a:lstStyle/>
+                    <a:p>
+                      <a:pPr>
+                        <a:defRPr sz="1200" b="1"/>
+                      </a:pPr>
+                      <a:r>
+                        <a:t>Perda</a:t>
+                      </a:r>
+                    </a:p>
+                  </a:txBody>
+                  <a:tcPr/>
+                </a:tc>
+                <a:tc>
+                  <a:txBody>
+                    <a:bodyPr/>
+                    <a:lstStyle/>
+                    <a:p>
+                      <a:pPr>
+                        <a:defRPr sz="1200" b="0"/>
+                      </a:pPr>
+                      <a:r>
+                        <a:t>Entropia cruzada sobre os tokens ocultos</a:t>
+                      </a:r>
+                    </a:p>
+                  </a:txBody>
+                  <a:tcPr/>
+                </a:tc>
+                <a:tc>
+                  <a:txBody>
+                    <a:bodyPr/>
+                    <a:lstStyle/>
+                    <a:p>
+                      <a:pPr>
+                        <a:defRPr sz="1200" b="0"/>
+                      </a:pPr>
+                      <a:r>
+                        <a:t>MSE nos pixels normalizados, média por patch oculto</a:t>
+                      </a:r>
+                    </a:p>
+                  </a:txBody>
+                  <a:tcPr/>
+                </a:tc>
+                <a:tc>
+                  <a:txBody>
+                    <a:bodyPr/>
+                    <a:lstStyle/>
+                    <a:p>
+                      <a:pPr>
+                        <a:defRPr sz="1200" b="0"/>
+                      </a:pPr>
+                      <a:r>
+                        <a:t>L1 (erro absoluto) nos pixels reconstruídos</a:t>
+                      </a:r>
+                    </a:p>
+                  </a:txBody>
+                  <a:tcPr/>
+                </a:tc>
+              </a:tr>
+              <a:tr h="804672">
+                <a:tc>
+                  <a:txBody>
+                    <a:bodyPr/>
+                    <a:lstStyle/>
+                    <a:p>
+                      <a:pPr>
+                        <a:defRPr sz="1200" b="1"/>
+                      </a:pPr>
+                      <a:r>
+                        <a:t>Arquitetura</a:t>
+                      </a:r>
+                    </a:p>
+                  </a:txBody>
+                  <a:tcPr/>
+                </a:tc>
+                <a:tc>
+                  <a:txBody>
+                    <a:bodyPr/>
+                    <a:lstStyle/>
+                    <a:p>
+                      <a:pPr>
+                        <a:defRPr sz="1200" b="0"/>
+                      </a:pPr>
+                      <a:r>
+                        <a:t>Encoder Transformer único</a:t>
+                      </a:r>
+                    </a:p>
+                  </a:txBody>
+                  <a:tcPr/>
+                </a:tc>
+                <a:tc>
+                  <a:txBody>
+                    <a:bodyPr/>
+                    <a:lstStyle/>
+                    <a:p>
+                      <a:pPr>
+                        <a:defRPr sz="1200" b="0"/>
+                      </a:pPr>
+                      <a:r>
+                        <a:t>Assimétrica: encoder pesado e decoder leve separado</a:t>
+                      </a:r>
+                    </a:p>
+                  </a:txBody>
+                  <a:tcPr/>
+                </a:tc>
+                <a:tc>
+                  <a:txBody>
+                    <a:bodyPr/>
+                    <a:lstStyle/>
+                    <a:p>
+                      <a:pPr>
+                        <a:defRPr sz="1200" b="0"/>
+                      </a:pPr>
+                      <a:r>
+                        <a:t>Encoder único com cabeça de predição linear leve</a:t>
+                      </a:r>
+                    </a:p>
+                  </a:txBody>
+                  <a:tcPr/>
+                </a:tc>
+              </a:tr>
+            </a:tbl>
+          </a:graphicData>
+        </a:graphic>
+      </p:graphicFrame>
+      <p:sp>
+        <p:nvSpPr>
+          <p:cNvPr id="4" name="TextBox 3"/>
+          <p:cNvSpPr txBox="1"/>
+          <p:nvPr/>
+        </p:nvSpPr>
+        <p:spPr>
+          <a:xfrm>
+            <a:off x="502920" y="5623560"/>
+            <a:ext cx="11247120" cy="1005840"/>
+          </a:xfrm>
+          <a:prstGeom prst="rect">
+            <a:avLst/>
+          </a:prstGeom>
+          <a:noFill/>
+        </p:spPr>
+        <p:txBody>
+          <a:bodyPr wrap="square">
+            <a:spAutoFit/>
+          </a:bodyPr>
+          <a:lstStyle/>
+          <a:p>
+            <a:pPr>
+              <a:defRPr sz="1300" b="0">
+                <a:latin typeface="Arial"/>
+              </a:defRPr>
+            </a:pPr>
+            <a:r>
+              <a:t>Contraste MSE x L1: o MSE do MAE opera em pixels normalizados com média por patch e pede decoder separado; a L1 do SimMIM faz regressão direta de pixels com cabeça linear leve sobre um encoder único, que admite proporções altas de máscara também</a:t>
             </a:r>
           </a:p>
         </p:txBody>
@@ -3779,63 +4314,929 @@
               <a:defRPr sz="3000"/>
             </a:pPr>
             <a:r>
-              <a:t>Arquitetura do MAE</a:t>
-            </a:r>
-          </a:p>
-        </p:txBody>
-      </p:sp>
-      <p:sp>
-        <p:nvSpPr>
-          <p:cNvPr id="3" name="Content Placeholder 2"/>
-          <p:cNvSpPr>
-            <a:spLocks noGrp="1"/>
-          </p:cNvSpPr>
-          <p:nvPr>
-            <p:ph idx="1"/>
-          </p:nvPr>
-        </p:nvSpPr>
-        <p:spPr/>
-        <p:txBody>
-          <a:bodyPr/>
-          <a:lstStyle/>
-          <a:p>
-            <a:pPr>
-              <a:defRPr sz="1700"/>
-            </a:pPr>
-            <a:r>
-              <a:t>Patchify: imagem 32x32x3 em 16 patches de 8x8 (192 valores cada)</a:t>
-            </a:r>
-          </a:p>
-          <a:p>
-            <a:pPr>
-              <a:defRPr sz="1700"/>
-            </a:pPr>
-            <a:r>
-              <a:t>Encoder: somente os patches visíveis entram (ViT dim 128, 4 blocos, 4 heads)</a:t>
-            </a:r>
-          </a:p>
-          <a:p>
-            <a:pPr>
-              <a:defRPr sz="1700"/>
-            </a:pPr>
-            <a:r>
-              <a:t>Decoder leve: dim 64, 2 blocos, tokens de máscara + embedding posicional</a:t>
-            </a:r>
-          </a:p>
-          <a:p>
-            <a:pPr>
-              <a:defRPr sz="1700"/>
-            </a:pPr>
-            <a:r>
-              <a:t>Saída: 192 valores por patch oculto (a imagem completa)</a:t>
-            </a:r>
-          </a:p>
-          <a:p>
-            <a:pPr>
-              <a:defRPr sz="1700"/>
-            </a:pPr>
-            <a:r>
-              <a:t>Perda: MSE somente nos patches ocultos, pixels brutos em [0,1]</a:t>
+              <a:t>Fluxo do MAE: da imagem à perda nos ocultos</a:t>
+            </a:r>
+          </a:p>
+        </p:txBody>
+      </p:sp>
+      <p:sp>
+        <p:nvSpPr>
+          <p:cNvPr id="3" name="Rounded Rectangle 2"/>
+          <p:cNvSpPr/>
+          <p:nvPr/>
+        </p:nvSpPr>
+        <p:spPr>
+          <a:xfrm>
+            <a:off x="612648" y="1463040"/>
+            <a:ext cx="2487168" cy="1371600"/>
+          </a:xfrm>
+          <a:prstGeom prst="roundRect">
+            <a:avLst/>
+          </a:prstGeom>
+          <a:solidFill>
+            <a:srgbClr val="EEF2F8"/>
+          </a:solidFill>
+          <a:ln>
+            <a:solidFill>
+              <a:srgbClr val="2F4B6E"/>
+            </a:solidFill>
+          </a:ln>
+        </p:spPr>
+        <p:style>
+          <a:lnRef idx="1">
+            <a:schemeClr val="accent1"/>
+          </a:lnRef>
+          <a:fillRef idx="3">
+            <a:schemeClr val="accent1"/>
+          </a:fillRef>
+          <a:effectRef idx="2">
+            <a:schemeClr val="accent1"/>
+          </a:effectRef>
+          <a:fontRef idx="minor">
+            <a:schemeClr val="lt1"/>
+          </a:fontRef>
+        </p:style>
+        <p:txBody>
+          <a:bodyPr rtlCol="0" anchor="ctr" wrap="square"/>
+          <a:lstStyle/>
+          <a:p>
+            <a:pPr algn="ctr">
+              <a:defRPr sz="1100" b="1">
+                <a:solidFill>
+                  <a:srgbClr val="2F4B6E"/>
+                </a:solidFill>
+              </a:defRPr>
+            </a:pPr>
+            <a:r>
+              <a:t>Imagem sem rótulo</a:t>
+            </a:r>
+          </a:p>
+          <a:p>
+            <a:pPr algn="ctr">
+              <a:defRPr sz="1000" b="0">
+                <a:solidFill>
+                  <a:srgbClr val="2F4B6E"/>
+                </a:solidFill>
+              </a:defRPr>
+            </a:pPr>
+            <a:r>
+              <a:t>32x32x3</a:t>
+            </a:r>
+          </a:p>
+        </p:txBody>
+      </p:sp>
+      <p:sp>
+        <p:nvSpPr>
+          <p:cNvPr id="4" name="Right Arrow 3"/>
+          <p:cNvSpPr/>
+          <p:nvPr/>
+        </p:nvSpPr>
+        <p:spPr>
+          <a:xfrm>
+            <a:off x="3099816" y="1956816"/>
+            <a:ext cx="329184" cy="384048"/>
+          </a:xfrm>
+          <a:prstGeom prst="rightArrow">
+            <a:avLst/>
+          </a:prstGeom>
+          <a:solidFill>
+            <a:srgbClr val="2F6BB0"/>
+          </a:solidFill>
+          <a:ln>
+            <a:noFill/>
+          </a:ln>
+        </p:spPr>
+        <p:style>
+          <a:lnRef idx="1">
+            <a:schemeClr val="accent1"/>
+          </a:lnRef>
+          <a:fillRef idx="3">
+            <a:schemeClr val="accent1"/>
+          </a:fillRef>
+          <a:effectRef idx="2">
+            <a:schemeClr val="accent1"/>
+          </a:effectRef>
+          <a:fontRef idx="minor">
+            <a:schemeClr val="lt1"/>
+          </a:fontRef>
+        </p:style>
+        <p:txBody>
+          <a:bodyPr rtlCol="0" anchor="ctr"/>
+          <a:lstStyle/>
+          <a:p>
+            <a:pPr algn="ctr"/>
+          </a:p>
+        </p:txBody>
+      </p:sp>
+      <p:sp>
+        <p:nvSpPr>
+          <p:cNvPr id="5" name="Rounded Rectangle 4"/>
+          <p:cNvSpPr/>
+          <p:nvPr/>
+        </p:nvSpPr>
+        <p:spPr>
+          <a:xfrm>
+            <a:off x="3429000" y="1463040"/>
+            <a:ext cx="2487168" cy="1371600"/>
+          </a:xfrm>
+          <a:prstGeom prst="roundRect">
+            <a:avLst/>
+          </a:prstGeom>
+          <a:solidFill>
+            <a:srgbClr val="EEF2F8"/>
+          </a:solidFill>
+          <a:ln>
+            <a:solidFill>
+              <a:srgbClr val="2F4B6E"/>
+            </a:solidFill>
+          </a:ln>
+        </p:spPr>
+        <p:style>
+          <a:lnRef idx="1">
+            <a:schemeClr val="accent1"/>
+          </a:lnRef>
+          <a:fillRef idx="3">
+            <a:schemeClr val="accent1"/>
+          </a:fillRef>
+          <a:effectRef idx="2">
+            <a:schemeClr val="accent1"/>
+          </a:effectRef>
+          <a:fontRef idx="minor">
+            <a:schemeClr val="lt1"/>
+          </a:fontRef>
+        </p:style>
+        <p:txBody>
+          <a:bodyPr rtlCol="0" anchor="ctr" wrap="square"/>
+          <a:lstStyle/>
+          <a:p>
+            <a:pPr algn="ctr">
+              <a:defRPr sz="1100" b="1">
+                <a:solidFill>
+                  <a:srgbClr val="2F4B6E"/>
+                </a:solidFill>
+              </a:defRPr>
+            </a:pPr>
+            <a:r>
+              <a:t>Patches</a:t>
+            </a:r>
+          </a:p>
+          <a:p>
+            <a:pPr algn="ctr">
+              <a:defRPr sz="1000" b="0">
+                <a:solidFill>
+                  <a:srgbClr val="2F4B6E"/>
+                </a:solidFill>
+              </a:defRPr>
+            </a:pPr>
+            <a:r>
+              <a:t>16 de 8x8</a:t>
+            </a:r>
+          </a:p>
+          <a:p>
+            <a:pPr algn="ctr">
+              <a:defRPr sz="1000" b="0">
+                <a:solidFill>
+                  <a:srgbClr val="2F4B6E"/>
+                </a:solidFill>
+              </a:defRPr>
+            </a:pPr>
+            <a:r>
+              <a:t>(192 valores cada)</a:t>
+            </a:r>
+          </a:p>
+        </p:txBody>
+      </p:sp>
+      <p:sp>
+        <p:nvSpPr>
+          <p:cNvPr id="6" name="Right Arrow 5"/>
+          <p:cNvSpPr/>
+          <p:nvPr/>
+        </p:nvSpPr>
+        <p:spPr>
+          <a:xfrm>
+            <a:off x="5916168" y="1956816"/>
+            <a:ext cx="329184" cy="384048"/>
+          </a:xfrm>
+          <a:prstGeom prst="rightArrow">
+            <a:avLst/>
+          </a:prstGeom>
+          <a:solidFill>
+            <a:srgbClr val="2F6BB0"/>
+          </a:solidFill>
+          <a:ln>
+            <a:noFill/>
+          </a:ln>
+        </p:spPr>
+        <p:style>
+          <a:lnRef idx="1">
+            <a:schemeClr val="accent1"/>
+          </a:lnRef>
+          <a:fillRef idx="3">
+            <a:schemeClr val="accent1"/>
+          </a:fillRef>
+          <a:effectRef idx="2">
+            <a:schemeClr val="accent1"/>
+          </a:effectRef>
+          <a:fontRef idx="minor">
+            <a:schemeClr val="lt1"/>
+          </a:fontRef>
+        </p:style>
+        <p:txBody>
+          <a:bodyPr rtlCol="0" anchor="ctr"/>
+          <a:lstStyle/>
+          <a:p>
+            <a:pPr algn="ctr"/>
+          </a:p>
+        </p:txBody>
+      </p:sp>
+      <p:sp>
+        <p:nvSpPr>
+          <p:cNvPr id="7" name="Rounded Rectangle 6"/>
+          <p:cNvSpPr/>
+          <p:nvPr/>
+        </p:nvSpPr>
+        <p:spPr>
+          <a:xfrm>
+            <a:off x="6245352" y="1463040"/>
+            <a:ext cx="2487168" cy="1371600"/>
+          </a:xfrm>
+          <a:prstGeom prst="roundRect">
+            <a:avLst/>
+          </a:prstGeom>
+          <a:solidFill>
+            <a:srgbClr val="EEF2F8"/>
+          </a:solidFill>
+          <a:ln>
+            <a:solidFill>
+              <a:srgbClr val="2F4B6E"/>
+            </a:solidFill>
+          </a:ln>
+        </p:spPr>
+        <p:style>
+          <a:lnRef idx="1">
+            <a:schemeClr val="accent1"/>
+          </a:lnRef>
+          <a:fillRef idx="3">
+            <a:schemeClr val="accent1"/>
+          </a:fillRef>
+          <a:effectRef idx="2">
+            <a:schemeClr val="accent1"/>
+          </a:effectRef>
+          <a:fontRef idx="minor">
+            <a:schemeClr val="lt1"/>
+          </a:fontRef>
+        </p:style>
+        <p:txBody>
+          <a:bodyPr rtlCol="0" anchor="ctr" wrap="square"/>
+          <a:lstStyle/>
+          <a:p>
+            <a:pPr algn="ctr">
+              <a:defRPr sz="1100" b="1">
+                <a:solidFill>
+                  <a:srgbClr val="2F4B6E"/>
+                </a:solidFill>
+              </a:defRPr>
+            </a:pPr>
+            <a:r>
+              <a:t>Máscara aleatória</a:t>
+            </a:r>
+          </a:p>
+          <a:p>
+            <a:pPr algn="ctr">
+              <a:defRPr sz="1000" b="0">
+                <a:solidFill>
+                  <a:srgbClr val="2F4B6E"/>
+                </a:solidFill>
+              </a:defRPr>
+            </a:pPr>
+            <a:r>
+              <a:t>50% ou 75% dos patches</a:t>
+            </a:r>
+          </a:p>
+        </p:txBody>
+      </p:sp>
+      <p:sp>
+        <p:nvSpPr>
+          <p:cNvPr id="8" name="Right Arrow 7"/>
+          <p:cNvSpPr/>
+          <p:nvPr/>
+        </p:nvSpPr>
+        <p:spPr>
+          <a:xfrm>
+            <a:off x="8732520" y="1956816"/>
+            <a:ext cx="329184" cy="384048"/>
+          </a:xfrm>
+          <a:prstGeom prst="rightArrow">
+            <a:avLst/>
+          </a:prstGeom>
+          <a:solidFill>
+            <a:srgbClr val="2F6BB0"/>
+          </a:solidFill>
+          <a:ln>
+            <a:noFill/>
+          </a:ln>
+        </p:spPr>
+        <p:style>
+          <a:lnRef idx="1">
+            <a:schemeClr val="accent1"/>
+          </a:lnRef>
+          <a:fillRef idx="3">
+            <a:schemeClr val="accent1"/>
+          </a:fillRef>
+          <a:effectRef idx="2">
+            <a:schemeClr val="accent1"/>
+          </a:effectRef>
+          <a:fontRef idx="minor">
+            <a:schemeClr val="lt1"/>
+          </a:fontRef>
+        </p:style>
+        <p:txBody>
+          <a:bodyPr rtlCol="0" anchor="ctr"/>
+          <a:lstStyle/>
+          <a:p>
+            <a:pPr algn="ctr"/>
+          </a:p>
+        </p:txBody>
+      </p:sp>
+      <p:sp>
+        <p:nvSpPr>
+          <p:cNvPr id="9" name="Rounded Rectangle 8"/>
+          <p:cNvSpPr/>
+          <p:nvPr/>
+        </p:nvSpPr>
+        <p:spPr>
+          <a:xfrm>
+            <a:off x="9061704" y="1463040"/>
+            <a:ext cx="2487168" cy="1371600"/>
+          </a:xfrm>
+          <a:prstGeom prst="roundRect">
+            <a:avLst/>
+          </a:prstGeom>
+          <a:solidFill>
+            <a:srgbClr val="EEF2F8"/>
+          </a:solidFill>
+          <a:ln>
+            <a:solidFill>
+              <a:srgbClr val="2F4B6E"/>
+            </a:solidFill>
+          </a:ln>
+        </p:spPr>
+        <p:style>
+          <a:lnRef idx="1">
+            <a:schemeClr val="accent1"/>
+          </a:lnRef>
+          <a:fillRef idx="3">
+            <a:schemeClr val="accent1"/>
+          </a:fillRef>
+          <a:effectRef idx="2">
+            <a:schemeClr val="accent1"/>
+          </a:effectRef>
+          <a:fontRef idx="minor">
+            <a:schemeClr val="lt1"/>
+          </a:fontRef>
+        </p:style>
+        <p:txBody>
+          <a:bodyPr rtlCol="0" anchor="ctr" wrap="square"/>
+          <a:lstStyle/>
+          <a:p>
+            <a:pPr algn="ctr">
+              <a:defRPr sz="1100" b="1">
+                <a:solidFill>
+                  <a:srgbClr val="2F4B6E"/>
+                </a:solidFill>
+              </a:defRPr>
+            </a:pPr>
+            <a:r>
+              <a:t>Codificador (ViT)</a:t>
+            </a:r>
+          </a:p>
+          <a:p>
+            <a:pPr algn="ctr">
+              <a:defRPr sz="1000" b="0">
+                <a:solidFill>
+                  <a:srgbClr val="2F4B6E"/>
+                </a:solidFill>
+              </a:defRPr>
+            </a:pPr>
+            <a:r>
+              <a:t>processa apenas</a:t>
+            </a:r>
+          </a:p>
+          <a:p>
+            <a:pPr algn="ctr">
+              <a:defRPr sz="1000" b="0">
+                <a:solidFill>
+                  <a:srgbClr val="2F4B6E"/>
+                </a:solidFill>
+              </a:defRPr>
+            </a:pPr>
+            <a:r>
+              <a:t>os patches visíveis</a:t>
+            </a:r>
+          </a:p>
+        </p:txBody>
+      </p:sp>
+      <p:sp>
+        <p:nvSpPr>
+          <p:cNvPr id="10" name="Down Arrow 9"/>
+          <p:cNvSpPr/>
+          <p:nvPr/>
+        </p:nvSpPr>
+        <p:spPr>
+          <a:xfrm>
+            <a:off x="10140696" y="2944368"/>
+            <a:ext cx="329184" cy="969264"/>
+          </a:xfrm>
+          <a:prstGeom prst="downArrow">
+            <a:avLst/>
+          </a:prstGeom>
+          <a:solidFill>
+            <a:srgbClr val="2F6BB0"/>
+          </a:solidFill>
+          <a:ln>
+            <a:noFill/>
+          </a:ln>
+        </p:spPr>
+        <p:style>
+          <a:lnRef idx="1">
+            <a:schemeClr val="accent1"/>
+          </a:lnRef>
+          <a:fillRef idx="3">
+            <a:schemeClr val="accent1"/>
+          </a:fillRef>
+          <a:effectRef idx="2">
+            <a:schemeClr val="accent1"/>
+          </a:effectRef>
+          <a:fontRef idx="minor">
+            <a:schemeClr val="lt1"/>
+          </a:fontRef>
+        </p:style>
+        <p:txBody>
+          <a:bodyPr rtlCol="0" anchor="ctr"/>
+          <a:lstStyle/>
+          <a:p>
+            <a:pPr algn="ctr"/>
+          </a:p>
+        </p:txBody>
+      </p:sp>
+      <p:sp>
+        <p:nvSpPr>
+          <p:cNvPr id="11" name="Rounded Rectangle 10"/>
+          <p:cNvSpPr/>
+          <p:nvPr/>
+        </p:nvSpPr>
+        <p:spPr>
+          <a:xfrm>
+            <a:off x="612648" y="4023360"/>
+            <a:ext cx="2487168" cy="1371600"/>
+          </a:xfrm>
+          <a:prstGeom prst="roundRect">
+            <a:avLst/>
+          </a:prstGeom>
+          <a:solidFill>
+            <a:srgbClr val="EEF2F8"/>
+          </a:solidFill>
+          <a:ln>
+            <a:solidFill>
+              <a:srgbClr val="2F4B6E"/>
+            </a:solidFill>
+          </a:ln>
+        </p:spPr>
+        <p:style>
+          <a:lnRef idx="1">
+            <a:schemeClr val="accent1"/>
+          </a:lnRef>
+          <a:fillRef idx="3">
+            <a:schemeClr val="accent1"/>
+          </a:fillRef>
+          <a:effectRef idx="2">
+            <a:schemeClr val="accent1"/>
+          </a:effectRef>
+          <a:fontRef idx="minor">
+            <a:schemeClr val="lt1"/>
+          </a:fontRef>
+        </p:style>
+        <p:txBody>
+          <a:bodyPr rtlCol="0" anchor="ctr" wrap="square"/>
+          <a:lstStyle/>
+          <a:p>
+            <a:pPr algn="ctr">
+              <a:defRPr sz="1100" b="1">
+                <a:solidFill>
+                  <a:srgbClr val="2F4B6E"/>
+                </a:solidFill>
+              </a:defRPr>
+            </a:pPr>
+            <a:r>
+              <a:t>Perda: MSE</a:t>
+            </a:r>
+          </a:p>
+          <a:p>
+            <a:pPr algn="ctr">
+              <a:defRPr sz="1000" b="0">
+                <a:solidFill>
+                  <a:srgbClr val="2F4B6E"/>
+                </a:solidFill>
+              </a:defRPr>
+            </a:pPr>
+            <a:r>
+              <a:t>somente nos</a:t>
+            </a:r>
+          </a:p>
+          <a:p>
+            <a:pPr algn="ctr">
+              <a:defRPr sz="1000" b="0">
+                <a:solidFill>
+                  <a:srgbClr val="2F4B6E"/>
+                </a:solidFill>
+              </a:defRPr>
+            </a:pPr>
+            <a:r>
+              <a:t>patches ocultos</a:t>
+            </a:r>
+          </a:p>
+        </p:txBody>
+      </p:sp>
+      <p:sp>
+        <p:nvSpPr>
+          <p:cNvPr id="12" name="Left Arrow 11"/>
+          <p:cNvSpPr/>
+          <p:nvPr/>
+        </p:nvSpPr>
+        <p:spPr>
+          <a:xfrm>
+            <a:off x="3099816" y="4517136"/>
+            <a:ext cx="329184" cy="384048"/>
+          </a:xfrm>
+          <a:prstGeom prst="leftArrow">
+            <a:avLst/>
+          </a:prstGeom>
+          <a:solidFill>
+            <a:srgbClr val="2F6BB0"/>
+          </a:solidFill>
+          <a:ln>
+            <a:noFill/>
+          </a:ln>
+        </p:spPr>
+        <p:style>
+          <a:lnRef idx="1">
+            <a:schemeClr val="accent1"/>
+          </a:lnRef>
+          <a:fillRef idx="3">
+            <a:schemeClr val="accent1"/>
+          </a:fillRef>
+          <a:effectRef idx="2">
+            <a:schemeClr val="accent1"/>
+          </a:effectRef>
+          <a:fontRef idx="minor">
+            <a:schemeClr val="lt1"/>
+          </a:fontRef>
+        </p:style>
+        <p:txBody>
+          <a:bodyPr rtlCol="0" anchor="ctr"/>
+          <a:lstStyle/>
+          <a:p>
+            <a:pPr algn="ctr"/>
+          </a:p>
+        </p:txBody>
+      </p:sp>
+      <p:sp>
+        <p:nvSpPr>
+          <p:cNvPr id="13" name="Rounded Rectangle 12"/>
+          <p:cNvSpPr/>
+          <p:nvPr/>
+        </p:nvSpPr>
+        <p:spPr>
+          <a:xfrm>
+            <a:off x="3429000" y="4023360"/>
+            <a:ext cx="2487168" cy="1371600"/>
+          </a:xfrm>
+          <a:prstGeom prst="roundRect">
+            <a:avLst/>
+          </a:prstGeom>
+          <a:solidFill>
+            <a:srgbClr val="EEF2F8"/>
+          </a:solidFill>
+          <a:ln>
+            <a:solidFill>
+              <a:srgbClr val="2F4B6E"/>
+            </a:solidFill>
+          </a:ln>
+        </p:spPr>
+        <p:style>
+          <a:lnRef idx="1">
+            <a:schemeClr val="accent1"/>
+          </a:lnRef>
+          <a:fillRef idx="3">
+            <a:schemeClr val="accent1"/>
+          </a:fillRef>
+          <a:effectRef idx="2">
+            <a:schemeClr val="accent1"/>
+          </a:effectRef>
+          <a:fontRef idx="minor">
+            <a:schemeClr val="lt1"/>
+          </a:fontRef>
+        </p:style>
+        <p:txBody>
+          <a:bodyPr rtlCol="0" anchor="ctr" wrap="square"/>
+          <a:lstStyle/>
+          <a:p>
+            <a:pPr algn="ctr">
+              <a:defRPr sz="1100" b="1">
+                <a:solidFill>
+                  <a:srgbClr val="2F4B6E"/>
+                </a:solidFill>
+              </a:defRPr>
+            </a:pPr>
+            <a:r>
+              <a:t>Reconstrução</a:t>
+            </a:r>
+          </a:p>
+          <a:p>
+            <a:pPr algn="ctr">
+              <a:defRPr sz="1000" b="0">
+                <a:solidFill>
+                  <a:srgbClr val="2F4B6E"/>
+                </a:solidFill>
+              </a:defRPr>
+            </a:pPr>
+            <a:r>
+              <a:t>dos pixels dos</a:t>
+            </a:r>
+          </a:p>
+          <a:p>
+            <a:pPr algn="ctr">
+              <a:defRPr sz="1000" b="0">
+                <a:solidFill>
+                  <a:srgbClr val="2F4B6E"/>
+                </a:solidFill>
+              </a:defRPr>
+            </a:pPr>
+            <a:r>
+              <a:t>patches ocultos</a:t>
+            </a:r>
+          </a:p>
+        </p:txBody>
+      </p:sp>
+      <p:sp>
+        <p:nvSpPr>
+          <p:cNvPr id="14" name="Left Arrow 13"/>
+          <p:cNvSpPr/>
+          <p:nvPr/>
+        </p:nvSpPr>
+        <p:spPr>
+          <a:xfrm>
+            <a:off x="5916168" y="4517136"/>
+            <a:ext cx="329184" cy="384048"/>
+          </a:xfrm>
+          <a:prstGeom prst="leftArrow">
+            <a:avLst/>
+          </a:prstGeom>
+          <a:solidFill>
+            <a:srgbClr val="2F6BB0"/>
+          </a:solidFill>
+          <a:ln>
+            <a:noFill/>
+          </a:ln>
+        </p:spPr>
+        <p:style>
+          <a:lnRef idx="1">
+            <a:schemeClr val="accent1"/>
+          </a:lnRef>
+          <a:fillRef idx="3">
+            <a:schemeClr val="accent1"/>
+          </a:fillRef>
+          <a:effectRef idx="2">
+            <a:schemeClr val="accent1"/>
+          </a:effectRef>
+          <a:fontRef idx="minor">
+            <a:schemeClr val="lt1"/>
+          </a:fontRef>
+        </p:style>
+        <p:txBody>
+          <a:bodyPr rtlCol="0" anchor="ctr"/>
+          <a:lstStyle/>
+          <a:p>
+            <a:pPr algn="ctr"/>
+          </a:p>
+        </p:txBody>
+      </p:sp>
+      <p:sp>
+        <p:nvSpPr>
+          <p:cNvPr id="15" name="Rounded Rectangle 14"/>
+          <p:cNvSpPr/>
+          <p:nvPr/>
+        </p:nvSpPr>
+        <p:spPr>
+          <a:xfrm>
+            <a:off x="6245352" y="4023360"/>
+            <a:ext cx="2487168" cy="1371600"/>
+          </a:xfrm>
+          <a:prstGeom prst="roundRect">
+            <a:avLst/>
+          </a:prstGeom>
+          <a:solidFill>
+            <a:srgbClr val="EEF2F8"/>
+          </a:solidFill>
+          <a:ln>
+            <a:solidFill>
+              <a:srgbClr val="2F4B6E"/>
+            </a:solidFill>
+          </a:ln>
+        </p:spPr>
+        <p:style>
+          <a:lnRef idx="1">
+            <a:schemeClr val="accent1"/>
+          </a:lnRef>
+          <a:fillRef idx="3">
+            <a:schemeClr val="accent1"/>
+          </a:fillRef>
+          <a:effectRef idx="2">
+            <a:schemeClr val="accent1"/>
+          </a:effectRef>
+          <a:fontRef idx="minor">
+            <a:schemeClr val="lt1"/>
+          </a:fontRef>
+        </p:style>
+        <p:txBody>
+          <a:bodyPr rtlCol="0" anchor="ctr" wrap="square"/>
+          <a:lstStyle/>
+          <a:p>
+            <a:pPr algn="ctr">
+              <a:defRPr sz="1100" b="1">
+                <a:solidFill>
+                  <a:srgbClr val="2F4B6E"/>
+                </a:solidFill>
+              </a:defRPr>
+            </a:pPr>
+            <a:r>
+              <a:t>Decodificador leve</a:t>
+            </a:r>
+          </a:p>
+          <a:p>
+            <a:pPr algn="ctr">
+              <a:defRPr sz="1000" b="0">
+                <a:solidFill>
+                  <a:srgbClr val="2F4B6E"/>
+                </a:solidFill>
+              </a:defRPr>
+            </a:pPr>
+            <a:r>
+              <a:t>dim 64, 2 blocos</a:t>
+            </a:r>
+          </a:p>
+        </p:txBody>
+      </p:sp>
+      <p:sp>
+        <p:nvSpPr>
+          <p:cNvPr id="16" name="Left Arrow 15"/>
+          <p:cNvSpPr/>
+          <p:nvPr/>
+        </p:nvSpPr>
+        <p:spPr>
+          <a:xfrm>
+            <a:off x="8732520" y="4517136"/>
+            <a:ext cx="329184" cy="384048"/>
+          </a:xfrm>
+          <a:prstGeom prst="leftArrow">
+            <a:avLst/>
+          </a:prstGeom>
+          <a:solidFill>
+            <a:srgbClr val="2F6BB0"/>
+          </a:solidFill>
+          <a:ln>
+            <a:noFill/>
+          </a:ln>
+        </p:spPr>
+        <p:style>
+          <a:lnRef idx="1">
+            <a:schemeClr val="accent1"/>
+          </a:lnRef>
+          <a:fillRef idx="3">
+            <a:schemeClr val="accent1"/>
+          </a:fillRef>
+          <a:effectRef idx="2">
+            <a:schemeClr val="accent1"/>
+          </a:effectRef>
+          <a:fontRef idx="minor">
+            <a:schemeClr val="lt1"/>
+          </a:fontRef>
+        </p:style>
+        <p:txBody>
+          <a:bodyPr rtlCol="0" anchor="ctr"/>
+          <a:lstStyle/>
+          <a:p>
+            <a:pPr algn="ctr"/>
+          </a:p>
+        </p:txBody>
+      </p:sp>
+      <p:sp>
+        <p:nvSpPr>
+          <p:cNvPr id="17" name="Rounded Rectangle 16"/>
+          <p:cNvSpPr/>
+          <p:nvPr/>
+        </p:nvSpPr>
+        <p:spPr>
+          <a:xfrm>
+            <a:off x="9061704" y="4023360"/>
+            <a:ext cx="2487168" cy="1371600"/>
+          </a:xfrm>
+          <a:prstGeom prst="roundRect">
+            <a:avLst/>
+          </a:prstGeom>
+          <a:solidFill>
+            <a:srgbClr val="EEF2F8"/>
+          </a:solidFill>
+          <a:ln>
+            <a:solidFill>
+              <a:srgbClr val="2F4B6E"/>
+            </a:solidFill>
+          </a:ln>
+        </p:spPr>
+        <p:style>
+          <a:lnRef idx="1">
+            <a:schemeClr val="accent1"/>
+          </a:lnRef>
+          <a:fillRef idx="3">
+            <a:schemeClr val="accent1"/>
+          </a:fillRef>
+          <a:effectRef idx="2">
+            <a:schemeClr val="accent1"/>
+          </a:effectRef>
+          <a:fontRef idx="minor">
+            <a:schemeClr val="lt1"/>
+          </a:fontRef>
+        </p:style>
+        <p:txBody>
+          <a:bodyPr rtlCol="0" anchor="ctr" wrap="square"/>
+          <a:lstStyle/>
+          <a:p>
+            <a:pPr algn="ctr">
+              <a:defRPr sz="1100" b="1">
+                <a:solidFill>
+                  <a:srgbClr val="2F4B6E"/>
+                </a:solidFill>
+              </a:defRPr>
+            </a:pPr>
+            <a:r>
+              <a:t>Tokens de máscara</a:t>
+            </a:r>
+          </a:p>
+          <a:p>
+            <a:pPr algn="ctr">
+              <a:defRPr sz="1000" b="0">
+                <a:solidFill>
+                  <a:srgbClr val="2F4B6E"/>
+                </a:solidFill>
+              </a:defRPr>
+            </a:pPr>
+            <a:r>
+              <a:t>com embedding</a:t>
+            </a:r>
+          </a:p>
+          <a:p>
+            <a:pPr algn="ctr">
+              <a:defRPr sz="1000" b="0">
+                <a:solidFill>
+                  <a:srgbClr val="2F4B6E"/>
+                </a:solidFill>
+              </a:defRPr>
+            </a:pPr>
+            <a:r>
+              <a:t>das posições</a:t>
+            </a:r>
+          </a:p>
+        </p:txBody>
+      </p:sp>
+      <p:sp>
+        <p:nvSpPr>
+          <p:cNvPr id="18" name="TextBox 17"/>
+          <p:cNvSpPr txBox="1"/>
+          <p:nvPr/>
+        </p:nvSpPr>
+        <p:spPr>
+          <a:xfrm>
+            <a:off x="612648" y="5715000"/>
+            <a:ext cx="10972800" cy="914400"/>
+          </a:xfrm>
+          <a:prstGeom prst="rect">
+            <a:avLst/>
+          </a:prstGeom>
+          <a:noFill/>
+        </p:spPr>
+        <p:txBody>
+          <a:bodyPr wrap="square">
+            <a:spAutoFit/>
+          </a:bodyPr>
+          <a:lstStyle/>
+          <a:p>
+            <a:pPr>
+              <a:defRPr sz="1300" b="0">
+                <a:latin typeface="Arial"/>
+              </a:defRPr>
+            </a:pPr>
+            <a:r>
+              <a:t>Arquitetura assimétrica: o codificador só vê os patches visíveis e o decoder leve, descartado nas tarefas posteriores de reconhecimento (He et al., 2022)</a:t>
             </a:r>
           </a:p>
         </p:txBody>
@@ -3874,58 +5275,216 @@
           <a:lstStyle/>
           <a:p>
             <a:pPr>
-              <a:defRPr sz="3000"/>
-            </a:pPr>
-            <a:r>
-              <a:t>Nossa implementação</a:t>
-            </a:r>
-          </a:p>
-        </p:txBody>
-      </p:sp>
-      <p:sp>
-        <p:nvSpPr>
-          <p:cNvPr id="3" name="Content Placeholder 2"/>
-          <p:cNvSpPr>
-            <a:spLocks noGrp="1"/>
-          </p:cNvSpPr>
-          <p:nvPr>
-            <p:ph idx="1"/>
-          </p:nvPr>
-        </p:nvSpPr>
-        <p:spPr/>
-        <p:txBody>
-          <a:bodyPr/>
-          <a:lstStyle/>
-          <a:p>
-            <a:pPr>
-              <a:defRPr sz="1700"/>
-            </a:pPr>
-            <a:r>
-              <a:t>MAE próprio em PyTorch puro (sem código de terceiros)</a:t>
-            </a:r>
-          </a:p>
-          <a:p>
-            <a:pPr>
-              <a:defRPr sz="1700"/>
-            </a:pPr>
-            <a:r>
-              <a:t>Máscara aninhada: permutação fixa por imagem com seed 42</a:t>
-            </a:r>
-          </a:p>
-          <a:p>
-            <a:pPr>
-              <a:defRPr sz="1700"/>
-            </a:pPr>
-            <a:r>
-              <a:t>50% oculta 8 patches; 75% oculta 12 (todos os da 50% também)</a:t>
-            </a:r>
-          </a:p>
-          <a:p>
-            <a:pPr>
-              <a:defRPr sz="1700"/>
-            </a:pPr>
-            <a:r>
-              <a:t>Validação contra o oráculo vit-pytorch em testes fora da entrega</a:t>
+              <a:defRPr sz="2800"/>
+            </a:pPr>
+            <a:r>
+              <a:t>Equação da perda e pseudocódigo do treinamento</a:t>
+            </a:r>
+          </a:p>
+        </p:txBody>
+      </p:sp>
+      <p:sp>
+        <p:nvSpPr>
+          <p:cNvPr id="3" name="TextBox 2"/>
+          <p:cNvSpPr txBox="1"/>
+          <p:nvPr/>
+        </p:nvSpPr>
+        <p:spPr>
+          <a:xfrm>
+            <a:off x="612648" y="1371600"/>
+            <a:ext cx="5577840" cy="5120640"/>
+          </a:xfrm>
+          <a:prstGeom prst="rect">
+            <a:avLst/>
+          </a:prstGeom>
+          <a:noFill/>
+        </p:spPr>
+        <p:txBody>
+          <a:bodyPr wrap="square">
+            <a:spAutoFit/>
+          </a:bodyPr>
+          <a:lstStyle/>
+          <a:p>
+            <a:pPr>
+              <a:defRPr sz="1400" b="1">
+                <a:latin typeface="Arial"/>
+              </a:defRPr>
+            </a:pPr>
+            <a:r>
+              <a:t>Equação da perda (erro quadrático médio nos ocultos)</a:t>
+            </a:r>
+          </a:p>
+          <a:p>
+            <a:pPr>
+              <a:defRPr sz="1300" b="1">
+                <a:latin typeface="Arial"/>
+              </a:defRPr>
+            </a:pPr>
+            <a:r>
+              <a:t>L_MAE = (1/|M|) · Σ i ∈ M (1/d) · ||x_i − x̂_i||²</a:t>
+            </a:r>
+          </a:p>
+          <a:p>
+            <a:pPr>
+              <a:defRPr sz="1300" b="0">
+                <a:latin typeface="Arial"/>
+              </a:defRPr>
+            </a:pPr>
+            <a:r>
+              <a:t>x_i: vetor de pixels do patch i (d valores)</a:t>
+            </a:r>
+          </a:p>
+          <a:p>
+            <a:pPr>
+              <a:defRPr sz="1300" b="0">
+                <a:latin typeface="Arial"/>
+              </a:defRPr>
+            </a:pPr>
+            <a:r>
+              <a:t>M: conjunto dos patches mascarados (ocultos)</a:t>
+            </a:r>
+          </a:p>
+          <a:p>
+            <a:pPr>
+              <a:defRPr sz="1300" b="0">
+                <a:latin typeface="Arial"/>
+              </a:defRPr>
+            </a:pPr>
+            <a:r>
+              <a:t>x̂_i: reconstrução do patch i produzida pelo modelo</a:t>
+            </a:r>
+          </a:p>
+          <a:p>
+            <a:pPr>
+              <a:defRPr sz="1300" b="0">
+                <a:latin typeface="Arial"/>
+              </a:defRPr>
+            </a:pPr>
+            <a:r>
+              <a:t>d: número de valores de pixel por patch (192);</a:t>
+            </a:r>
+          </a:p>
+          <a:p>
+            <a:pPr>
+              <a:defRPr sz="1200" b="0">
+                <a:latin typeface="Arial"/>
+              </a:defRPr>
+            </a:pPr>
+            <a:r>
+              <a:t>normaliza pela dimensão da reconstrução</a:t>
+            </a:r>
+          </a:p>
+          <a:p>
+            <a:pPr>
+              <a:defRPr sz="1300" b="1">
+                <a:latin typeface="Arial"/>
+              </a:defRPr>
+            </a:pPr>
+            <a:r>
+              <a:t>média sobre i ∈ M: a perda ignora os patches visíveis</a:t>
+            </a:r>
+          </a:p>
+        </p:txBody>
+      </p:sp>
+      <p:sp>
+        <p:nvSpPr>
+          <p:cNvPr id="4" name="TextBox 3"/>
+          <p:cNvSpPr txBox="1"/>
+          <p:nvPr/>
+        </p:nvSpPr>
+        <p:spPr>
+          <a:xfrm>
+            <a:off x="6400800" y="1371600"/>
+            <a:ext cx="5175504" cy="5120640"/>
+          </a:xfrm>
+          <a:prstGeom prst="rect">
+            <a:avLst/>
+          </a:prstGeom>
+          <a:noFill/>
+        </p:spPr>
+        <p:txBody>
+          <a:bodyPr wrap="square">
+            <a:spAutoFit/>
+          </a:bodyPr>
+          <a:lstStyle/>
+          <a:p>
+            <a:pPr>
+              <a:defRPr sz="1400" b="1">
+                <a:latin typeface="Consolas"/>
+              </a:defRPr>
+            </a:pPr>
+            <a:r>
+              <a:t>Pseudocódigo do laço de treinamento</a:t>
+            </a:r>
+          </a:p>
+          <a:p>
+            <a:pPr>
+              <a:defRPr sz="1200" b="0">
+                <a:latin typeface="Consolas"/>
+              </a:defRPr>
+            </a:pPr>
+            <a:r>
+              <a:t>1. dividir o lote em patches</a:t>
+            </a:r>
+          </a:p>
+          <a:p>
+            <a:pPr>
+              <a:defRPr sz="1200" b="0">
+                <a:latin typeface="Consolas"/>
+              </a:defRPr>
+            </a:pPr>
+            <a:r>
+              <a:t>2. amostrar a máscara na razão r</a:t>
+            </a:r>
+          </a:p>
+          <a:p>
+            <a:pPr>
+              <a:defRPr sz="1200" b="0">
+                <a:latin typeface="Consolas"/>
+              </a:defRPr>
+            </a:pPr>
+            <a:r>
+              <a:t>3. codificar somente os patches visíveis</a:t>
+            </a:r>
+          </a:p>
+          <a:p>
+            <a:pPr>
+              <a:defRPr sz="1200" b="0">
+                <a:latin typeface="Consolas"/>
+              </a:defRPr>
+            </a:pPr>
+            <a:r>
+              <a:t>4. decodificar com tokens de máscara e posições</a:t>
+            </a:r>
+          </a:p>
+          <a:p>
+            <a:pPr>
+              <a:defRPr sz="1200" b="0">
+                <a:latin typeface="Consolas"/>
+              </a:defRPr>
+            </a:pPr>
+            <a:r>
+              <a:t>5. calcular a perda somente nos patches ocultos, normalizada por d</a:t>
+            </a:r>
+          </a:p>
+          <a:p>
+            <a:pPr>
+              <a:defRPr sz="1200" b="0">
+                <a:latin typeface="Consolas"/>
+              </a:defRPr>
+            </a:pPr>
+            <a:r>
+              <a:t>6. atualizar os parâmetros por retropropagação</a:t>
+            </a:r>
+          </a:p>
+          <a:p>
+            <a:pPr>
+              <a:defRPr sz="1200" b="0">
+                <a:latin typeface="Consolas"/>
+              </a:defRPr>
+            </a:pPr>
+            <a:r>
+              <a:t>Repetir por época sobre o conjunto de treino</a:t>
             </a:r>
           </a:p>
         </p:txBody>
@@ -3967,7 +5526,7 @@
               <a:defRPr sz="3000"/>
             </a:pPr>
             <a:r>
-              <a:t>Dados e protocolo</a:t>
+              <a:t>Arquitetura e implementação</a:t>
             </a:r>
           </a:p>
         </p:txBody>
@@ -3991,7 +5550,7 @@
               <a:defRPr sz="1700"/>
             </a:pPr>
             <a:r>
-              <a:t>CIFAR-10 verificado por md5 antes de qualquer uso</a:t>
+              <a:t>Patchify: imagem 32x32x3 em 16 patches de 8x8 (192 valores cada)</a:t>
             </a:r>
           </a:p>
           <a:p>
@@ -3999,7 +5558,7 @@
               <a:defRPr sz="1700"/>
             </a:pPr>
             <a:r>
-              <a:t>Subset seed 42, balanceado: 500 treino, 100 validação e 100 teste por classe</a:t>
+              <a:t>Encoder: somente os patches visíveis entram (ViT dim 128, 4 blocos, 4 heads)</a:t>
             </a:r>
           </a:p>
           <a:p>
@@ -4007,7 +5566,7 @@
               <a:defRPr sz="1700"/>
             </a:pPr>
             <a:r>
-              <a:t>Validação disjunta do treino; teste sai do split oficial e é usado só no fim</a:t>
+              <a:t>Decoder leve: dim 64, 2 blocos, tokens de máscara + embedding posicional</a:t>
             </a:r>
           </a:p>
           <a:p>
@@ -4015,7 +5574,31 @@
               <a:defRPr sz="1700"/>
             </a:pPr>
             <a:r>
-              <a:t>Métrica: MSE nos patches ocultos do conjunto de teste</a:t>
+              <a:t>Saída: 192 valores por patch oculto; o decoder é descartado em tarefas posteriores</a:t>
+            </a:r>
+          </a:p>
+          <a:p>
+            <a:pPr>
+              <a:defRPr sz="1700"/>
+            </a:pPr>
+            <a:r>
+              <a:t>MAE próprio em PyTorch puro (sem código de terceiros), validado contra oráculo fora do pacote</a:t>
+            </a:r>
+          </a:p>
+          <a:p>
+            <a:pPr>
+              <a:defRPr sz="1700"/>
+            </a:pPr>
+            <a:r>
+              <a:t>Máscara aninhada: permutação fixa por imagem com seed 42</a:t>
+            </a:r>
+          </a:p>
+          <a:p>
+            <a:pPr>
+              <a:defRPr sz="1700"/>
+            </a:pPr>
+            <a:r>
+              <a:t>50% oculta 8 patches; 75% oculta 12 (todos os da 50% também)</a:t>
             </a:r>
           </a:p>
         </p:txBody>
@@ -4057,7 +5640,7 @@
               <a:defRPr sz="3000"/>
             </a:pPr>
             <a:r>
-              <a:t>Experimento: máscara de 50% contra 75%</a:t>
+              <a:t>Protocolo e orçamento de treino</a:t>
             </a:r>
           </a:p>
         </p:txBody>
@@ -4081,7 +5664,7 @@
               <a:defRPr sz="1700"/>
             </a:pPr>
             <a:r>
-              <a:t>Mesmo treino nas duas condições: 200 épocas, batch 256, lr 3.0e-04 (AdamW)</a:t>
+              <a:t>CIFAR-10 verificado por md5 antes de qualquer uso</a:t>
             </a:r>
           </a:p>
           <a:p>
@@ -4089,7 +5672,7 @@
               <a:defRPr sz="1700"/>
             </a:pPr>
             <a:r>
-              <a:t>O custo computacional por época diverge: a 75% o encoder vê 4 tokens, a 50% vê 8</a:t>
+              <a:t>Subset seed 42, balanceado: 500 treino, 100 validação e 100 teste por classe</a:t>
             </a:r>
           </a:p>
           <a:p>
@@ -4097,7 +5680,7 @@
               <a:defRPr sz="1700"/>
             </a:pPr>
             <a:r>
-              <a:t>Tempo medido por época na RTX 3050 (na condição 75%): 0.58 s</a:t>
+              <a:t>Validação disjunta do treino; teste sai do split oficial e é usado só no fim</a:t>
             </a:r>
           </a:p>
           <a:p>
@@ -4105,15 +5688,7 @@
               <a:defRPr sz="1700"/>
             </a:pPr>
             <a:r>
-              <a:t>Orçamento previsto: 30 minutos para as duas condições somadas</a:t>
-            </a:r>
-          </a:p>
-          <a:p>
-            <a:pPr>
-              <a:defRPr sz="1700"/>
-            </a:pPr>
-            <a:r>
-              <a:t>MSE de teste nos ocultos: 50% = 0.0608 | 75% = 0.0717</a:t>
+              <a:t>Métrica: MSE nos patches ocultos do conjunto de teste</a:t>
             </a:r>
           </a:p>
         </p:txBody>
@@ -4155,62 +5730,63 @@
               <a:defRPr sz="3000"/>
             </a:pPr>
             <a:r>
-              <a:t>Resultados: reconstruções</a:t>
-            </a:r>
-          </a:p>
-        </p:txBody>
-      </p:sp>
-      <p:pic>
-        <p:nvPicPr>
-          <p:cNvPr id="3" name="Picture 2" descr="reconstrucoes.png"/>
-          <p:cNvPicPr>
-            <a:picLocks noChangeAspect="1"/>
-          </p:cNvPicPr>
-          <p:nvPr/>
-        </p:nvPicPr>
-        <p:blipFill>
-          <a:blip r:embed="rId2"/>
-          <a:stretch>
-            <a:fillRect/>
-          </a:stretch>
-        </p:blipFill>
-        <p:spPr>
-          <a:xfrm>
-            <a:off x="609447" y="2547850"/>
-            <a:ext cx="10972800" cy="2493818"/>
-          </a:xfrm>
-          <a:prstGeom prst="rect">
-            <a:avLst/>
-          </a:prstGeom>
-        </p:spPr>
-      </p:pic>
-      <p:sp>
-        <p:nvSpPr>
-          <p:cNvPr id="4" name="TextBox 3"/>
-          <p:cNvSpPr txBox="1"/>
-          <p:nvPr/>
-        </p:nvSpPr>
-        <p:spPr>
-          <a:xfrm>
-            <a:off x="612648" y="6355080"/>
-            <a:ext cx="10972800" cy="411480"/>
-          </a:xfrm>
-          <a:prstGeom prst="rect">
-            <a:avLst/>
-          </a:prstGeom>
-          <a:noFill/>
-        </p:spPr>
-        <p:txBody>
-          <a:bodyPr wrap="none">
-            <a:spAutoFit/>
-          </a:bodyPr>
-          <a:lstStyle/>
-          <a:p>
-            <a:pPr>
-              <a:defRPr sz="1400"/>
-            </a:pPr>
-            <a:r>
-              <a:t>8 imagens fixas do teste (seed 42): original, mascarada e reconstrução por condição</a:t>
+              <a:t>Experimento: máscara de 50% contra 75%</a:t>
+            </a:r>
+          </a:p>
+        </p:txBody>
+      </p:sp>
+      <p:sp>
+        <p:nvSpPr>
+          <p:cNvPr id="3" name="Content Placeholder 2"/>
+          <p:cNvSpPr>
+            <a:spLocks noGrp="1"/>
+          </p:cNvSpPr>
+          <p:nvPr>
+            <p:ph idx="1"/>
+          </p:nvPr>
+        </p:nvSpPr>
+        <p:spPr/>
+        <p:txBody>
+          <a:bodyPr/>
+          <a:lstStyle/>
+          <a:p>
+            <a:pPr>
+              <a:defRPr sz="1700"/>
+            </a:pPr>
+            <a:r>
+              <a:t>Mesmo treino nas duas condições: 200 épocas, batch 256, lr 3.0e-04 (AdamW)</a:t>
+            </a:r>
+          </a:p>
+          <a:p>
+            <a:pPr>
+              <a:defRPr sz="1700"/>
+            </a:pPr>
+            <a:r>
+              <a:t>O custo computacional por época diverge: a 75% o encoder vê 4 tokens, a 50% vê 8</a:t>
+            </a:r>
+          </a:p>
+          <a:p>
+            <a:pPr>
+              <a:defRPr sz="1700"/>
+            </a:pPr>
+            <a:r>
+              <a:t>Tempo medido por época (na condição 75%): 0.58 s</a:t>
+            </a:r>
+          </a:p>
+          <a:p>
+            <a:pPr>
+              <a:defRPr sz="1700"/>
+            </a:pPr>
+            <a:r>
+              <a:t>Orçamento previsto: 30 minutos para as duas condições somadas</a:t>
+            </a:r>
+          </a:p>
+          <a:p>
+            <a:pPr>
+              <a:defRPr sz="1700"/>
+            </a:pPr>
+            <a:r>
+              <a:t>MSE de teste nos ocultos: 50% = 0.0608 | 75% = 0.0717</a:t>
             </a:r>
           </a:p>
         </p:txBody>

</xml_diff>

<commit_message>
feat(completar-entrega-seminario): slides didáticos completos e pacote entregue com testes de cobertura (#3)
</commit_message>
<xml_diff>
--- a/slides/seminario_masked_modeling.pptx
+++ b/slides/seminario_masked_modeling.pptx
@@ -3192,14 +3192,47 @@
               <a:defRPr sz="3000"/>
             </a:pPr>
             <a:r>
-              <a:t>Resultados: curva de perda de validação</a:t>
+              <a:t>Resultados: reconstruções e curva de perda</a:t>
+            </a:r>
+          </a:p>
+        </p:txBody>
+      </p:sp>
+      <p:sp>
+        <p:nvSpPr>
+          <p:cNvPr id="3" name="TextBox 2"/>
+          <p:cNvSpPr txBox="1"/>
+          <p:nvPr/>
+        </p:nvSpPr>
+        <p:spPr>
+          <a:xfrm>
+            <a:off x="612648" y="1325880"/>
+            <a:ext cx="10972800" cy="310896"/>
+          </a:xfrm>
+          <a:prstGeom prst="rect">
+            <a:avLst/>
+          </a:prstGeom>
+          <a:noFill/>
+        </p:spPr>
+        <p:txBody>
+          <a:bodyPr wrap="square">
+            <a:spAutoFit/>
+          </a:bodyPr>
+          <a:lstStyle/>
+          <a:p>
+            <a:pPr>
+              <a:defRPr sz="1300" b="1">
+                <a:latin typeface="Arial"/>
+              </a:defRPr>
+            </a:pPr>
+            <a:r>
+              <a:t>Reconstruções: 8 imagens fixas do teste (seed 42)</a:t>
             </a:r>
           </a:p>
         </p:txBody>
       </p:sp>
       <p:pic>
         <p:nvPicPr>
-          <p:cNvPr id="3" name="Picture 2" descr="curva_perda.png"/>
+          <p:cNvPr id="4" name="Picture 3" descr="reconstrucoes.png"/>
           <p:cNvPicPr>
             <a:picLocks noChangeAspect="1"/>
           </p:cNvPicPr>
@@ -3213,8 +3246,8 @@
         </p:blipFill>
         <p:spPr>
           <a:xfrm>
-            <a:off x="2218791" y="1371600"/>
-            <a:ext cx="7754112" cy="4846320"/>
+            <a:off x="1295247" y="1876182"/>
+            <a:ext cx="9601200" cy="2182090"/>
           </a:xfrm>
           <a:prstGeom prst="rect">
             <a:avLst/>
@@ -3223,14 +3256,14 @@
       </p:pic>
       <p:sp>
         <p:nvSpPr>
-          <p:cNvPr id="4" name="TextBox 3"/>
+          <p:cNvPr id="5" name="TextBox 4"/>
           <p:cNvSpPr txBox="1"/>
           <p:nvPr/>
         </p:nvSpPr>
         <p:spPr>
           <a:xfrm>
-            <a:off x="612648" y="6355080"/>
-            <a:ext cx="10972800" cy="411480"/>
+            <a:off x="612648" y="4251959"/>
+            <a:ext cx="10972800" cy="310896"/>
           </a:xfrm>
           <a:prstGeom prst="rect">
             <a:avLst/>
@@ -3238,16 +3271,75 @@
           <a:noFill/>
         </p:spPr>
         <p:txBody>
-          <a:bodyPr wrap="none">
+          <a:bodyPr wrap="square">
             <a:spAutoFit/>
           </a:bodyPr>
           <a:lstStyle/>
           <a:p>
             <a:pPr>
-              <a:defRPr sz="1400"/>
-            </a:pPr>
-            <a:r>
-              <a:t>MSE de validação nos patches ocultos por época</a:t>
+              <a:defRPr sz="1300" b="1">
+                <a:latin typeface="Arial"/>
+              </a:defRPr>
+            </a:pPr>
+            <a:r>
+              <a:t>Curva de perda de validação: MSE nos patches ocultos por época</a:t>
+            </a:r>
+          </a:p>
+        </p:txBody>
+      </p:sp>
+      <p:pic>
+        <p:nvPicPr>
+          <p:cNvPr id="6" name="Picture 5" descr="curva_perda.png"/>
+          <p:cNvPicPr>
+            <a:picLocks noChangeAspect="1"/>
+          </p:cNvPicPr>
+          <p:nvPr/>
+        </p:nvPicPr>
+        <p:blipFill>
+          <a:blip r:embed="rId3"/>
+          <a:stretch>
+            <a:fillRect/>
+          </a:stretch>
+        </p:blipFill>
+        <p:spPr>
+          <a:xfrm>
+            <a:off x="4669383" y="4590288"/>
+            <a:ext cx="2852927" cy="1783080"/>
+          </a:xfrm>
+          <a:prstGeom prst="rect">
+            <a:avLst/>
+          </a:prstGeom>
+        </p:spPr>
+      </p:pic>
+      <p:sp>
+        <p:nvSpPr>
+          <p:cNvPr id="7" name="TextBox 6"/>
+          <p:cNvSpPr txBox="1"/>
+          <p:nvPr/>
+        </p:nvSpPr>
+        <p:spPr>
+          <a:xfrm>
+            <a:off x="612648" y="6400800"/>
+            <a:ext cx="10972800" cy="384048"/>
+          </a:xfrm>
+          <a:prstGeom prst="rect">
+            <a:avLst/>
+          </a:prstGeom>
+          <a:noFill/>
+        </p:spPr>
+        <p:txBody>
+          <a:bodyPr wrap="square">
+            <a:spAutoFit/>
+          </a:bodyPr>
+          <a:lstStyle/>
+          <a:p>
+            <a:pPr>
+              <a:defRPr sz="1300" b="0">
+                <a:latin typeface="Arial"/>
+              </a:defRPr>
+            </a:pPr>
+            <a:r>
+              <a:t>Esquerda: original, mascarada e reconstrução por condição; direita: as duas condições no mesmo eixo</a:t>
             </a:r>
           </a:p>
         </p:txBody>
@@ -3289,7 +3381,7 @@
               <a:defRPr sz="3000"/>
             </a:pPr>
             <a:r>
-              <a:t>Lendo os números</a:t>
+              <a:t>Resultados, críticas e próximos passos</a:t>
             </a:r>
           </a:p>
         </p:txBody>
@@ -3321,7 +3413,7 @@
               <a:defRPr sz="1700"/>
             </a:pPr>
             <a:r>
-              <a:t>Épocas, batch e taxa de aprendizado foram igualados; a quantidade de computação por época diverge (4 contra 8 tokens no encoder)</a:t>
+              <a:t>Épocas, batch e lr igualados; a computação por época diverge (4 contra 8 tokens no encoder)</a:t>
             </a:r>
           </a:p>
           <a:p>
@@ -3329,7 +3421,7 @@
               <a:defRPr sz="1700"/>
             </a:pPr>
             <a:r>
-              <a:t>A diferença principal entre condições vem da taxa de ocultação</a:t>
+              <a:t>Máscara aninhada isola o efeito da taxa: os patches ocultos a 50% também estão a 75%</a:t>
             </a:r>
           </a:p>
           <a:p>
@@ -3337,7 +3429,7 @@
               <a:defRPr sz="1700"/>
             </a:pPr>
             <a:r>
-              <a:t>Máscara aninhada isola o efeito da taxa (mesmos patches ocultos a 50%)</a:t>
+              <a:t>Evidência desta configuração: semente única 42, teste fixo de 1.000 imagens e máscara aninhada</a:t>
             </a:r>
           </a:p>
           <a:p>
@@ -3345,7 +3437,31 @@
               <a:defRPr sz="1700"/>
             </a:pPr>
             <a:r>
-              <a:t>Semente única 42: comparação determinística, mas repetição com mais sementes é necessária</a:t>
+              <a:t>Não generalizar: repetir com mais sementes e avaliar downstream antes de concluir</a:t>
+            </a:r>
+          </a:p>
+          <a:p>
+            <a:pPr>
+              <a:defRPr sz="1700"/>
+            </a:pPr>
+            <a:r>
+              <a:t>Qualidade visual da reconstrução não é prova de representações melhores</a:t>
+            </a:r>
+          </a:p>
+          <a:p>
+            <a:pPr>
+              <a:defRPr sz="1700"/>
+            </a:pPr>
+            <a:r>
+              <a:t>Dataset pequeno e didático: qualidade absoluta menor que a do paper</a:t>
+            </a:r>
+          </a:p>
+          <a:p>
+            <a:pPr>
+              <a:defRPr sz="1700"/>
+            </a:pPr>
+            <a:r>
+              <a:t>Linear probing e classificação downstream fora do escopo; próximo passo: linear probing em mais sementes</a:t>
             </a:r>
           </a:p>
         </p:txBody>
@@ -3387,55 +3503,143 @@
               <a:defRPr sz="3000"/>
             </a:pPr>
             <a:r>
-              <a:t>Limitações e próximos passos</a:t>
-            </a:r>
-          </a:p>
-        </p:txBody>
-      </p:sp>
-      <p:sp>
-        <p:nvSpPr>
-          <p:cNvPr id="3" name="Content Placeholder 2"/>
-          <p:cNvSpPr>
-            <a:spLocks noGrp="1"/>
-          </p:cNvSpPr>
-          <p:nvPr>
-            <p:ph idx="1"/>
-          </p:nvPr>
-        </p:nvSpPr>
-        <p:spPr/>
-        <p:txBody>
-          <a:bodyPr/>
-          <a:lstStyle/>
-          <a:p>
-            <a:pPr>
-              <a:defRPr sz="1700"/>
-            </a:pPr>
-            <a:r>
-              <a:t>Dataset pequeno e didático: qualidade absoluta é menor que a do paper</a:t>
-            </a:r>
-          </a:p>
-          <a:p>
-            <a:pPr>
-              <a:defRPr sz="1700"/>
-            </a:pPr>
-            <a:r>
-              <a:t>Linear probing e classificação downstream: fora do escopo deste trabalho</a:t>
-            </a:r>
-          </a:p>
-          <a:p>
-            <a:pPr>
-              <a:defRPr sz="1700"/>
-            </a:pPr>
-            <a:r>
-              <a:t>Próximo passo: avaliar representações com linear probing em mais sementes</a:t>
-            </a:r>
-          </a:p>
-          <a:p>
-            <a:pPr>
-              <a:defRPr sz="1700"/>
-            </a:pPr>
-            <a:r>
-              <a:t>Referência: He et al. (2022), Masked Autoencoders Are Scalable Vision Learners</a:t>
+              <a:t>Aplicações e referências</a:t>
+            </a:r>
+          </a:p>
+        </p:txBody>
+      </p:sp>
+      <p:sp>
+        <p:nvSpPr>
+          <p:cNvPr id="3" name="TextBox 2"/>
+          <p:cNvSpPr txBox="1"/>
+          <p:nvPr/>
+        </p:nvSpPr>
+        <p:spPr>
+          <a:xfrm>
+            <a:off x="612648" y="1371600"/>
+            <a:ext cx="10972800" cy="2103120"/>
+          </a:xfrm>
+          <a:prstGeom prst="rect">
+            <a:avLst/>
+          </a:prstGeom>
+          <a:noFill/>
+        </p:spPr>
+        <p:txBody>
+          <a:bodyPr wrap="square">
+            <a:spAutoFit/>
+          </a:bodyPr>
+          <a:lstStyle/>
+          <a:p>
+            <a:pPr>
+              <a:defRPr sz="1500" b="1">
+                <a:latin typeface="Arial"/>
+              </a:defRPr>
+            </a:pPr>
+            <a:r>
+              <a:t>Aplicações das representações aprendidas:</a:t>
+            </a:r>
+          </a:p>
+          <a:p>
+            <a:pPr>
+              <a:defRPr sz="1400" b="0">
+                <a:latin typeface="Arial"/>
+              </a:defRPr>
+            </a:pPr>
+            <a:r>
+              <a:t>BERT: compreensão de linguagem (busca, classificação e diálogo)</a:t>
+            </a:r>
+          </a:p>
+          <a:p>
+            <a:pPr>
+              <a:defRPr sz="1400" b="0">
+                <a:latin typeface="Arial"/>
+              </a:defRPr>
+            </a:pPr>
+            <a:r>
+              <a:t>MAE: classificação, detecção e segmentação de imagens</a:t>
+            </a:r>
+          </a:p>
+          <a:p>
+            <a:pPr>
+              <a:defRPr sz="1400" b="0">
+                <a:latin typeface="Arial"/>
+              </a:defRPr>
+            </a:pPr>
+            <a:r>
+              <a:t>SimMIM: classificação, detecção e segmentação em imagens</a:t>
+            </a:r>
+          </a:p>
+        </p:txBody>
+      </p:sp>
+      <p:sp>
+        <p:nvSpPr>
+          <p:cNvPr id="4" name="TextBox 3"/>
+          <p:cNvSpPr txBox="1"/>
+          <p:nvPr/>
+        </p:nvSpPr>
+        <p:spPr>
+          <a:xfrm>
+            <a:off x="612648" y="3063240"/>
+            <a:ext cx="10972800" cy="3200400"/>
+          </a:xfrm>
+          <a:prstGeom prst="rect">
+            <a:avLst/>
+          </a:prstGeom>
+          <a:noFill/>
+        </p:spPr>
+        <p:txBody>
+          <a:bodyPr wrap="square">
+            <a:spAutoFit/>
+          </a:bodyPr>
+          <a:lstStyle/>
+          <a:p>
+            <a:pPr>
+              <a:defRPr sz="1500" b="1">
+                <a:latin typeface="Arial"/>
+              </a:defRPr>
+            </a:pPr>
+            <a:r>
+              <a:t>Referências:</a:t>
+            </a:r>
+          </a:p>
+          <a:p>
+            <a:pPr>
+              <a:defRPr sz="1200" b="0">
+                <a:latin typeface="Arial"/>
+              </a:defRPr>
+            </a:pPr>
+            <a:r>
+              <a:t>Devlin, J.; Chang, M.; Lee, K.; Toutanova, K. (2019). BERT: Pre-training of Deep Bidirectional Transformers for Language Understanding. NAACL-HLT.</a:t>
+            </a:r>
+          </a:p>
+          <a:p>
+            <a:pPr>
+              <a:defRPr sz="1200" b="0">
+                <a:latin typeface="Arial"/>
+              </a:defRPr>
+            </a:pPr>
+            <a:r>
+              <a:t>He, K.; Chen, X.; Xie, S.; Li, Y.; Dollár, P.; Girshick, R. (2022). Masked Autoencoders Are Scalable Vision Learners. CVPR.</a:t>
+            </a:r>
+          </a:p>
+          <a:p>
+            <a:pPr>
+              <a:defRPr sz="1200" b="0">
+                <a:latin typeface="Arial"/>
+              </a:defRPr>
+            </a:pPr>
+            <a:r>
+              <a:t>Xie, Z.; Zhang, Z.; Lin, Y.; Bian, J.; Lin, L.; Zeng, D. (2022). SimMIM: A Simple Framework for Masked Image Modeling. CVPR.</a:t>
+            </a:r>
+          </a:p>
+          <a:p>
+            <a:pPr>
+              <a:defRPr sz="1200" b="0">
+                <a:latin typeface="Arial"/>
+              </a:defRPr>
+            </a:pPr>
+            <a:r>
+              <a:t>Krizhevsky, A.; Nair, V.; Hinton, G. (2009). CIFAR-10 (Canadian Institute for Advanced Research). Fonte dos dados, verificado por md5.</a:t>
             </a:r>
           </a:p>
         </p:txBody>
@@ -3517,7 +3721,7 @@
               <a:defRPr sz="1700"/>
             </a:pPr>
             <a:r>
-              <a:t>Arquitetura de um Masked Autoencoder</a:t>
+              <a:t>Fluxo do MAE: diagrama, equação da perda e pseudocódigo</a:t>
             </a:r>
           </a:p>
           <a:p>
@@ -3525,7 +3729,7 @@
               <a:defRPr sz="1700"/>
             </a:pPr>
             <a:r>
-              <a:t>Nossa implementação: patches, máscara aninhada, perda</a:t>
+              <a:t>Arquitetura e nossa implementação</a:t>
             </a:r>
           </a:p>
           <a:p>
@@ -3533,7 +3737,7 @@
               <a:defRPr sz="1700"/>
             </a:pPr>
             <a:r>
-              <a:t>Protocolo e orcamento de treino</a:t>
+              <a:t>Protocolo e orçamento de treino</a:t>
             </a:r>
           </a:p>
           <a:p>
@@ -3550,6 +3754,14 @@
             </a:pPr>
             <a:r>
               <a:t>Resultados, críticas e próximos passos</a:t>
+            </a:r>
+          </a:p>
+          <a:p>
+            <a:pPr>
+              <a:defRPr sz="1700"/>
+            </a:pPr>
+            <a:r>
+              <a:t>Aplicações e referências</a:t>
             </a:r>
           </a:p>
         </p:txBody>
@@ -3694,50 +3906,373 @@
           </a:p>
         </p:txBody>
       </p:sp>
-      <p:sp>
-        <p:nvSpPr>
-          <p:cNvPr id="3" name="Content Placeholder 2"/>
-          <p:cNvSpPr>
-            <a:spLocks noGrp="1"/>
-          </p:cNvSpPr>
-          <p:nvPr>
-            <p:ph idx="1"/>
-          </p:nvPr>
-        </p:nvSpPr>
-        <p:spPr/>
-        <p:txBody>
-          <a:bodyPr/>
-          <a:lstStyle/>
-          <a:p>
-            <a:pPr>
-              <a:defRPr sz="1700"/>
-            </a:pPr>
-            <a:r>
-              <a:t>BERT (2018): mascarar tokens de texto e prever os ocultos</a:t>
-            </a:r>
-          </a:p>
-          <a:p>
-            <a:pPr>
-              <a:defRPr sz="1700"/>
-            </a:pPr>
-            <a:r>
-              <a:t>MAE (He et al., 2022): patches ocultos, encoder assimétrico, decoder leve</a:t>
-            </a:r>
-          </a:p>
-          <a:p>
-            <a:pPr>
-              <a:defRPr sz="1700"/>
-            </a:pPr>
-            <a:r>
-              <a:t>SimMIM (2022): mascarar pixels brutos com decoder simples</a:t>
-            </a:r>
-          </a:p>
-          <a:p>
-            <a:pPr>
-              <a:defRPr sz="1700"/>
-            </a:pPr>
-            <a:r>
-              <a:t>Diferença chave: o quanto se pode ocultar (75% funciona no MAE)</a:t>
+      <p:graphicFrame>
+        <p:nvGraphicFramePr>
+          <p:cNvPr id="3" name="Table 2"/>
+          <p:cNvGraphicFramePr>
+            <a:graphicFrameLocks noGrp="1"/>
+          </p:cNvGraphicFramePr>
+          <p:nvPr/>
+        </p:nvGraphicFramePr>
+        <p:xfrm>
+          <a:off x="502920" y="1371600"/>
+          <a:ext cx="11247120" cy="4023360"/>
+        </p:xfrm>
+        <a:graphic>
+          <a:graphicData uri="http://schemas.openxmlformats.org/drawingml/2006/table">
+            <a:tbl>
+              <a:tblPr firstRow="1" bandRow="1">
+                <a:tableStyleId>{5C22544A-7EE6-4342-B048-85BDC9FD1C3A}</a:tableStyleId>
+              </a:tblPr>
+              <a:tblGrid>
+                <a:gridCol w="1737360"/>
+                <a:gridCol w="3169920"/>
+                <a:gridCol w="3169920"/>
+                <a:gridCol w="3169920"/>
+              </a:tblGrid>
+              <a:tr h="804672">
+                <a:tc>
+                  <a:txBody>
+                    <a:bodyPr/>
+                    <a:lstStyle/>
+                    <a:p>
+                      <a:pPr>
+                        <a:defRPr sz="1500" b="1"/>
+                      </a:pPr>
+                      <a:r>
+                        <a:t>Dimensão</a:t>
+                      </a:r>
+                    </a:p>
+                  </a:txBody>
+                  <a:tcPr/>
+                </a:tc>
+                <a:tc>
+                  <a:txBody>
+                    <a:bodyPr/>
+                    <a:lstStyle/>
+                    <a:p>
+                      <a:pPr>
+                        <a:defRPr sz="1500" b="1"/>
+                      </a:pPr>
+                      <a:r>
+                        <a:t>BERT</a:t>
+                      </a:r>
+                    </a:p>
+                  </a:txBody>
+                  <a:tcPr/>
+                </a:tc>
+                <a:tc>
+                  <a:txBody>
+                    <a:bodyPr/>
+                    <a:lstStyle/>
+                    <a:p>
+                      <a:pPr>
+                        <a:defRPr sz="1500" b="1"/>
+                      </a:pPr>
+                      <a:r>
+                        <a:t>MAE</a:t>
+                      </a:r>
+                    </a:p>
+                  </a:txBody>
+                  <a:tcPr/>
+                </a:tc>
+                <a:tc>
+                  <a:txBody>
+                    <a:bodyPr/>
+                    <a:lstStyle/>
+                    <a:p>
+                      <a:pPr>
+                        <a:defRPr sz="1500" b="1"/>
+                      </a:pPr>
+                      <a:r>
+                        <a:t>SimMIM</a:t>
+                      </a:r>
+                    </a:p>
+                  </a:txBody>
+                  <a:tcPr/>
+                </a:tc>
+              </a:tr>
+              <a:tr h="804672">
+                <a:tc>
+                  <a:txBody>
+                    <a:bodyPr/>
+                    <a:lstStyle/>
+                    <a:p>
+                      <a:pPr>
+                        <a:defRPr sz="1200" b="1"/>
+                      </a:pPr>
+                      <a:r>
+                        <a:t>Modalidade</a:t>
+                      </a:r>
+                    </a:p>
+                  </a:txBody>
+                  <a:tcPr/>
+                </a:tc>
+                <a:tc>
+                  <a:txBody>
+                    <a:bodyPr/>
+                    <a:lstStyle/>
+                    <a:p>
+                      <a:pPr>
+                        <a:defRPr sz="1200" b="0"/>
+                      </a:pPr>
+                      <a:r>
+                        <a:t>Texto (tokens discretos)</a:t>
+                      </a:r>
+                    </a:p>
+                  </a:txBody>
+                  <a:tcPr/>
+                </a:tc>
+                <a:tc>
+                  <a:txBody>
+                    <a:bodyPr/>
+                    <a:lstStyle/>
+                    <a:p>
+                      <a:pPr>
+                        <a:defRPr sz="1200" b="0"/>
+                      </a:pPr>
+                      <a:r>
+                        <a:t>Imagem (patches de pixels)</a:t>
+                      </a:r>
+                    </a:p>
+                  </a:txBody>
+                  <a:tcPr/>
+                </a:tc>
+                <a:tc>
+                  <a:txBody>
+                    <a:bodyPr/>
+                    <a:lstStyle/>
+                    <a:p>
+                      <a:pPr>
+                        <a:defRPr sz="1200" b="0"/>
+                      </a:pPr>
+                      <a:r>
+                        <a:t>Imagem (patches de pixels)</a:t>
+                      </a:r>
+                    </a:p>
+                  </a:txBody>
+                  <a:tcPr/>
+                </a:tc>
+              </a:tr>
+              <a:tr h="804672">
+                <a:tc>
+                  <a:txBody>
+                    <a:bodyPr/>
+                    <a:lstStyle/>
+                    <a:p>
+                      <a:pPr>
+                        <a:defRPr sz="1200" b="1"/>
+                      </a:pPr>
+                      <a:r>
+                        <a:t>Alvo previsto</a:t>
+                      </a:r>
+                    </a:p>
+                  </a:txBody>
+                  <a:tcPr/>
+                </a:tc>
+                <a:tc>
+                  <a:txBody>
+                    <a:bodyPr/>
+                    <a:lstStyle/>
+                    <a:p>
+                      <a:pPr>
+                        <a:defRPr sz="1200" b="0"/>
+                      </a:pPr>
+                      <a:r>
+                        <a:t>Palavras (tokens) ocultas</a:t>
+                      </a:r>
+                    </a:p>
+                  </a:txBody>
+                  <a:tcPr/>
+                </a:tc>
+                <a:tc>
+                  <a:txBody>
+                    <a:bodyPr/>
+                    <a:lstStyle/>
+                    <a:p>
+                      <a:pPr>
+                        <a:defRPr sz="1200" b="0"/>
+                      </a:pPr>
+                      <a:r>
+                        <a:t>Pixels brutos dos patches ocultos</a:t>
+                      </a:r>
+                    </a:p>
+                  </a:txBody>
+                  <a:tcPr/>
+                </a:tc>
+                <a:tc>
+                  <a:txBody>
+                    <a:bodyPr/>
+                    <a:lstStyle/>
+                    <a:p>
+                      <a:pPr>
+                        <a:defRPr sz="1200" b="0"/>
+                      </a:pPr>
+                      <a:r>
+                        <a:t>Pixels brutos dos patches ocultos</a:t>
+                      </a:r>
+                    </a:p>
+                  </a:txBody>
+                  <a:tcPr/>
+                </a:tc>
+              </a:tr>
+              <a:tr h="804672">
+                <a:tc>
+                  <a:txBody>
+                    <a:bodyPr/>
+                    <a:lstStyle/>
+                    <a:p>
+                      <a:pPr>
+                        <a:defRPr sz="1200" b="1"/>
+                      </a:pPr>
+                      <a:r>
+                        <a:t>Perda</a:t>
+                      </a:r>
+                    </a:p>
+                  </a:txBody>
+                  <a:tcPr/>
+                </a:tc>
+                <a:tc>
+                  <a:txBody>
+                    <a:bodyPr/>
+                    <a:lstStyle/>
+                    <a:p>
+                      <a:pPr>
+                        <a:defRPr sz="1200" b="0"/>
+                      </a:pPr>
+                      <a:r>
+                        <a:t>Entropia cruzada sobre os tokens ocultos</a:t>
+                      </a:r>
+                    </a:p>
+                  </a:txBody>
+                  <a:tcPr/>
+                </a:tc>
+                <a:tc>
+                  <a:txBody>
+                    <a:bodyPr/>
+                    <a:lstStyle/>
+                    <a:p>
+                      <a:pPr>
+                        <a:defRPr sz="1200" b="0"/>
+                      </a:pPr>
+                      <a:r>
+                        <a:t>MSE nos pixels normalizados, média por patch oculto</a:t>
+                      </a:r>
+                    </a:p>
+                  </a:txBody>
+                  <a:tcPr/>
+                </a:tc>
+                <a:tc>
+                  <a:txBody>
+                    <a:bodyPr/>
+                    <a:lstStyle/>
+                    <a:p>
+                      <a:pPr>
+                        <a:defRPr sz="1200" b="0"/>
+                      </a:pPr>
+                      <a:r>
+                        <a:t>L1 (erro absoluto) nos pixels reconstruídos</a:t>
+                      </a:r>
+                    </a:p>
+                  </a:txBody>
+                  <a:tcPr/>
+                </a:tc>
+              </a:tr>
+              <a:tr h="804672">
+                <a:tc>
+                  <a:txBody>
+                    <a:bodyPr/>
+                    <a:lstStyle/>
+                    <a:p>
+                      <a:pPr>
+                        <a:defRPr sz="1200" b="1"/>
+                      </a:pPr>
+                      <a:r>
+                        <a:t>Arquitetura</a:t>
+                      </a:r>
+                    </a:p>
+                  </a:txBody>
+                  <a:tcPr/>
+                </a:tc>
+                <a:tc>
+                  <a:txBody>
+                    <a:bodyPr/>
+                    <a:lstStyle/>
+                    <a:p>
+                      <a:pPr>
+                        <a:defRPr sz="1200" b="0"/>
+                      </a:pPr>
+                      <a:r>
+                        <a:t>Encoder Transformer único</a:t>
+                      </a:r>
+                    </a:p>
+                  </a:txBody>
+                  <a:tcPr/>
+                </a:tc>
+                <a:tc>
+                  <a:txBody>
+                    <a:bodyPr/>
+                    <a:lstStyle/>
+                    <a:p>
+                      <a:pPr>
+                        <a:defRPr sz="1200" b="0"/>
+                      </a:pPr>
+                      <a:r>
+                        <a:t>Assimétrica: encoder pesado e decoder leve separado</a:t>
+                      </a:r>
+                    </a:p>
+                  </a:txBody>
+                  <a:tcPr/>
+                </a:tc>
+                <a:tc>
+                  <a:txBody>
+                    <a:bodyPr/>
+                    <a:lstStyle/>
+                    <a:p>
+                      <a:pPr>
+                        <a:defRPr sz="1200" b="0"/>
+                      </a:pPr>
+                      <a:r>
+                        <a:t>Encoder único com cabeça de predição linear leve</a:t>
+                      </a:r>
+                    </a:p>
+                  </a:txBody>
+                  <a:tcPr/>
+                </a:tc>
+              </a:tr>
+            </a:tbl>
+          </a:graphicData>
+        </a:graphic>
+      </p:graphicFrame>
+      <p:sp>
+        <p:nvSpPr>
+          <p:cNvPr id="4" name="TextBox 3"/>
+          <p:cNvSpPr txBox="1"/>
+          <p:nvPr/>
+        </p:nvSpPr>
+        <p:spPr>
+          <a:xfrm>
+            <a:off x="502920" y="5623560"/>
+            <a:ext cx="11247120" cy="1005840"/>
+          </a:xfrm>
+          <a:prstGeom prst="rect">
+            <a:avLst/>
+          </a:prstGeom>
+          <a:noFill/>
+        </p:spPr>
+        <p:txBody>
+          <a:bodyPr wrap="square">
+            <a:spAutoFit/>
+          </a:bodyPr>
+          <a:lstStyle/>
+          <a:p>
+            <a:pPr>
+              <a:defRPr sz="1300" b="0">
+                <a:latin typeface="Arial"/>
+              </a:defRPr>
+            </a:pPr>
+            <a:r>
+              <a:t>Contraste MSE x L1: o MSE do MAE opera em pixels normalizados com média por patch e pede decoder separado; a L1 do SimMIM faz regressão direta de pixels com cabeça linear leve sobre um encoder único, que admite proporções altas de máscara também</a:t>
             </a:r>
           </a:p>
         </p:txBody>
@@ -3779,63 +4314,929 @@
               <a:defRPr sz="3000"/>
             </a:pPr>
             <a:r>
-              <a:t>Arquitetura do MAE</a:t>
-            </a:r>
-          </a:p>
-        </p:txBody>
-      </p:sp>
-      <p:sp>
-        <p:nvSpPr>
-          <p:cNvPr id="3" name="Content Placeholder 2"/>
-          <p:cNvSpPr>
-            <a:spLocks noGrp="1"/>
-          </p:cNvSpPr>
-          <p:nvPr>
-            <p:ph idx="1"/>
-          </p:nvPr>
-        </p:nvSpPr>
-        <p:spPr/>
-        <p:txBody>
-          <a:bodyPr/>
-          <a:lstStyle/>
-          <a:p>
-            <a:pPr>
-              <a:defRPr sz="1700"/>
-            </a:pPr>
-            <a:r>
-              <a:t>Patchify: imagem 32x32x3 em 16 patches de 8x8 (192 valores cada)</a:t>
-            </a:r>
-          </a:p>
-          <a:p>
-            <a:pPr>
-              <a:defRPr sz="1700"/>
-            </a:pPr>
-            <a:r>
-              <a:t>Encoder: somente os patches visíveis entram (ViT dim 128, 4 blocos, 4 heads)</a:t>
-            </a:r>
-          </a:p>
-          <a:p>
-            <a:pPr>
-              <a:defRPr sz="1700"/>
-            </a:pPr>
-            <a:r>
-              <a:t>Decoder leve: dim 64, 2 blocos, tokens de máscara + embedding posicional</a:t>
-            </a:r>
-          </a:p>
-          <a:p>
-            <a:pPr>
-              <a:defRPr sz="1700"/>
-            </a:pPr>
-            <a:r>
-              <a:t>Saída: 192 valores por patch oculto (a imagem completa)</a:t>
-            </a:r>
-          </a:p>
-          <a:p>
-            <a:pPr>
-              <a:defRPr sz="1700"/>
-            </a:pPr>
-            <a:r>
-              <a:t>Perda: MSE somente nos patches ocultos, pixels brutos em [0,1]</a:t>
+              <a:t>Fluxo do MAE: da imagem à perda nos ocultos</a:t>
+            </a:r>
+          </a:p>
+        </p:txBody>
+      </p:sp>
+      <p:sp>
+        <p:nvSpPr>
+          <p:cNvPr id="3" name="Rounded Rectangle 2"/>
+          <p:cNvSpPr/>
+          <p:nvPr/>
+        </p:nvSpPr>
+        <p:spPr>
+          <a:xfrm>
+            <a:off x="612648" y="1463040"/>
+            <a:ext cx="2487168" cy="1371600"/>
+          </a:xfrm>
+          <a:prstGeom prst="roundRect">
+            <a:avLst/>
+          </a:prstGeom>
+          <a:solidFill>
+            <a:srgbClr val="EEF2F8"/>
+          </a:solidFill>
+          <a:ln>
+            <a:solidFill>
+              <a:srgbClr val="2F4B6E"/>
+            </a:solidFill>
+          </a:ln>
+        </p:spPr>
+        <p:style>
+          <a:lnRef idx="1">
+            <a:schemeClr val="accent1"/>
+          </a:lnRef>
+          <a:fillRef idx="3">
+            <a:schemeClr val="accent1"/>
+          </a:fillRef>
+          <a:effectRef idx="2">
+            <a:schemeClr val="accent1"/>
+          </a:effectRef>
+          <a:fontRef idx="minor">
+            <a:schemeClr val="lt1"/>
+          </a:fontRef>
+        </p:style>
+        <p:txBody>
+          <a:bodyPr rtlCol="0" anchor="ctr" wrap="square"/>
+          <a:lstStyle/>
+          <a:p>
+            <a:pPr algn="ctr">
+              <a:defRPr sz="1100" b="1">
+                <a:solidFill>
+                  <a:srgbClr val="2F4B6E"/>
+                </a:solidFill>
+              </a:defRPr>
+            </a:pPr>
+            <a:r>
+              <a:t>Imagem sem rótulo</a:t>
+            </a:r>
+          </a:p>
+          <a:p>
+            <a:pPr algn="ctr">
+              <a:defRPr sz="1000" b="0">
+                <a:solidFill>
+                  <a:srgbClr val="2F4B6E"/>
+                </a:solidFill>
+              </a:defRPr>
+            </a:pPr>
+            <a:r>
+              <a:t>32x32x3</a:t>
+            </a:r>
+          </a:p>
+        </p:txBody>
+      </p:sp>
+      <p:sp>
+        <p:nvSpPr>
+          <p:cNvPr id="4" name="Right Arrow 3"/>
+          <p:cNvSpPr/>
+          <p:nvPr/>
+        </p:nvSpPr>
+        <p:spPr>
+          <a:xfrm>
+            <a:off x="3099816" y="1956816"/>
+            <a:ext cx="329184" cy="384048"/>
+          </a:xfrm>
+          <a:prstGeom prst="rightArrow">
+            <a:avLst/>
+          </a:prstGeom>
+          <a:solidFill>
+            <a:srgbClr val="2F6BB0"/>
+          </a:solidFill>
+          <a:ln>
+            <a:noFill/>
+          </a:ln>
+        </p:spPr>
+        <p:style>
+          <a:lnRef idx="1">
+            <a:schemeClr val="accent1"/>
+          </a:lnRef>
+          <a:fillRef idx="3">
+            <a:schemeClr val="accent1"/>
+          </a:fillRef>
+          <a:effectRef idx="2">
+            <a:schemeClr val="accent1"/>
+          </a:effectRef>
+          <a:fontRef idx="minor">
+            <a:schemeClr val="lt1"/>
+          </a:fontRef>
+        </p:style>
+        <p:txBody>
+          <a:bodyPr rtlCol="0" anchor="ctr"/>
+          <a:lstStyle/>
+          <a:p>
+            <a:pPr algn="ctr"/>
+          </a:p>
+        </p:txBody>
+      </p:sp>
+      <p:sp>
+        <p:nvSpPr>
+          <p:cNvPr id="5" name="Rounded Rectangle 4"/>
+          <p:cNvSpPr/>
+          <p:nvPr/>
+        </p:nvSpPr>
+        <p:spPr>
+          <a:xfrm>
+            <a:off x="3429000" y="1463040"/>
+            <a:ext cx="2487168" cy="1371600"/>
+          </a:xfrm>
+          <a:prstGeom prst="roundRect">
+            <a:avLst/>
+          </a:prstGeom>
+          <a:solidFill>
+            <a:srgbClr val="EEF2F8"/>
+          </a:solidFill>
+          <a:ln>
+            <a:solidFill>
+              <a:srgbClr val="2F4B6E"/>
+            </a:solidFill>
+          </a:ln>
+        </p:spPr>
+        <p:style>
+          <a:lnRef idx="1">
+            <a:schemeClr val="accent1"/>
+          </a:lnRef>
+          <a:fillRef idx="3">
+            <a:schemeClr val="accent1"/>
+          </a:fillRef>
+          <a:effectRef idx="2">
+            <a:schemeClr val="accent1"/>
+          </a:effectRef>
+          <a:fontRef idx="minor">
+            <a:schemeClr val="lt1"/>
+          </a:fontRef>
+        </p:style>
+        <p:txBody>
+          <a:bodyPr rtlCol="0" anchor="ctr" wrap="square"/>
+          <a:lstStyle/>
+          <a:p>
+            <a:pPr algn="ctr">
+              <a:defRPr sz="1100" b="1">
+                <a:solidFill>
+                  <a:srgbClr val="2F4B6E"/>
+                </a:solidFill>
+              </a:defRPr>
+            </a:pPr>
+            <a:r>
+              <a:t>Patches</a:t>
+            </a:r>
+          </a:p>
+          <a:p>
+            <a:pPr algn="ctr">
+              <a:defRPr sz="1000" b="0">
+                <a:solidFill>
+                  <a:srgbClr val="2F4B6E"/>
+                </a:solidFill>
+              </a:defRPr>
+            </a:pPr>
+            <a:r>
+              <a:t>16 de 8x8</a:t>
+            </a:r>
+          </a:p>
+          <a:p>
+            <a:pPr algn="ctr">
+              <a:defRPr sz="1000" b="0">
+                <a:solidFill>
+                  <a:srgbClr val="2F4B6E"/>
+                </a:solidFill>
+              </a:defRPr>
+            </a:pPr>
+            <a:r>
+              <a:t>(192 valores cada)</a:t>
+            </a:r>
+          </a:p>
+        </p:txBody>
+      </p:sp>
+      <p:sp>
+        <p:nvSpPr>
+          <p:cNvPr id="6" name="Right Arrow 5"/>
+          <p:cNvSpPr/>
+          <p:nvPr/>
+        </p:nvSpPr>
+        <p:spPr>
+          <a:xfrm>
+            <a:off x="5916168" y="1956816"/>
+            <a:ext cx="329184" cy="384048"/>
+          </a:xfrm>
+          <a:prstGeom prst="rightArrow">
+            <a:avLst/>
+          </a:prstGeom>
+          <a:solidFill>
+            <a:srgbClr val="2F6BB0"/>
+          </a:solidFill>
+          <a:ln>
+            <a:noFill/>
+          </a:ln>
+        </p:spPr>
+        <p:style>
+          <a:lnRef idx="1">
+            <a:schemeClr val="accent1"/>
+          </a:lnRef>
+          <a:fillRef idx="3">
+            <a:schemeClr val="accent1"/>
+          </a:fillRef>
+          <a:effectRef idx="2">
+            <a:schemeClr val="accent1"/>
+          </a:effectRef>
+          <a:fontRef idx="minor">
+            <a:schemeClr val="lt1"/>
+          </a:fontRef>
+        </p:style>
+        <p:txBody>
+          <a:bodyPr rtlCol="0" anchor="ctr"/>
+          <a:lstStyle/>
+          <a:p>
+            <a:pPr algn="ctr"/>
+          </a:p>
+        </p:txBody>
+      </p:sp>
+      <p:sp>
+        <p:nvSpPr>
+          <p:cNvPr id="7" name="Rounded Rectangle 6"/>
+          <p:cNvSpPr/>
+          <p:nvPr/>
+        </p:nvSpPr>
+        <p:spPr>
+          <a:xfrm>
+            <a:off x="6245352" y="1463040"/>
+            <a:ext cx="2487168" cy="1371600"/>
+          </a:xfrm>
+          <a:prstGeom prst="roundRect">
+            <a:avLst/>
+          </a:prstGeom>
+          <a:solidFill>
+            <a:srgbClr val="EEF2F8"/>
+          </a:solidFill>
+          <a:ln>
+            <a:solidFill>
+              <a:srgbClr val="2F4B6E"/>
+            </a:solidFill>
+          </a:ln>
+        </p:spPr>
+        <p:style>
+          <a:lnRef idx="1">
+            <a:schemeClr val="accent1"/>
+          </a:lnRef>
+          <a:fillRef idx="3">
+            <a:schemeClr val="accent1"/>
+          </a:fillRef>
+          <a:effectRef idx="2">
+            <a:schemeClr val="accent1"/>
+          </a:effectRef>
+          <a:fontRef idx="minor">
+            <a:schemeClr val="lt1"/>
+          </a:fontRef>
+        </p:style>
+        <p:txBody>
+          <a:bodyPr rtlCol="0" anchor="ctr" wrap="square"/>
+          <a:lstStyle/>
+          <a:p>
+            <a:pPr algn="ctr">
+              <a:defRPr sz="1100" b="1">
+                <a:solidFill>
+                  <a:srgbClr val="2F4B6E"/>
+                </a:solidFill>
+              </a:defRPr>
+            </a:pPr>
+            <a:r>
+              <a:t>Máscara aleatória</a:t>
+            </a:r>
+          </a:p>
+          <a:p>
+            <a:pPr algn="ctr">
+              <a:defRPr sz="1000" b="0">
+                <a:solidFill>
+                  <a:srgbClr val="2F4B6E"/>
+                </a:solidFill>
+              </a:defRPr>
+            </a:pPr>
+            <a:r>
+              <a:t>50% ou 75% dos patches</a:t>
+            </a:r>
+          </a:p>
+        </p:txBody>
+      </p:sp>
+      <p:sp>
+        <p:nvSpPr>
+          <p:cNvPr id="8" name="Right Arrow 7"/>
+          <p:cNvSpPr/>
+          <p:nvPr/>
+        </p:nvSpPr>
+        <p:spPr>
+          <a:xfrm>
+            <a:off x="8732520" y="1956816"/>
+            <a:ext cx="329184" cy="384048"/>
+          </a:xfrm>
+          <a:prstGeom prst="rightArrow">
+            <a:avLst/>
+          </a:prstGeom>
+          <a:solidFill>
+            <a:srgbClr val="2F6BB0"/>
+          </a:solidFill>
+          <a:ln>
+            <a:noFill/>
+          </a:ln>
+        </p:spPr>
+        <p:style>
+          <a:lnRef idx="1">
+            <a:schemeClr val="accent1"/>
+          </a:lnRef>
+          <a:fillRef idx="3">
+            <a:schemeClr val="accent1"/>
+          </a:fillRef>
+          <a:effectRef idx="2">
+            <a:schemeClr val="accent1"/>
+          </a:effectRef>
+          <a:fontRef idx="minor">
+            <a:schemeClr val="lt1"/>
+          </a:fontRef>
+        </p:style>
+        <p:txBody>
+          <a:bodyPr rtlCol="0" anchor="ctr"/>
+          <a:lstStyle/>
+          <a:p>
+            <a:pPr algn="ctr"/>
+          </a:p>
+        </p:txBody>
+      </p:sp>
+      <p:sp>
+        <p:nvSpPr>
+          <p:cNvPr id="9" name="Rounded Rectangle 8"/>
+          <p:cNvSpPr/>
+          <p:nvPr/>
+        </p:nvSpPr>
+        <p:spPr>
+          <a:xfrm>
+            <a:off x="9061704" y="1463040"/>
+            <a:ext cx="2487168" cy="1371600"/>
+          </a:xfrm>
+          <a:prstGeom prst="roundRect">
+            <a:avLst/>
+          </a:prstGeom>
+          <a:solidFill>
+            <a:srgbClr val="EEF2F8"/>
+          </a:solidFill>
+          <a:ln>
+            <a:solidFill>
+              <a:srgbClr val="2F4B6E"/>
+            </a:solidFill>
+          </a:ln>
+        </p:spPr>
+        <p:style>
+          <a:lnRef idx="1">
+            <a:schemeClr val="accent1"/>
+          </a:lnRef>
+          <a:fillRef idx="3">
+            <a:schemeClr val="accent1"/>
+          </a:fillRef>
+          <a:effectRef idx="2">
+            <a:schemeClr val="accent1"/>
+          </a:effectRef>
+          <a:fontRef idx="minor">
+            <a:schemeClr val="lt1"/>
+          </a:fontRef>
+        </p:style>
+        <p:txBody>
+          <a:bodyPr rtlCol="0" anchor="ctr" wrap="square"/>
+          <a:lstStyle/>
+          <a:p>
+            <a:pPr algn="ctr">
+              <a:defRPr sz="1100" b="1">
+                <a:solidFill>
+                  <a:srgbClr val="2F4B6E"/>
+                </a:solidFill>
+              </a:defRPr>
+            </a:pPr>
+            <a:r>
+              <a:t>Codificador (ViT)</a:t>
+            </a:r>
+          </a:p>
+          <a:p>
+            <a:pPr algn="ctr">
+              <a:defRPr sz="1000" b="0">
+                <a:solidFill>
+                  <a:srgbClr val="2F4B6E"/>
+                </a:solidFill>
+              </a:defRPr>
+            </a:pPr>
+            <a:r>
+              <a:t>processa apenas</a:t>
+            </a:r>
+          </a:p>
+          <a:p>
+            <a:pPr algn="ctr">
+              <a:defRPr sz="1000" b="0">
+                <a:solidFill>
+                  <a:srgbClr val="2F4B6E"/>
+                </a:solidFill>
+              </a:defRPr>
+            </a:pPr>
+            <a:r>
+              <a:t>os patches visíveis</a:t>
+            </a:r>
+          </a:p>
+        </p:txBody>
+      </p:sp>
+      <p:sp>
+        <p:nvSpPr>
+          <p:cNvPr id="10" name="Down Arrow 9"/>
+          <p:cNvSpPr/>
+          <p:nvPr/>
+        </p:nvSpPr>
+        <p:spPr>
+          <a:xfrm>
+            <a:off x="10140696" y="2944368"/>
+            <a:ext cx="329184" cy="969264"/>
+          </a:xfrm>
+          <a:prstGeom prst="downArrow">
+            <a:avLst/>
+          </a:prstGeom>
+          <a:solidFill>
+            <a:srgbClr val="2F6BB0"/>
+          </a:solidFill>
+          <a:ln>
+            <a:noFill/>
+          </a:ln>
+        </p:spPr>
+        <p:style>
+          <a:lnRef idx="1">
+            <a:schemeClr val="accent1"/>
+          </a:lnRef>
+          <a:fillRef idx="3">
+            <a:schemeClr val="accent1"/>
+          </a:fillRef>
+          <a:effectRef idx="2">
+            <a:schemeClr val="accent1"/>
+          </a:effectRef>
+          <a:fontRef idx="minor">
+            <a:schemeClr val="lt1"/>
+          </a:fontRef>
+        </p:style>
+        <p:txBody>
+          <a:bodyPr rtlCol="0" anchor="ctr"/>
+          <a:lstStyle/>
+          <a:p>
+            <a:pPr algn="ctr"/>
+          </a:p>
+        </p:txBody>
+      </p:sp>
+      <p:sp>
+        <p:nvSpPr>
+          <p:cNvPr id="11" name="Rounded Rectangle 10"/>
+          <p:cNvSpPr/>
+          <p:nvPr/>
+        </p:nvSpPr>
+        <p:spPr>
+          <a:xfrm>
+            <a:off x="612648" y="4023360"/>
+            <a:ext cx="2487168" cy="1371600"/>
+          </a:xfrm>
+          <a:prstGeom prst="roundRect">
+            <a:avLst/>
+          </a:prstGeom>
+          <a:solidFill>
+            <a:srgbClr val="EEF2F8"/>
+          </a:solidFill>
+          <a:ln>
+            <a:solidFill>
+              <a:srgbClr val="2F4B6E"/>
+            </a:solidFill>
+          </a:ln>
+        </p:spPr>
+        <p:style>
+          <a:lnRef idx="1">
+            <a:schemeClr val="accent1"/>
+          </a:lnRef>
+          <a:fillRef idx="3">
+            <a:schemeClr val="accent1"/>
+          </a:fillRef>
+          <a:effectRef idx="2">
+            <a:schemeClr val="accent1"/>
+          </a:effectRef>
+          <a:fontRef idx="minor">
+            <a:schemeClr val="lt1"/>
+          </a:fontRef>
+        </p:style>
+        <p:txBody>
+          <a:bodyPr rtlCol="0" anchor="ctr" wrap="square"/>
+          <a:lstStyle/>
+          <a:p>
+            <a:pPr algn="ctr">
+              <a:defRPr sz="1100" b="1">
+                <a:solidFill>
+                  <a:srgbClr val="2F4B6E"/>
+                </a:solidFill>
+              </a:defRPr>
+            </a:pPr>
+            <a:r>
+              <a:t>Perda: MSE</a:t>
+            </a:r>
+          </a:p>
+          <a:p>
+            <a:pPr algn="ctr">
+              <a:defRPr sz="1000" b="0">
+                <a:solidFill>
+                  <a:srgbClr val="2F4B6E"/>
+                </a:solidFill>
+              </a:defRPr>
+            </a:pPr>
+            <a:r>
+              <a:t>somente nos</a:t>
+            </a:r>
+          </a:p>
+          <a:p>
+            <a:pPr algn="ctr">
+              <a:defRPr sz="1000" b="0">
+                <a:solidFill>
+                  <a:srgbClr val="2F4B6E"/>
+                </a:solidFill>
+              </a:defRPr>
+            </a:pPr>
+            <a:r>
+              <a:t>patches ocultos</a:t>
+            </a:r>
+          </a:p>
+        </p:txBody>
+      </p:sp>
+      <p:sp>
+        <p:nvSpPr>
+          <p:cNvPr id="12" name="Left Arrow 11"/>
+          <p:cNvSpPr/>
+          <p:nvPr/>
+        </p:nvSpPr>
+        <p:spPr>
+          <a:xfrm>
+            <a:off x="3099816" y="4517136"/>
+            <a:ext cx="329184" cy="384048"/>
+          </a:xfrm>
+          <a:prstGeom prst="leftArrow">
+            <a:avLst/>
+          </a:prstGeom>
+          <a:solidFill>
+            <a:srgbClr val="2F6BB0"/>
+          </a:solidFill>
+          <a:ln>
+            <a:noFill/>
+          </a:ln>
+        </p:spPr>
+        <p:style>
+          <a:lnRef idx="1">
+            <a:schemeClr val="accent1"/>
+          </a:lnRef>
+          <a:fillRef idx="3">
+            <a:schemeClr val="accent1"/>
+          </a:fillRef>
+          <a:effectRef idx="2">
+            <a:schemeClr val="accent1"/>
+          </a:effectRef>
+          <a:fontRef idx="minor">
+            <a:schemeClr val="lt1"/>
+          </a:fontRef>
+        </p:style>
+        <p:txBody>
+          <a:bodyPr rtlCol="0" anchor="ctr"/>
+          <a:lstStyle/>
+          <a:p>
+            <a:pPr algn="ctr"/>
+          </a:p>
+        </p:txBody>
+      </p:sp>
+      <p:sp>
+        <p:nvSpPr>
+          <p:cNvPr id="13" name="Rounded Rectangle 12"/>
+          <p:cNvSpPr/>
+          <p:nvPr/>
+        </p:nvSpPr>
+        <p:spPr>
+          <a:xfrm>
+            <a:off x="3429000" y="4023360"/>
+            <a:ext cx="2487168" cy="1371600"/>
+          </a:xfrm>
+          <a:prstGeom prst="roundRect">
+            <a:avLst/>
+          </a:prstGeom>
+          <a:solidFill>
+            <a:srgbClr val="EEF2F8"/>
+          </a:solidFill>
+          <a:ln>
+            <a:solidFill>
+              <a:srgbClr val="2F4B6E"/>
+            </a:solidFill>
+          </a:ln>
+        </p:spPr>
+        <p:style>
+          <a:lnRef idx="1">
+            <a:schemeClr val="accent1"/>
+          </a:lnRef>
+          <a:fillRef idx="3">
+            <a:schemeClr val="accent1"/>
+          </a:fillRef>
+          <a:effectRef idx="2">
+            <a:schemeClr val="accent1"/>
+          </a:effectRef>
+          <a:fontRef idx="minor">
+            <a:schemeClr val="lt1"/>
+          </a:fontRef>
+        </p:style>
+        <p:txBody>
+          <a:bodyPr rtlCol="0" anchor="ctr" wrap="square"/>
+          <a:lstStyle/>
+          <a:p>
+            <a:pPr algn="ctr">
+              <a:defRPr sz="1100" b="1">
+                <a:solidFill>
+                  <a:srgbClr val="2F4B6E"/>
+                </a:solidFill>
+              </a:defRPr>
+            </a:pPr>
+            <a:r>
+              <a:t>Reconstrução</a:t>
+            </a:r>
+          </a:p>
+          <a:p>
+            <a:pPr algn="ctr">
+              <a:defRPr sz="1000" b="0">
+                <a:solidFill>
+                  <a:srgbClr val="2F4B6E"/>
+                </a:solidFill>
+              </a:defRPr>
+            </a:pPr>
+            <a:r>
+              <a:t>dos pixels dos</a:t>
+            </a:r>
+          </a:p>
+          <a:p>
+            <a:pPr algn="ctr">
+              <a:defRPr sz="1000" b="0">
+                <a:solidFill>
+                  <a:srgbClr val="2F4B6E"/>
+                </a:solidFill>
+              </a:defRPr>
+            </a:pPr>
+            <a:r>
+              <a:t>patches ocultos</a:t>
+            </a:r>
+          </a:p>
+        </p:txBody>
+      </p:sp>
+      <p:sp>
+        <p:nvSpPr>
+          <p:cNvPr id="14" name="Left Arrow 13"/>
+          <p:cNvSpPr/>
+          <p:nvPr/>
+        </p:nvSpPr>
+        <p:spPr>
+          <a:xfrm>
+            <a:off x="5916168" y="4517136"/>
+            <a:ext cx="329184" cy="384048"/>
+          </a:xfrm>
+          <a:prstGeom prst="leftArrow">
+            <a:avLst/>
+          </a:prstGeom>
+          <a:solidFill>
+            <a:srgbClr val="2F6BB0"/>
+          </a:solidFill>
+          <a:ln>
+            <a:noFill/>
+          </a:ln>
+        </p:spPr>
+        <p:style>
+          <a:lnRef idx="1">
+            <a:schemeClr val="accent1"/>
+          </a:lnRef>
+          <a:fillRef idx="3">
+            <a:schemeClr val="accent1"/>
+          </a:fillRef>
+          <a:effectRef idx="2">
+            <a:schemeClr val="accent1"/>
+          </a:effectRef>
+          <a:fontRef idx="minor">
+            <a:schemeClr val="lt1"/>
+          </a:fontRef>
+        </p:style>
+        <p:txBody>
+          <a:bodyPr rtlCol="0" anchor="ctr"/>
+          <a:lstStyle/>
+          <a:p>
+            <a:pPr algn="ctr"/>
+          </a:p>
+        </p:txBody>
+      </p:sp>
+      <p:sp>
+        <p:nvSpPr>
+          <p:cNvPr id="15" name="Rounded Rectangle 14"/>
+          <p:cNvSpPr/>
+          <p:nvPr/>
+        </p:nvSpPr>
+        <p:spPr>
+          <a:xfrm>
+            <a:off x="6245352" y="4023360"/>
+            <a:ext cx="2487168" cy="1371600"/>
+          </a:xfrm>
+          <a:prstGeom prst="roundRect">
+            <a:avLst/>
+          </a:prstGeom>
+          <a:solidFill>
+            <a:srgbClr val="EEF2F8"/>
+          </a:solidFill>
+          <a:ln>
+            <a:solidFill>
+              <a:srgbClr val="2F4B6E"/>
+            </a:solidFill>
+          </a:ln>
+        </p:spPr>
+        <p:style>
+          <a:lnRef idx="1">
+            <a:schemeClr val="accent1"/>
+          </a:lnRef>
+          <a:fillRef idx="3">
+            <a:schemeClr val="accent1"/>
+          </a:fillRef>
+          <a:effectRef idx="2">
+            <a:schemeClr val="accent1"/>
+          </a:effectRef>
+          <a:fontRef idx="minor">
+            <a:schemeClr val="lt1"/>
+          </a:fontRef>
+        </p:style>
+        <p:txBody>
+          <a:bodyPr rtlCol="0" anchor="ctr" wrap="square"/>
+          <a:lstStyle/>
+          <a:p>
+            <a:pPr algn="ctr">
+              <a:defRPr sz="1100" b="1">
+                <a:solidFill>
+                  <a:srgbClr val="2F4B6E"/>
+                </a:solidFill>
+              </a:defRPr>
+            </a:pPr>
+            <a:r>
+              <a:t>Decodificador leve</a:t>
+            </a:r>
+          </a:p>
+          <a:p>
+            <a:pPr algn="ctr">
+              <a:defRPr sz="1000" b="0">
+                <a:solidFill>
+                  <a:srgbClr val="2F4B6E"/>
+                </a:solidFill>
+              </a:defRPr>
+            </a:pPr>
+            <a:r>
+              <a:t>dim 64, 2 blocos</a:t>
+            </a:r>
+          </a:p>
+        </p:txBody>
+      </p:sp>
+      <p:sp>
+        <p:nvSpPr>
+          <p:cNvPr id="16" name="Left Arrow 15"/>
+          <p:cNvSpPr/>
+          <p:nvPr/>
+        </p:nvSpPr>
+        <p:spPr>
+          <a:xfrm>
+            <a:off x="8732520" y="4517136"/>
+            <a:ext cx="329184" cy="384048"/>
+          </a:xfrm>
+          <a:prstGeom prst="leftArrow">
+            <a:avLst/>
+          </a:prstGeom>
+          <a:solidFill>
+            <a:srgbClr val="2F6BB0"/>
+          </a:solidFill>
+          <a:ln>
+            <a:noFill/>
+          </a:ln>
+        </p:spPr>
+        <p:style>
+          <a:lnRef idx="1">
+            <a:schemeClr val="accent1"/>
+          </a:lnRef>
+          <a:fillRef idx="3">
+            <a:schemeClr val="accent1"/>
+          </a:fillRef>
+          <a:effectRef idx="2">
+            <a:schemeClr val="accent1"/>
+          </a:effectRef>
+          <a:fontRef idx="minor">
+            <a:schemeClr val="lt1"/>
+          </a:fontRef>
+        </p:style>
+        <p:txBody>
+          <a:bodyPr rtlCol="0" anchor="ctr"/>
+          <a:lstStyle/>
+          <a:p>
+            <a:pPr algn="ctr"/>
+          </a:p>
+        </p:txBody>
+      </p:sp>
+      <p:sp>
+        <p:nvSpPr>
+          <p:cNvPr id="17" name="Rounded Rectangle 16"/>
+          <p:cNvSpPr/>
+          <p:nvPr/>
+        </p:nvSpPr>
+        <p:spPr>
+          <a:xfrm>
+            <a:off x="9061704" y="4023360"/>
+            <a:ext cx="2487168" cy="1371600"/>
+          </a:xfrm>
+          <a:prstGeom prst="roundRect">
+            <a:avLst/>
+          </a:prstGeom>
+          <a:solidFill>
+            <a:srgbClr val="EEF2F8"/>
+          </a:solidFill>
+          <a:ln>
+            <a:solidFill>
+              <a:srgbClr val="2F4B6E"/>
+            </a:solidFill>
+          </a:ln>
+        </p:spPr>
+        <p:style>
+          <a:lnRef idx="1">
+            <a:schemeClr val="accent1"/>
+          </a:lnRef>
+          <a:fillRef idx="3">
+            <a:schemeClr val="accent1"/>
+          </a:fillRef>
+          <a:effectRef idx="2">
+            <a:schemeClr val="accent1"/>
+          </a:effectRef>
+          <a:fontRef idx="minor">
+            <a:schemeClr val="lt1"/>
+          </a:fontRef>
+        </p:style>
+        <p:txBody>
+          <a:bodyPr rtlCol="0" anchor="ctr" wrap="square"/>
+          <a:lstStyle/>
+          <a:p>
+            <a:pPr algn="ctr">
+              <a:defRPr sz="1100" b="1">
+                <a:solidFill>
+                  <a:srgbClr val="2F4B6E"/>
+                </a:solidFill>
+              </a:defRPr>
+            </a:pPr>
+            <a:r>
+              <a:t>Tokens de máscara</a:t>
+            </a:r>
+          </a:p>
+          <a:p>
+            <a:pPr algn="ctr">
+              <a:defRPr sz="1000" b="0">
+                <a:solidFill>
+                  <a:srgbClr val="2F4B6E"/>
+                </a:solidFill>
+              </a:defRPr>
+            </a:pPr>
+            <a:r>
+              <a:t>com embedding</a:t>
+            </a:r>
+          </a:p>
+          <a:p>
+            <a:pPr algn="ctr">
+              <a:defRPr sz="1000" b="0">
+                <a:solidFill>
+                  <a:srgbClr val="2F4B6E"/>
+                </a:solidFill>
+              </a:defRPr>
+            </a:pPr>
+            <a:r>
+              <a:t>das posições</a:t>
+            </a:r>
+          </a:p>
+        </p:txBody>
+      </p:sp>
+      <p:sp>
+        <p:nvSpPr>
+          <p:cNvPr id="18" name="TextBox 17"/>
+          <p:cNvSpPr txBox="1"/>
+          <p:nvPr/>
+        </p:nvSpPr>
+        <p:spPr>
+          <a:xfrm>
+            <a:off x="612648" y="5715000"/>
+            <a:ext cx="10972800" cy="914400"/>
+          </a:xfrm>
+          <a:prstGeom prst="rect">
+            <a:avLst/>
+          </a:prstGeom>
+          <a:noFill/>
+        </p:spPr>
+        <p:txBody>
+          <a:bodyPr wrap="square">
+            <a:spAutoFit/>
+          </a:bodyPr>
+          <a:lstStyle/>
+          <a:p>
+            <a:pPr>
+              <a:defRPr sz="1300" b="0">
+                <a:latin typeface="Arial"/>
+              </a:defRPr>
+            </a:pPr>
+            <a:r>
+              <a:t>Arquitetura assimétrica: o codificador só vê os patches visíveis e o decoder leve, descartado nas tarefas posteriores de reconhecimento (He et al., 2022)</a:t>
             </a:r>
           </a:p>
         </p:txBody>
@@ -3874,58 +5275,216 @@
           <a:lstStyle/>
           <a:p>
             <a:pPr>
-              <a:defRPr sz="3000"/>
-            </a:pPr>
-            <a:r>
-              <a:t>Nossa implementação</a:t>
-            </a:r>
-          </a:p>
-        </p:txBody>
-      </p:sp>
-      <p:sp>
-        <p:nvSpPr>
-          <p:cNvPr id="3" name="Content Placeholder 2"/>
-          <p:cNvSpPr>
-            <a:spLocks noGrp="1"/>
-          </p:cNvSpPr>
-          <p:nvPr>
-            <p:ph idx="1"/>
-          </p:nvPr>
-        </p:nvSpPr>
-        <p:spPr/>
-        <p:txBody>
-          <a:bodyPr/>
-          <a:lstStyle/>
-          <a:p>
-            <a:pPr>
-              <a:defRPr sz="1700"/>
-            </a:pPr>
-            <a:r>
-              <a:t>MAE próprio em PyTorch puro (sem código de terceiros)</a:t>
-            </a:r>
-          </a:p>
-          <a:p>
-            <a:pPr>
-              <a:defRPr sz="1700"/>
-            </a:pPr>
-            <a:r>
-              <a:t>Máscara aninhada: permutação fixa por imagem com seed 42</a:t>
-            </a:r>
-          </a:p>
-          <a:p>
-            <a:pPr>
-              <a:defRPr sz="1700"/>
-            </a:pPr>
-            <a:r>
-              <a:t>50% oculta 8 patches; 75% oculta 12 (todos os da 50% também)</a:t>
-            </a:r>
-          </a:p>
-          <a:p>
-            <a:pPr>
-              <a:defRPr sz="1700"/>
-            </a:pPr>
-            <a:r>
-              <a:t>Validação contra o oráculo vit-pytorch em testes fora da entrega</a:t>
+              <a:defRPr sz="2800"/>
+            </a:pPr>
+            <a:r>
+              <a:t>Equação da perda e pseudocódigo do treinamento</a:t>
+            </a:r>
+          </a:p>
+        </p:txBody>
+      </p:sp>
+      <p:sp>
+        <p:nvSpPr>
+          <p:cNvPr id="3" name="TextBox 2"/>
+          <p:cNvSpPr txBox="1"/>
+          <p:nvPr/>
+        </p:nvSpPr>
+        <p:spPr>
+          <a:xfrm>
+            <a:off x="612648" y="1371600"/>
+            <a:ext cx="5577840" cy="5120640"/>
+          </a:xfrm>
+          <a:prstGeom prst="rect">
+            <a:avLst/>
+          </a:prstGeom>
+          <a:noFill/>
+        </p:spPr>
+        <p:txBody>
+          <a:bodyPr wrap="square">
+            <a:spAutoFit/>
+          </a:bodyPr>
+          <a:lstStyle/>
+          <a:p>
+            <a:pPr>
+              <a:defRPr sz="1400" b="1">
+                <a:latin typeface="Arial"/>
+              </a:defRPr>
+            </a:pPr>
+            <a:r>
+              <a:t>Equação da perda (erro quadrático médio nos ocultos)</a:t>
+            </a:r>
+          </a:p>
+          <a:p>
+            <a:pPr>
+              <a:defRPr sz="1300" b="1">
+                <a:latin typeface="Arial"/>
+              </a:defRPr>
+            </a:pPr>
+            <a:r>
+              <a:t>L_MAE = (1/|M|) · Σ i ∈ M (1/d) · ||x_i − x̂_i||²</a:t>
+            </a:r>
+          </a:p>
+          <a:p>
+            <a:pPr>
+              <a:defRPr sz="1300" b="0">
+                <a:latin typeface="Arial"/>
+              </a:defRPr>
+            </a:pPr>
+            <a:r>
+              <a:t>x_i: vetor de pixels do patch i (d valores)</a:t>
+            </a:r>
+          </a:p>
+          <a:p>
+            <a:pPr>
+              <a:defRPr sz="1300" b="0">
+                <a:latin typeface="Arial"/>
+              </a:defRPr>
+            </a:pPr>
+            <a:r>
+              <a:t>M: conjunto dos patches mascarados (ocultos)</a:t>
+            </a:r>
+          </a:p>
+          <a:p>
+            <a:pPr>
+              <a:defRPr sz="1300" b="0">
+                <a:latin typeface="Arial"/>
+              </a:defRPr>
+            </a:pPr>
+            <a:r>
+              <a:t>x̂_i: reconstrução do patch i produzida pelo modelo</a:t>
+            </a:r>
+          </a:p>
+          <a:p>
+            <a:pPr>
+              <a:defRPr sz="1300" b="0">
+                <a:latin typeface="Arial"/>
+              </a:defRPr>
+            </a:pPr>
+            <a:r>
+              <a:t>d: número de valores de pixel por patch (192);</a:t>
+            </a:r>
+          </a:p>
+          <a:p>
+            <a:pPr>
+              <a:defRPr sz="1200" b="0">
+                <a:latin typeface="Arial"/>
+              </a:defRPr>
+            </a:pPr>
+            <a:r>
+              <a:t>normaliza pela dimensão da reconstrução</a:t>
+            </a:r>
+          </a:p>
+          <a:p>
+            <a:pPr>
+              <a:defRPr sz="1300" b="1">
+                <a:latin typeface="Arial"/>
+              </a:defRPr>
+            </a:pPr>
+            <a:r>
+              <a:t>média sobre i ∈ M: a perda ignora os patches visíveis</a:t>
+            </a:r>
+          </a:p>
+        </p:txBody>
+      </p:sp>
+      <p:sp>
+        <p:nvSpPr>
+          <p:cNvPr id="4" name="TextBox 3"/>
+          <p:cNvSpPr txBox="1"/>
+          <p:nvPr/>
+        </p:nvSpPr>
+        <p:spPr>
+          <a:xfrm>
+            <a:off x="6400800" y="1371600"/>
+            <a:ext cx="5175504" cy="5120640"/>
+          </a:xfrm>
+          <a:prstGeom prst="rect">
+            <a:avLst/>
+          </a:prstGeom>
+          <a:noFill/>
+        </p:spPr>
+        <p:txBody>
+          <a:bodyPr wrap="square">
+            <a:spAutoFit/>
+          </a:bodyPr>
+          <a:lstStyle/>
+          <a:p>
+            <a:pPr>
+              <a:defRPr sz="1400" b="1">
+                <a:latin typeface="Consolas"/>
+              </a:defRPr>
+            </a:pPr>
+            <a:r>
+              <a:t>Pseudocódigo do laço de treinamento</a:t>
+            </a:r>
+          </a:p>
+          <a:p>
+            <a:pPr>
+              <a:defRPr sz="1200" b="0">
+                <a:latin typeface="Consolas"/>
+              </a:defRPr>
+            </a:pPr>
+            <a:r>
+              <a:t>1. dividir o lote em patches</a:t>
+            </a:r>
+          </a:p>
+          <a:p>
+            <a:pPr>
+              <a:defRPr sz="1200" b="0">
+                <a:latin typeface="Consolas"/>
+              </a:defRPr>
+            </a:pPr>
+            <a:r>
+              <a:t>2. amostrar a máscara na razão r</a:t>
+            </a:r>
+          </a:p>
+          <a:p>
+            <a:pPr>
+              <a:defRPr sz="1200" b="0">
+                <a:latin typeface="Consolas"/>
+              </a:defRPr>
+            </a:pPr>
+            <a:r>
+              <a:t>3. codificar somente os patches visíveis</a:t>
+            </a:r>
+          </a:p>
+          <a:p>
+            <a:pPr>
+              <a:defRPr sz="1200" b="0">
+                <a:latin typeface="Consolas"/>
+              </a:defRPr>
+            </a:pPr>
+            <a:r>
+              <a:t>4. decodificar com tokens de máscara e posições</a:t>
+            </a:r>
+          </a:p>
+          <a:p>
+            <a:pPr>
+              <a:defRPr sz="1200" b="0">
+                <a:latin typeface="Consolas"/>
+              </a:defRPr>
+            </a:pPr>
+            <a:r>
+              <a:t>5. calcular a perda somente nos patches ocultos, normalizada por d</a:t>
+            </a:r>
+          </a:p>
+          <a:p>
+            <a:pPr>
+              <a:defRPr sz="1200" b="0">
+                <a:latin typeface="Consolas"/>
+              </a:defRPr>
+            </a:pPr>
+            <a:r>
+              <a:t>6. atualizar os parâmetros por retropropagação</a:t>
+            </a:r>
+          </a:p>
+          <a:p>
+            <a:pPr>
+              <a:defRPr sz="1200" b="0">
+                <a:latin typeface="Consolas"/>
+              </a:defRPr>
+            </a:pPr>
+            <a:r>
+              <a:t>Repetir por época sobre o conjunto de treino</a:t>
             </a:r>
           </a:p>
         </p:txBody>
@@ -3967,7 +5526,7 @@
               <a:defRPr sz="3000"/>
             </a:pPr>
             <a:r>
-              <a:t>Dados e protocolo</a:t>
+              <a:t>Arquitetura e implementação</a:t>
             </a:r>
           </a:p>
         </p:txBody>
@@ -3991,7 +5550,7 @@
               <a:defRPr sz="1700"/>
             </a:pPr>
             <a:r>
-              <a:t>CIFAR-10 verificado por md5 antes de qualquer uso</a:t>
+              <a:t>Patchify: imagem 32x32x3 em 16 patches de 8x8 (192 valores cada)</a:t>
             </a:r>
           </a:p>
           <a:p>
@@ -3999,7 +5558,7 @@
               <a:defRPr sz="1700"/>
             </a:pPr>
             <a:r>
-              <a:t>Subset seed 42, balanceado: 500 treino, 100 validação e 100 teste por classe</a:t>
+              <a:t>Encoder: somente os patches visíveis entram (ViT dim 128, 4 blocos, 4 heads)</a:t>
             </a:r>
           </a:p>
           <a:p>
@@ -4007,7 +5566,7 @@
               <a:defRPr sz="1700"/>
             </a:pPr>
             <a:r>
-              <a:t>Validação disjunta do treino; teste sai do split oficial e é usado só no fim</a:t>
+              <a:t>Decoder leve: dim 64, 2 blocos, tokens de máscara + embedding posicional</a:t>
             </a:r>
           </a:p>
           <a:p>
@@ -4015,7 +5574,31 @@
               <a:defRPr sz="1700"/>
             </a:pPr>
             <a:r>
-              <a:t>Métrica: MSE nos patches ocultos do conjunto de teste</a:t>
+              <a:t>Saída: 192 valores por patch oculto; o decoder é descartado em tarefas posteriores</a:t>
+            </a:r>
+          </a:p>
+          <a:p>
+            <a:pPr>
+              <a:defRPr sz="1700"/>
+            </a:pPr>
+            <a:r>
+              <a:t>MAE próprio em PyTorch puro (sem código de terceiros), validado contra oráculo fora do pacote</a:t>
+            </a:r>
+          </a:p>
+          <a:p>
+            <a:pPr>
+              <a:defRPr sz="1700"/>
+            </a:pPr>
+            <a:r>
+              <a:t>Máscara aninhada: permutação fixa por imagem com seed 42</a:t>
+            </a:r>
+          </a:p>
+          <a:p>
+            <a:pPr>
+              <a:defRPr sz="1700"/>
+            </a:pPr>
+            <a:r>
+              <a:t>50% oculta 8 patches; 75% oculta 12 (todos os da 50% também)</a:t>
             </a:r>
           </a:p>
         </p:txBody>
@@ -4057,7 +5640,7 @@
               <a:defRPr sz="3000"/>
             </a:pPr>
             <a:r>
-              <a:t>Experimento: máscara de 50% contra 75%</a:t>
+              <a:t>Protocolo e orçamento de treino</a:t>
             </a:r>
           </a:p>
         </p:txBody>
@@ -4081,7 +5664,7 @@
               <a:defRPr sz="1700"/>
             </a:pPr>
             <a:r>
-              <a:t>Mesmo treino nas duas condições: 200 épocas, batch 256, lr 3.0e-04 (AdamW)</a:t>
+              <a:t>CIFAR-10 verificado por md5 antes de qualquer uso</a:t>
             </a:r>
           </a:p>
           <a:p>
@@ -4089,7 +5672,7 @@
               <a:defRPr sz="1700"/>
             </a:pPr>
             <a:r>
-              <a:t>O custo computacional por época diverge: a 75% o encoder vê 4 tokens, a 50% vê 8</a:t>
+              <a:t>Subset seed 42, balanceado: 500 treino, 100 validação e 100 teste por classe</a:t>
             </a:r>
           </a:p>
           <a:p>
@@ -4097,7 +5680,7 @@
               <a:defRPr sz="1700"/>
             </a:pPr>
             <a:r>
-              <a:t>Tempo medido por época na RTX 3050 (na condição 75%): 0.58 s</a:t>
+              <a:t>Validação disjunta do treino; teste sai do split oficial e é usado só no fim</a:t>
             </a:r>
           </a:p>
           <a:p>
@@ -4105,15 +5688,7 @@
               <a:defRPr sz="1700"/>
             </a:pPr>
             <a:r>
-              <a:t>Orçamento previsto: 30 minutos para as duas condições somadas</a:t>
-            </a:r>
-          </a:p>
-          <a:p>
-            <a:pPr>
-              <a:defRPr sz="1700"/>
-            </a:pPr>
-            <a:r>
-              <a:t>MSE de teste nos ocultos: 50% = 0.0608 | 75% = 0.0717</a:t>
+              <a:t>Métrica: MSE nos patches ocultos do conjunto de teste</a:t>
             </a:r>
           </a:p>
         </p:txBody>
@@ -4155,62 +5730,63 @@
               <a:defRPr sz="3000"/>
             </a:pPr>
             <a:r>
-              <a:t>Resultados: reconstruções</a:t>
-            </a:r>
-          </a:p>
-        </p:txBody>
-      </p:sp>
-      <p:pic>
-        <p:nvPicPr>
-          <p:cNvPr id="3" name="Picture 2" descr="reconstrucoes.png"/>
-          <p:cNvPicPr>
-            <a:picLocks noChangeAspect="1"/>
-          </p:cNvPicPr>
-          <p:nvPr/>
-        </p:nvPicPr>
-        <p:blipFill>
-          <a:blip r:embed="rId2"/>
-          <a:stretch>
-            <a:fillRect/>
-          </a:stretch>
-        </p:blipFill>
-        <p:spPr>
-          <a:xfrm>
-            <a:off x="609447" y="2547850"/>
-            <a:ext cx="10972800" cy="2493818"/>
-          </a:xfrm>
-          <a:prstGeom prst="rect">
-            <a:avLst/>
-          </a:prstGeom>
-        </p:spPr>
-      </p:pic>
-      <p:sp>
-        <p:nvSpPr>
-          <p:cNvPr id="4" name="TextBox 3"/>
-          <p:cNvSpPr txBox="1"/>
-          <p:nvPr/>
-        </p:nvSpPr>
-        <p:spPr>
-          <a:xfrm>
-            <a:off x="612648" y="6355080"/>
-            <a:ext cx="10972800" cy="411480"/>
-          </a:xfrm>
-          <a:prstGeom prst="rect">
-            <a:avLst/>
-          </a:prstGeom>
-          <a:noFill/>
-        </p:spPr>
-        <p:txBody>
-          <a:bodyPr wrap="none">
-            <a:spAutoFit/>
-          </a:bodyPr>
-          <a:lstStyle/>
-          <a:p>
-            <a:pPr>
-              <a:defRPr sz="1400"/>
-            </a:pPr>
-            <a:r>
-              <a:t>8 imagens fixas do teste (seed 42): original, mascarada e reconstrução por condição</a:t>
+              <a:t>Experimento: máscara de 50% contra 75%</a:t>
+            </a:r>
+          </a:p>
+        </p:txBody>
+      </p:sp>
+      <p:sp>
+        <p:nvSpPr>
+          <p:cNvPr id="3" name="Content Placeholder 2"/>
+          <p:cNvSpPr>
+            <a:spLocks noGrp="1"/>
+          </p:cNvSpPr>
+          <p:nvPr>
+            <p:ph idx="1"/>
+          </p:nvPr>
+        </p:nvSpPr>
+        <p:spPr/>
+        <p:txBody>
+          <a:bodyPr/>
+          <a:lstStyle/>
+          <a:p>
+            <a:pPr>
+              <a:defRPr sz="1700"/>
+            </a:pPr>
+            <a:r>
+              <a:t>Mesmo treino nas duas condições: 200 épocas, batch 256, lr 3.0e-04 (AdamW)</a:t>
+            </a:r>
+          </a:p>
+          <a:p>
+            <a:pPr>
+              <a:defRPr sz="1700"/>
+            </a:pPr>
+            <a:r>
+              <a:t>O custo computacional por época diverge: a 75% o encoder vê 4 tokens, a 50% vê 8</a:t>
+            </a:r>
+          </a:p>
+          <a:p>
+            <a:pPr>
+              <a:defRPr sz="1700"/>
+            </a:pPr>
+            <a:r>
+              <a:t>Tempo medido por época (na condição 75%): 0.58 s</a:t>
+            </a:r>
+          </a:p>
+          <a:p>
+            <a:pPr>
+              <a:defRPr sz="1700"/>
+            </a:pPr>
+            <a:r>
+              <a:t>Orçamento previsto: 30 minutos para as duas condições somadas</a:t>
+            </a:r>
+          </a:p>
+          <a:p>
+            <a:pPr>
+              <a:defRPr sz="1700"/>
+            </a:pPr>
+            <a:r>
+              <a:t>MSE de teste nos ocultos: 50% = 0.0608 | 75% = 0.0717</a:t>
             </a:r>
           </a:p>
         </p:txBody>

</xml_diff>

<commit_message>
feat(mesclar-apresentacoes): apresentação fundida em 12 slides com material do colega e segundo experimento
Fusão das duas apresentações em 12 slides com abertura da ideia-chave.
Tabela comparativa BERT × MAE × SimMIM, diagrama de 8 etapas,
equação e pseudocódigo do mecanismo masked autoencoding.
Experimento próprio CIFAR-10 com taxas 50 e 75 (semente 42)
e experimento complementar ViT-MAE de 25 a 90 com três imagens
creditadas e MSEs 0,0476 / 0,1403 / 0,3117.
Aplicações por domínio, pos-MAE e downstream, referências
completas e zip de entrega com md5.
</commit_message>
<xml_diff>
--- a/slides/seminario_masked_modeling.pptx
+++ b/slides/seminario_masked_modeling.pptx
@@ -3192,154 +3192,71 @@
               <a:defRPr sz="3000"/>
             </a:pPr>
             <a:r>
-              <a:t>Resultados: reconstruções e curva de perda</a:t>
-            </a:r>
-          </a:p>
-        </p:txBody>
-      </p:sp>
-      <p:sp>
-        <p:nvSpPr>
-          <p:cNvPr id="3" name="TextBox 2"/>
-          <p:cNvSpPr txBox="1"/>
-          <p:nvPr/>
-        </p:nvSpPr>
-        <p:spPr>
-          <a:xfrm>
-            <a:off x="612648" y="1325880"/>
-            <a:ext cx="10972800" cy="310896"/>
-          </a:xfrm>
-          <a:prstGeom prst="rect">
-            <a:avLst/>
-          </a:prstGeom>
-          <a:noFill/>
-        </p:spPr>
-        <p:txBody>
-          <a:bodyPr wrap="square">
-            <a:spAutoFit/>
-          </a:bodyPr>
-          <a:lstStyle/>
-          <a:p>
-            <a:pPr>
-              <a:defRPr sz="1300" b="1">
-                <a:latin typeface="Arial"/>
-              </a:defRPr>
-            </a:pPr>
-            <a:r>
-              <a:t>Reconstruções: 8 imagens fixas do teste (seed 42)</a:t>
-            </a:r>
-          </a:p>
-        </p:txBody>
-      </p:sp>
-      <p:pic>
-        <p:nvPicPr>
-          <p:cNvPr id="4" name="Picture 3" descr="reconstrucoes.png"/>
-          <p:cNvPicPr>
-            <a:picLocks noChangeAspect="1"/>
-          </p:cNvPicPr>
-          <p:nvPr/>
-        </p:nvPicPr>
-        <p:blipFill>
-          <a:blip r:embed="rId2"/>
-          <a:stretch>
-            <a:fillRect/>
-          </a:stretch>
-        </p:blipFill>
-        <p:spPr>
-          <a:xfrm>
-            <a:off x="1295247" y="1876182"/>
-            <a:ext cx="9601200" cy="2182090"/>
-          </a:xfrm>
-          <a:prstGeom prst="rect">
-            <a:avLst/>
-          </a:prstGeom>
-        </p:spPr>
-      </p:pic>
-      <p:sp>
-        <p:nvSpPr>
-          <p:cNvPr id="5" name="TextBox 4"/>
-          <p:cNvSpPr txBox="1"/>
-          <p:nvPr/>
-        </p:nvSpPr>
-        <p:spPr>
-          <a:xfrm>
-            <a:off x="612648" y="4251959"/>
-            <a:ext cx="10972800" cy="310896"/>
-          </a:xfrm>
-          <a:prstGeom prst="rect">
-            <a:avLst/>
-          </a:prstGeom>
-          <a:noFill/>
-        </p:spPr>
-        <p:txBody>
-          <a:bodyPr wrap="square">
-            <a:spAutoFit/>
-          </a:bodyPr>
-          <a:lstStyle/>
-          <a:p>
-            <a:pPr>
-              <a:defRPr sz="1300" b="1">
-                <a:latin typeface="Arial"/>
-              </a:defRPr>
-            </a:pPr>
-            <a:r>
-              <a:t>Curva de perda de validação: MSE nos patches ocultos por época</a:t>
-            </a:r>
-          </a:p>
-        </p:txBody>
-      </p:sp>
-      <p:pic>
-        <p:nvPicPr>
-          <p:cNvPr id="6" name="Picture 5" descr="curva_perda.png"/>
-          <p:cNvPicPr>
-            <a:picLocks noChangeAspect="1"/>
-          </p:cNvPicPr>
-          <p:nvPr/>
-        </p:nvPicPr>
-        <p:blipFill>
-          <a:blip r:embed="rId3"/>
-          <a:stretch>
-            <a:fillRect/>
-          </a:stretch>
-        </p:blipFill>
-        <p:spPr>
-          <a:xfrm>
-            <a:off x="4669383" y="4590288"/>
-            <a:ext cx="2852927" cy="1783080"/>
-          </a:xfrm>
-          <a:prstGeom prst="rect">
-            <a:avLst/>
-          </a:prstGeom>
-        </p:spPr>
-      </p:pic>
-      <p:sp>
-        <p:nvSpPr>
-          <p:cNvPr id="7" name="TextBox 6"/>
-          <p:cNvSpPr txBox="1"/>
-          <p:nvPr/>
-        </p:nvSpPr>
-        <p:spPr>
-          <a:xfrm>
-            <a:off x="612648" y="6400800"/>
-            <a:ext cx="10972800" cy="384048"/>
-          </a:xfrm>
-          <a:prstGeom prst="rect">
-            <a:avLst/>
-          </a:prstGeom>
-          <a:noFill/>
-        </p:spPr>
-        <p:txBody>
-          <a:bodyPr wrap="square">
-            <a:spAutoFit/>
-          </a:bodyPr>
-          <a:lstStyle/>
-          <a:p>
-            <a:pPr>
-              <a:defRPr sz="1300" b="0">
-                <a:latin typeface="Arial"/>
-              </a:defRPr>
-            </a:pPr>
-            <a:r>
-              <a:t>Esquerda: original, mascarada e reconstrução por condição; direita: as duas condições no mesmo eixo</a:t>
+              <a:t>Pós MAE e tarefas downstream (colega)</a:t>
+            </a:r>
+          </a:p>
+        </p:txBody>
+      </p:sp>
+      <p:sp>
+        <p:nvSpPr>
+          <p:cNvPr id="3" name="Content Placeholder 2"/>
+          <p:cNvSpPr>
+            <a:spLocks noGrp="1"/>
+          </p:cNvSpPr>
+          <p:nvPr>
+            <p:ph idx="1"/>
+          </p:nvPr>
+        </p:nvSpPr>
+        <p:spPr/>
+        <p:txBody>
+          <a:bodyPr/>
+          <a:lstStyle/>
+          <a:p>
+            <a:pPr>
+              <a:defRPr sz="1700"/>
+            </a:pPr>
+            <a:r>
+              <a:t>Pré-treinamento: o MAE usa grandes volumes de imagens não rotuladas; parte dos patches é mascarada e o modelo aprende a reconstruir</a:t>
+            </a:r>
+          </a:p>
+          <a:p>
+            <a:pPr>
+              <a:defRPr sz="1700"/>
+            </a:pPr>
+            <a:r>
+              <a:t>Nesse processo, o encoder ViT aprende representações visuais das imagens</a:t>
+            </a:r>
+          </a:p>
+          <a:p>
+            <a:pPr>
+              <a:defRPr sz="1700"/>
+            </a:pPr>
+            <a:r>
+              <a:t>Depois do pré-treinamento, o decoder pode ser descartado: sua função principal era auxiliar a reconstrução</a:t>
+            </a:r>
+          </a:p>
+          <a:p>
+            <a:pPr>
+              <a:defRPr sz="1700"/>
+            </a:pPr>
+            <a:r>
+              <a:t>O encoder pré-treinado é reutilizado em tarefas downstream: classificação de imagens, detecção de objetos e segmentação semântica</a:t>
+            </a:r>
+          </a:p>
+          <a:p>
+            <a:pPr>
+              <a:defRPr sz="1700"/>
+            </a:pPr>
+            <a:r>
+              <a:t>Uso do encoder: extrator de características ou pesos ajustados por fine-tuning para a nova tarefa</a:t>
+            </a:r>
+          </a:p>
+          <a:p>
+            <a:pPr>
+              <a:defRPr sz="1700"/>
+            </a:pPr>
+            <a:r>
+              <a:t>Eco do nosso diagrama: o decoder leve sai e o encoder pesado fica</a:t>
             </a:r>
           </a:p>
         </p:txBody>
@@ -3381,7 +3298,7 @@
               <a:defRPr sz="3000"/>
             </a:pPr>
             <a:r>
-              <a:t>Resultados, críticas e próximos passos</a:t>
+              <a:t>Conclusões</a:t>
             </a:r>
           </a:p>
         </p:txBody>
@@ -3405,7 +3322,7 @@
               <a:defRPr sz="1700"/>
             </a:pPr>
             <a:r>
-              <a:t>75% oculta mais e é mais difícil: MSE 0.0717 contra 0.0608 a 50% (+17.8%)</a:t>
+              <a:t>Reconstruir o que foi escondido não é o objetivo final: é o mecanismo para o modelo aprender boas representações</a:t>
             </a:r>
           </a:p>
           <a:p>
@@ -3413,7 +3330,7 @@
               <a:defRPr sz="1700"/>
             </a:pPr>
             <a:r>
-              <a:t>Épocas, batch e lr igualados; a computação por época diverge (4 contra 8 tokens no encoder)</a:t>
+              <a:t>O mascaramento aproveita dados não rotulados, em texto (BERT) e em imagens (MAE)</a:t>
             </a:r>
           </a:p>
           <a:p>
@@ -3421,7 +3338,7 @@
               <a:defRPr sz="1700"/>
             </a:pPr>
             <a:r>
-              <a:t>Máscara aninhada isola o efeito da taxa: os patches ocultos a 50% também estão a 75%</a:t>
+              <a:t>No experimento próprio, 75% mascarado errou mais que 50%: nesta configuração, mascarar mais elevou o erro (semente única 42)</a:t>
             </a:r>
           </a:p>
           <a:p>
@@ -3429,7 +3346,7 @@
               <a:defRPr sz="1700"/>
             </a:pPr>
             <a:r>
-              <a:t>Evidência desta configuração: semente única 42, teste fixo de 1.000 imagens e máscara aninhada</a:t>
+              <a:t>No experimento do colega com MAE pré-treinado público, as taxas maiores de mascaramento elevaram o MSE registrado no material dele</a:t>
             </a:r>
           </a:p>
           <a:p>
@@ -3437,7 +3354,7 @@
               <a:defRPr sz="1700"/>
             </a:pPr>
             <a:r>
-              <a:t>Não generalizar: repetir com mais sementes e avaliar downstream antes de concluir</a:t>
+              <a:t>Leitura delimitada: qualidade visual da reconstrução não é prova de representações melhores</a:t>
             </a:r>
           </a:p>
           <a:p>
@@ -3445,23 +3362,7 @@
               <a:defRPr sz="1700"/>
             </a:pPr>
             <a:r>
-              <a:t>Qualidade visual da reconstrução não é prova de representações melhores</a:t>
-            </a:r>
-          </a:p>
-          <a:p>
-            <a:pPr>
-              <a:defRPr sz="1700"/>
-            </a:pPr>
-            <a:r>
-              <a:t>Dataset pequeno e didático: qualidade absoluta menor que a do paper</a:t>
-            </a:r>
-          </a:p>
-          <a:p>
-            <a:pPr>
-              <a:defRPr sz="1700"/>
-            </a:pPr>
-            <a:r>
-              <a:t>Linear probing e classificação downstream fora do escopo; próximo passo: linear probing em mais sementes</a:t>
+              <a:t>Repetição com mais sementes e avaliação downstream continuam necessárias antes de generalizar</a:t>
             </a:r>
           </a:p>
         </p:txBody>
@@ -3503,7 +3404,7 @@
               <a:defRPr sz="3000"/>
             </a:pPr>
             <a:r>
-              <a:t>Aplicações e referências</a:t>
+              <a:t>Referências</a:t>
             </a:r>
           </a:p>
         </p:txBody>
@@ -3517,7 +3418,7 @@
         <p:spPr>
           <a:xfrm>
             <a:off x="612648" y="1371600"/>
-            <a:ext cx="10972800" cy="2103120"/>
+            <a:ext cx="10972800" cy="5303520"/>
           </a:xfrm>
           <a:prstGeom prst="rect">
             <a:avLst/>
@@ -3531,75 +3432,72 @@
           <a:lstStyle/>
           <a:p>
             <a:pPr>
-              <a:defRPr sz="1500" b="1">
+              <a:defRPr sz="1300" b="0">
                 <a:latin typeface="Arial"/>
               </a:defRPr>
             </a:pPr>
             <a:r>
-              <a:t>Aplicações das representações aprendidas:</a:t>
-            </a:r>
-          </a:p>
-          <a:p>
-            <a:pPr>
-              <a:defRPr sz="1400" b="0">
+              <a:t>Devlin, J.; Chang, M.; Lee, K.; Toutanova, K. (2019). BERT: Pre-training of Deep Bidirectional Transformers for Language Understanding. NAACL-HLT.</a:t>
+            </a:r>
+          </a:p>
+          <a:p>
+            <a:pPr>
+              <a:defRPr sz="1300" b="0">
                 <a:latin typeface="Arial"/>
               </a:defRPr>
             </a:pPr>
             <a:r>
-              <a:t>BERT: compreensão de linguagem (busca, classificação e diálogo)</a:t>
-            </a:r>
-          </a:p>
-          <a:p>
-            <a:pPr>
-              <a:defRPr sz="1400" b="0">
+              <a:t>Dosovitskiy, A. et al. (2021). An Image is Worth 16x16 Words: Transformers for Image Recognition at Scale. ICLR.</a:t>
+            </a:r>
+          </a:p>
+          <a:p>
+            <a:pPr>
+              <a:defRPr sz="1300" b="0">
                 <a:latin typeface="Arial"/>
               </a:defRPr>
             </a:pPr>
             <a:r>
-              <a:t>MAE: classificação, detecção e segmentação de imagens</a:t>
-            </a:r>
-          </a:p>
-          <a:p>
-            <a:pPr>
-              <a:defRPr sz="1400" b="0">
+              <a:t>He, K.; Chen, X.; Xie, S.; Li, Y.; Dollár, P.; Girshick, R. (2022). Masked Autoencoders Are Scalable Vision Learners. CVPR.</a:t>
+            </a:r>
+          </a:p>
+          <a:p>
+            <a:pPr>
+              <a:defRPr sz="1300" b="0">
                 <a:latin typeface="Arial"/>
               </a:defRPr>
             </a:pPr>
             <a:r>
-              <a:t>SimMIM: classificação, detecção e segmentação em imagens</a:t>
-            </a:r>
-          </a:p>
-        </p:txBody>
-      </p:sp>
-      <p:sp>
-        <p:nvSpPr>
-          <p:cNvPr id="4" name="TextBox 3"/>
-          <p:cNvSpPr txBox="1"/>
-          <p:nvPr/>
-        </p:nvSpPr>
-        <p:spPr>
-          <a:xfrm>
-            <a:off x="612648" y="3063240"/>
-            <a:ext cx="10972800" cy="3200400"/>
-          </a:xfrm>
-          <a:prstGeom prst="rect">
-            <a:avLst/>
-          </a:prstGeom>
-          <a:noFill/>
-        </p:spPr>
-        <p:txBody>
-          <a:bodyPr wrap="square">
-            <a:spAutoFit/>
-          </a:bodyPr>
-          <a:lstStyle/>
-          <a:p>
-            <a:pPr>
-              <a:defRPr sz="1500" b="1">
+              <a:t>Bao, H. et al. (2022). BEiT: BERT Pre-Training of Image Transformers. ICLR.</a:t>
+            </a:r>
+          </a:p>
+          <a:p>
+            <a:pPr>
+              <a:defRPr sz="1300" b="0">
                 <a:latin typeface="Arial"/>
               </a:defRPr>
             </a:pPr>
             <a:r>
-              <a:t>Referências:</a:t>
+              <a:t>Xie, Z.; Zhang, Z.; Lin, Y.; Bian, J.; Lin, L.; Zeng, D. (2022). SimMIM: A Simple Framework for Masked Image Modeling. CVPR.</a:t>
+            </a:r>
+          </a:p>
+          <a:p>
+            <a:pPr>
+              <a:defRPr sz="1300" b="0">
+                <a:latin typeface="Arial"/>
+              </a:defRPr>
+            </a:pPr>
+            <a:r>
+              <a:t>Krizhevsky, A.; Nair, V.; Hinton, G. (2009). CIFAR-10 (Canadian Institute for Advanced Research). Fonte dos dados deste trabalho, verificado por md5.</a:t>
+            </a:r>
+          </a:p>
+          <a:p>
+            <a:pPr>
+              <a:defRPr sz="1300" b="0">
+                <a:latin typeface="Arial"/>
+              </a:defRPr>
+            </a:pPr>
+            <a:r>
+              <a:t>Crédito do experimento complementar: material do colega do grupo, com a implementação pública Hugging Face Transformers, ViTMAE, modelo facebook/vit-mae-base (Meta AI).</a:t>
             </a:r>
           </a:p>
           <a:p>
@@ -3609,37 +3507,7 @@
               </a:defRPr>
             </a:pPr>
             <a:r>
-              <a:t>Devlin, J.; Chang, M.; Lee, K.; Toutanova, K. (2019). BERT: Pre-training of Deep Bidirectional Transformers for Language Understanding. NAACL-HLT.</a:t>
-            </a:r>
-          </a:p>
-          <a:p>
-            <a:pPr>
-              <a:defRPr sz="1200" b="0">
-                <a:latin typeface="Arial"/>
-              </a:defRPr>
-            </a:pPr>
-            <a:r>
-              <a:t>He, K.; Chen, X.; Xie, S.; Li, Y.; Dollár, P.; Girshick, R. (2022). Masked Autoencoders Are Scalable Vision Learners. CVPR.</a:t>
-            </a:r>
-          </a:p>
-          <a:p>
-            <a:pPr>
-              <a:defRPr sz="1200" b="0">
-                <a:latin typeface="Arial"/>
-              </a:defRPr>
-            </a:pPr>
-            <a:r>
-              <a:t>Xie, Z.; Zhang, Z.; Lin, Y.; Bian, J.; Lin, L.; Zeng, D. (2022). SimMIM: A Simple Framework for Masked Image Modeling. CVPR.</a:t>
-            </a:r>
-          </a:p>
-          <a:p>
-            <a:pPr>
-              <a:defRPr sz="1200" b="0">
-                <a:latin typeface="Arial"/>
-              </a:defRPr>
-            </a:pPr>
-            <a:r>
-              <a:t>Krizhevsky, A.; Nair, V.; Hinton, G. (2009). CIFAR-10 (Canadian Institute for Advanced Research). Fonte dos dados, verificado por md5.</a:t>
+              <a:t>Código do experimento do colega: https://colab.research.google.com/drive/11BkUg8lzF079vWErYh5plimEVcF16gXN</a:t>
             </a:r>
           </a:p>
         </p:txBody>
@@ -3681,7 +3549,7 @@
               <a:defRPr sz="3000"/>
             </a:pPr>
             <a:r>
-              <a:t>Roteiro</a:t>
+              <a:t>O que é Masked Modeling</a:t>
             </a:r>
           </a:p>
         </p:txBody>
@@ -3705,7 +3573,7 @@
               <a:defRPr sz="1700"/>
             </a:pPr>
             <a:r>
-              <a:t>O problema: aprender representações com conteúdo incompleto</a:t>
+              <a:t>Estratégia de aprendizado em que parte dos dados de entrada é propositalmente ocultada (mascarada)</a:t>
             </a:r>
           </a:p>
           <a:p>
@@ -3713,7 +3581,7 @@
               <a:defRPr sz="1700"/>
             </a:pPr>
             <a:r>
-              <a:t>Panorama: BERT, MAE e SimMIM</a:t>
+              <a:t>O modelo é treinado para prever ou reconstruir a informação ausente</a:t>
             </a:r>
           </a:p>
           <a:p>
@@ -3721,7 +3589,7 @@
               <a:defRPr sz="1700"/>
             </a:pPr>
             <a:r>
-              <a:t>Fluxo do MAE: diagrama, equação da perda e pseudocódigo</a:t>
+              <a:t>Ideia-chave (material do colega): o próprio dado fornece a supervisão</a:t>
             </a:r>
           </a:p>
           <a:p>
@@ -3729,7 +3597,7 @@
               <a:defRPr sz="1700"/>
             </a:pPr>
             <a:r>
-              <a:t>Arquitetura e nossa implementação</a:t>
+              <a:t>A parte original funciona como referência para verificar o que o modelo previu ou reconstruiu</a:t>
             </a:r>
           </a:p>
           <a:p>
@@ -3737,7 +3605,7 @@
               <a:defRPr sz="1700"/>
             </a:pPr>
             <a:r>
-              <a:t>Protocolo e orçamento de treino</a:t>
+              <a:t>Quatro etapas: ocultar uma parte da entrada, usar o visível como contexto,</a:t>
             </a:r>
           </a:p>
           <a:p>
@@ -3745,23 +3613,7 @@
               <a:defRPr sz="1700"/>
             </a:pPr>
             <a:r>
-              <a:t>Experimento: máscara de 50% contra 75%</a:t>
-            </a:r>
-          </a:p>
-          <a:p>
-            <a:pPr>
-              <a:defRPr sz="1700"/>
-            </a:pPr>
-            <a:r>
-              <a:t>Resultados, críticas e próximos passos</a:t>
-            </a:r>
-          </a:p>
-          <a:p>
-            <a:pPr>
-              <a:defRPr sz="1700"/>
-            </a:pPr>
-            <a:r>
-              <a:t>Aplicações e referências</a:t>
+              <a:t>prever ou reconstruir o conteúdo mascarado e aprender representações úteis dos dados</a:t>
             </a:r>
           </a:p>
         </p:txBody>
@@ -3803,7 +3655,7 @@
               <a:defRPr sz="3000"/>
             </a:pPr>
             <a:r>
-              <a:t>O problema</a:t>
+              <a:t>Por que usar: motivações</a:t>
             </a:r>
           </a:p>
         </p:txBody>
@@ -3827,7 +3679,7 @@
               <a:defRPr sz="1700"/>
             </a:pPr>
             <a:r>
-              <a:t>Supervisão cara: rotular milhões de imagens é custoso</a:t>
+              <a:t>Treino de deep learning depende de grandes quantidades de dados rotulados, caros e demorados de obter</a:t>
             </a:r>
           </a:p>
           <a:p>
@@ -3835,7 +3687,7 @@
               <a:defRPr sz="1700"/>
             </a:pPr>
             <a:r>
-              <a:t>Auto-supervisão: a própria imagem fornece o alvo</a:t>
+              <a:t>Masked modeling aproveita dados não rotulados: a tarefa de aprendizado nasce do próprio dado</a:t>
             </a:r>
           </a:p>
           <a:p>
@@ -3843,7 +3695,7 @@
               <a:defRPr sz="1700"/>
             </a:pPr>
             <a:r>
-              <a:t>BERT: prever palavras ocultas do texto</a:t>
+              <a:t>Reduz a dependência de dados rotulados</a:t>
             </a:r>
           </a:p>
           <a:p>
@@ -3851,7 +3703,7 @@
               <a:defRPr sz="1700"/>
             </a:pPr>
             <a:r>
-              <a:t>Ideia do vision masking: ocultar partes da imagem e reconstruir</a:t>
+              <a:t>Aprende representações relevantes dos dados</a:t>
             </a:r>
           </a:p>
           <a:p>
@@ -3859,7 +3711,15 @@
               <a:defRPr sz="1700"/>
             </a:pPr>
             <a:r>
-              <a:t>A hipótese (He et al., 2022): reconstruir obrigaria o modelo a representar objetos; exigiria avaliação downstream para confirmar</a:t>
+              <a:t>Explora o contexto e as relações entre as partes da entrada</a:t>
+            </a:r>
+          </a:p>
+          <a:p>
+            <a:pPr>
+              <a:defRPr sz="1700"/>
+            </a:pPr>
+            <a:r>
+              <a:t>Serve de pré-treinamento para modelos adaptados a outras tarefas depois</a:t>
             </a:r>
           </a:p>
         </p:txBody>
@@ -5526,83 +5386,316 @@
               <a:defRPr sz="3000"/>
             </a:pPr>
             <a:r>
-              <a:t>Arquitetura e implementação</a:t>
-            </a:r>
-          </a:p>
-        </p:txBody>
-      </p:sp>
-      <p:sp>
-        <p:nvSpPr>
-          <p:cNvPr id="3" name="Content Placeholder 2"/>
-          <p:cNvSpPr>
-            <a:spLocks noGrp="1"/>
-          </p:cNvSpPr>
-          <p:nvPr>
-            <p:ph idx="1"/>
-          </p:nvPr>
-        </p:nvSpPr>
-        <p:spPr/>
-        <p:txBody>
-          <a:bodyPr/>
-          <a:lstStyle/>
-          <a:p>
-            <a:pPr>
-              <a:defRPr sz="1700"/>
-            </a:pPr>
-            <a:r>
-              <a:t>Patchify: imagem 32x32x3 em 16 patches de 8x8 (192 valores cada)</a:t>
-            </a:r>
-          </a:p>
-          <a:p>
-            <a:pPr>
-              <a:defRPr sz="1700"/>
-            </a:pPr>
-            <a:r>
-              <a:t>Encoder: somente os patches visíveis entram (ViT dim 128, 4 blocos, 4 heads)</a:t>
-            </a:r>
-          </a:p>
-          <a:p>
-            <a:pPr>
-              <a:defRPr sz="1700"/>
-            </a:pPr>
-            <a:r>
-              <a:t>Decoder leve: dim 64, 2 blocos, tokens de máscara + embedding posicional</a:t>
-            </a:r>
-          </a:p>
-          <a:p>
-            <a:pPr>
-              <a:defRPr sz="1700"/>
-            </a:pPr>
-            <a:r>
-              <a:t>Saída: 192 valores por patch oculto; o decoder é descartado em tarefas posteriores</a:t>
-            </a:r>
-          </a:p>
-          <a:p>
-            <a:pPr>
-              <a:defRPr sz="1700"/>
-            </a:pPr>
-            <a:r>
-              <a:t>MAE próprio em PyTorch puro (sem código de terceiros), validado contra oráculo fora do pacote</a:t>
-            </a:r>
-          </a:p>
-          <a:p>
-            <a:pPr>
-              <a:defRPr sz="1700"/>
-            </a:pPr>
-            <a:r>
-              <a:t>Máscara aninhada: permutação fixa por imagem com seed 42</a:t>
-            </a:r>
-          </a:p>
-          <a:p>
-            <a:pPr>
-              <a:defRPr sz="1700"/>
-            </a:pPr>
-            <a:r>
-              <a:t>50% oculta 8 patches; 75% oculta 12 (todos os da 50% também)</a:t>
-            </a:r>
-          </a:p>
-        </p:txBody>
-      </p:sp>
+              <a:t>Experimento próprio no CIFAR-10</a:t>
+            </a:r>
+          </a:p>
+        </p:txBody>
+      </p:sp>
+      <p:sp>
+        <p:nvSpPr>
+          <p:cNvPr id="3" name="TextBox 2"/>
+          <p:cNvSpPr txBox="1"/>
+          <p:nvPr/>
+        </p:nvSpPr>
+        <p:spPr>
+          <a:xfrm>
+            <a:off x="612648" y="1325880"/>
+            <a:ext cx="6309360" cy="2743200"/>
+          </a:xfrm>
+          <a:prstGeom prst="rect">
+            <a:avLst/>
+          </a:prstGeom>
+          <a:noFill/>
+        </p:spPr>
+        <p:txBody>
+          <a:bodyPr wrap="square">
+            <a:spAutoFit/>
+          </a:bodyPr>
+          <a:lstStyle/>
+          <a:p>
+            <a:pPr>
+              <a:defRPr sz="1400" b="0">
+                <a:latin typeface="Arial"/>
+              </a:defRPr>
+            </a:pPr>
+            <a:r>
+              <a:t>MAE próprio, escrito do zero em PyTorch puro (sem código de terceiros)</a:t>
+            </a:r>
+          </a:p>
+          <a:p>
+            <a:pPr>
+              <a:defRPr sz="1400" b="0">
+                <a:latin typeface="Arial"/>
+              </a:defRPr>
+            </a:pPr>
+            <a:r>
+              <a:t>Mesmo protocolo nas duas condições: 200 épocas, batch 256, lr 3.0e-04 (AdamW)</a:t>
+            </a:r>
+          </a:p>
+          <a:p>
+            <a:pPr>
+              <a:defRPr sz="1400" b="0">
+                <a:latin typeface="Arial"/>
+              </a:defRPr>
+            </a:pPr>
+            <a:r>
+              <a:t>Semente única 42; subset balanceado verificado por md5; teste fixo de 1.000 imagens</a:t>
+            </a:r>
+          </a:p>
+          <a:p>
+            <a:pPr>
+              <a:defRPr sz="1400" b="0">
+                <a:latin typeface="Arial"/>
+              </a:defRPr>
+            </a:pPr>
+            <a:r>
+              <a:t>Máscara aninhada: os patches ocultos a 50% também estão a 75%, isolando o efeito da taxa</a:t>
+            </a:r>
+          </a:p>
+          <a:p>
+            <a:pPr>
+              <a:defRPr sz="1400" b="0">
+                <a:latin typeface="Arial"/>
+              </a:defRPr>
+            </a:pPr>
+            <a:r>
+              <a:t>50% oculta 8 dos 16 patches; 75% oculta 12 (custo por época diverge: 8 contra 4 tokens no encoder)</a:t>
+            </a:r>
+          </a:p>
+          <a:p>
+            <a:pPr>
+              <a:defRPr sz="1400" b="0">
+                <a:latin typeface="Arial"/>
+              </a:defRPr>
+            </a:pPr>
+            <a:r>
+              <a:t>MSE de 75% é +17.8% maior que o de 50%: nesta configuração, mascarar mais elevou o erro</a:t>
+            </a:r>
+          </a:p>
+          <a:p>
+            <a:pPr>
+              <a:defRPr sz="1400" b="0">
+                <a:latin typeface="Arial"/>
+              </a:defRPr>
+            </a:pPr>
+            <a:r>
+              <a:t>Delimitação: evidência desta configuração, semente única; repetir com mais sementes e avaliar downstream antes de generalizar</a:t>
+            </a:r>
+          </a:p>
+        </p:txBody>
+      </p:sp>
+      <p:graphicFrame>
+        <p:nvGraphicFramePr>
+          <p:cNvPr id="4" name="Table 3"/>
+          <p:cNvGraphicFramePr>
+            <a:graphicFrameLocks noGrp="1"/>
+          </p:cNvGraphicFramePr>
+          <p:nvPr/>
+        </p:nvGraphicFramePr>
+        <p:xfrm>
+          <a:off x="7315200" y="1463040"/>
+          <a:ext cx="4114800" cy="1508760"/>
+        </p:xfrm>
+        <a:graphic>
+          <a:graphicData uri="http://schemas.openxmlformats.org/drawingml/2006/table">
+            <a:tbl>
+              <a:tblPr firstRow="1" bandRow="1">
+                <a:tableStyleId>{5C22544A-7EE6-4342-B048-85BDC9FD1C3A}</a:tableStyleId>
+              </a:tblPr>
+              <a:tblGrid>
+                <a:gridCol w="2057400"/>
+                <a:gridCol w="2057400"/>
+              </a:tblGrid>
+              <a:tr h="502920">
+                <a:tc>
+                  <a:txBody>
+                    <a:bodyPr/>
+                    <a:lstStyle/>
+                    <a:p>
+                      <a:pPr>
+                        <a:defRPr sz="1300" b="1"/>
+                      </a:pPr>
+                      <a:r>
+                        <a:t>Condição</a:t>
+                      </a:r>
+                    </a:p>
+                  </a:txBody>
+                  <a:tcPr/>
+                </a:tc>
+                <a:tc>
+                  <a:txBody>
+                    <a:bodyPr/>
+                    <a:lstStyle/>
+                    <a:p>
+                      <a:pPr>
+                        <a:defRPr sz="1300" b="1"/>
+                      </a:pPr>
+                      <a:r>
+                        <a:t>MSE de teste (ocultos)</a:t>
+                      </a:r>
+                    </a:p>
+                  </a:txBody>
+                  <a:tcPr/>
+                </a:tc>
+              </a:tr>
+              <a:tr h="502920">
+                <a:tc>
+                  <a:txBody>
+                    <a:bodyPr/>
+                    <a:lstStyle/>
+                    <a:p>
+                      <a:pPr>
+                        <a:defRPr sz="1300" b="1"/>
+                      </a:pPr>
+                      <a:r>
+                        <a:t>Máscara 50%</a:t>
+                      </a:r>
+                    </a:p>
+                  </a:txBody>
+                  <a:tcPr/>
+                </a:tc>
+                <a:tc>
+                  <a:txBody>
+                    <a:bodyPr/>
+                    <a:lstStyle/>
+                    <a:p>
+                      <a:pPr>
+                        <a:defRPr sz="1300" b="0"/>
+                      </a:pPr>
+                      <a:r>
+                        <a:t>0.0608</a:t>
+                      </a:r>
+                    </a:p>
+                  </a:txBody>
+                  <a:tcPr/>
+                </a:tc>
+              </a:tr>
+              <a:tr h="502920">
+                <a:tc>
+                  <a:txBody>
+                    <a:bodyPr/>
+                    <a:lstStyle/>
+                    <a:p>
+                      <a:pPr>
+                        <a:defRPr sz="1300" b="1"/>
+                      </a:pPr>
+                      <a:r>
+                        <a:t>Máscara 75%</a:t>
+                      </a:r>
+                    </a:p>
+                  </a:txBody>
+                  <a:tcPr/>
+                </a:tc>
+                <a:tc>
+                  <a:txBody>
+                    <a:bodyPr/>
+                    <a:lstStyle/>
+                    <a:p>
+                      <a:pPr>
+                        <a:defRPr sz="1300" b="0"/>
+                      </a:pPr>
+                      <a:r>
+                        <a:t>0.0717</a:t>
+                      </a:r>
+                    </a:p>
+                  </a:txBody>
+                  <a:tcPr/>
+                </a:tc>
+              </a:tr>
+            </a:tbl>
+          </a:graphicData>
+        </a:graphic>
+      </p:graphicFrame>
+      <p:sp>
+        <p:nvSpPr>
+          <p:cNvPr id="5" name="TextBox 4"/>
+          <p:cNvSpPr txBox="1"/>
+          <p:nvPr/>
+        </p:nvSpPr>
+        <p:spPr>
+          <a:xfrm>
+            <a:off x="7315200" y="3063240"/>
+            <a:ext cx="4114800" cy="457200"/>
+          </a:xfrm>
+          <a:prstGeom prst="rect">
+            <a:avLst/>
+          </a:prstGeom>
+          <a:noFill/>
+        </p:spPr>
+        <p:txBody>
+          <a:bodyPr wrap="square">
+            <a:spAutoFit/>
+          </a:bodyPr>
+          <a:lstStyle/>
+          <a:p>
+            <a:pPr>
+              <a:defRPr sz="1100" b="0">
+                <a:latin typeface="Arial"/>
+              </a:defRPr>
+            </a:pPr>
+            <a:r>
+              <a:t>Fonte: resultados/metricas.csv (semente 42)</a:t>
+            </a:r>
+          </a:p>
+        </p:txBody>
+      </p:sp>
+      <p:sp>
+        <p:nvSpPr>
+          <p:cNvPr id="6" name="TextBox 5"/>
+          <p:cNvSpPr txBox="1"/>
+          <p:nvPr/>
+        </p:nvSpPr>
+        <p:spPr>
+          <a:xfrm>
+            <a:off x="612648" y="4224528"/>
+            <a:ext cx="10972800" cy="274320"/>
+          </a:xfrm>
+          <a:prstGeom prst="rect">
+            <a:avLst/>
+          </a:prstGeom>
+          <a:noFill/>
+        </p:spPr>
+        <p:txBody>
+          <a:bodyPr wrap="square">
+            <a:spAutoFit/>
+          </a:bodyPr>
+          <a:lstStyle/>
+          <a:p>
+            <a:pPr>
+              <a:defRPr sz="1200" b="1">
+                <a:latin typeface="Arial"/>
+              </a:defRPr>
+            </a:pPr>
+            <a:r>
+              <a:t>Reconstruções: 8 imagens fixas do teste (semente 42)</a:t>
+            </a:r>
+          </a:p>
+        </p:txBody>
+      </p:sp>
+      <p:pic>
+        <p:nvPicPr>
+          <p:cNvPr id="7" name="Picture 6" descr="reconstrucoes.png"/>
+          <p:cNvPicPr>
+            <a:picLocks noChangeAspect="1"/>
+          </p:cNvPicPr>
+          <p:nvPr/>
+        </p:nvPicPr>
+        <p:blipFill>
+          <a:blip r:embed="rId2"/>
+          <a:stretch>
+            <a:fillRect/>
+          </a:stretch>
+        </p:blipFill>
+        <p:spPr>
+          <a:xfrm>
+            <a:off x="1252728" y="4526280"/>
+            <a:ext cx="9656063" cy="2194560"/>
+          </a:xfrm>
+          <a:prstGeom prst="rect">
+            <a:avLst/>
+          </a:prstGeom>
+        </p:spPr>
+      </p:pic>
     </p:spTree>
   </p:cSld>
   <p:clrMapOvr>
@@ -5640,55 +5733,281 @@
               <a:defRPr sz="3000"/>
             </a:pPr>
             <a:r>
-              <a:t>Protocolo e orçamento de treino</a:t>
-            </a:r>
-          </a:p>
-        </p:txBody>
-      </p:sp>
-      <p:sp>
-        <p:nvSpPr>
-          <p:cNvPr id="3" name="Content Placeholder 2"/>
-          <p:cNvSpPr>
-            <a:spLocks noGrp="1"/>
-          </p:cNvSpPr>
-          <p:nvPr>
-            <p:ph idx="1"/>
-          </p:nvPr>
-        </p:nvSpPr>
-        <p:spPr/>
-        <p:txBody>
-          <a:bodyPr/>
-          <a:lstStyle/>
-          <a:p>
-            <a:pPr>
-              <a:defRPr sz="1700"/>
-            </a:pPr>
-            <a:r>
-              <a:t>CIFAR-10 verificado por md5 antes de qualquer uso</a:t>
-            </a:r>
-          </a:p>
-          <a:p>
-            <a:pPr>
-              <a:defRPr sz="1700"/>
-            </a:pPr>
-            <a:r>
-              <a:t>Subset seed 42, balanceado: 500 treino, 100 validação e 100 teste por classe</a:t>
-            </a:r>
-          </a:p>
-          <a:p>
-            <a:pPr>
-              <a:defRPr sz="1700"/>
-            </a:pPr>
-            <a:r>
-              <a:t>Validação disjunta do treino; teste sai do split oficial e é usado só no fim</a:t>
-            </a:r>
-          </a:p>
-          <a:p>
-            <a:pPr>
-              <a:defRPr sz="1700"/>
-            </a:pPr>
-            <a:r>
-              <a:t>Métrica: MSE nos patches ocultos do conjunto de teste</a:t>
+              <a:t>Experimento complementar: ViT-MAE</a:t>
+            </a:r>
+          </a:p>
+        </p:txBody>
+      </p:sp>
+      <p:pic>
+        <p:nvPicPr>
+          <p:cNvPr id="3" name="Picture 2" descr="vitmae-fluxo-experimento.png"/>
+          <p:cNvPicPr>
+            <a:picLocks noChangeAspect="1"/>
+          </p:cNvPicPr>
+          <p:nvPr/>
+        </p:nvPicPr>
+        <p:blipFill>
+          <a:blip r:embed="rId2"/>
+          <a:stretch>
+            <a:fillRect/>
+          </a:stretch>
+        </p:blipFill>
+        <p:spPr>
+          <a:xfrm>
+            <a:off x="798437" y="1143000"/>
+            <a:ext cx="10601221" cy="2057400"/>
+          </a:xfrm>
+          <a:prstGeom prst="rect">
+            <a:avLst/>
+          </a:prstGeom>
+        </p:spPr>
+      </p:pic>
+      <p:sp>
+        <p:nvSpPr>
+          <p:cNvPr id="4" name="TextBox 3"/>
+          <p:cNvSpPr txBox="1"/>
+          <p:nvPr/>
+        </p:nvSpPr>
+        <p:spPr>
+          <a:xfrm>
+            <a:off x="612648" y="3273552"/>
+            <a:ext cx="2194560" cy="402336"/>
+          </a:xfrm>
+          <a:prstGeom prst="rect">
+            <a:avLst/>
+          </a:prstGeom>
+          <a:noFill/>
+        </p:spPr>
+        <p:txBody>
+          <a:bodyPr wrap="square">
+            <a:spAutoFit/>
+          </a:bodyPr>
+          <a:lstStyle/>
+          <a:p>
+            <a:pPr>
+              <a:defRPr sz="1100" b="1">
+                <a:latin typeface="Arial"/>
+              </a:defRPr>
+            </a:pPr>
+            <a:r>
+              <a:t>Mascarado e reconstruído em cada taxa</a:t>
+            </a:r>
+          </a:p>
+        </p:txBody>
+      </p:sp>
+      <p:sp>
+        <p:nvSpPr>
+          <p:cNvPr id="5" name="TextBox 4"/>
+          <p:cNvSpPr txBox="1"/>
+          <p:nvPr/>
+        </p:nvSpPr>
+        <p:spPr>
+          <a:xfrm>
+            <a:off x="5897880" y="3273552"/>
+            <a:ext cx="3840480" cy="402336"/>
+          </a:xfrm>
+          <a:prstGeom prst="rect">
+            <a:avLst/>
+          </a:prstGeom>
+          <a:noFill/>
+        </p:spPr>
+        <p:txBody>
+          <a:bodyPr wrap="square">
+            <a:spAutoFit/>
+          </a:bodyPr>
+          <a:lstStyle/>
+          <a:p>
+            <a:pPr>
+              <a:defRPr sz="1100" b="1">
+                <a:latin typeface="Arial"/>
+              </a:defRPr>
+            </a:pPr>
+            <a:r>
+              <a:t>Erro de reconstrução por taxa (colega)</a:t>
+            </a:r>
+          </a:p>
+        </p:txBody>
+      </p:sp>
+      <p:sp>
+        <p:nvSpPr>
+          <p:cNvPr id="6" name="TextBox 5"/>
+          <p:cNvSpPr txBox="1"/>
+          <p:nvPr/>
+        </p:nvSpPr>
+        <p:spPr>
+          <a:xfrm>
+            <a:off x="2788920" y="3611880"/>
+            <a:ext cx="3017520" cy="2560320"/>
+          </a:xfrm>
+          <a:prstGeom prst="rect">
+            <a:avLst/>
+          </a:prstGeom>
+          <a:noFill/>
+        </p:spPr>
+        <p:txBody>
+          <a:bodyPr wrap="square">
+            <a:spAutoFit/>
+          </a:bodyPr>
+          <a:lstStyle/>
+          <a:p>
+            <a:pPr>
+              <a:defRPr sz="1200" b="0">
+                <a:latin typeface="Arial"/>
+              </a:defRPr>
+            </a:pPr>
+            <a:r>
+              <a:t>Configuração do material do colega:</a:t>
+            </a:r>
+          </a:p>
+          <a:p>
+            <a:pPr>
+              <a:defRPr sz="1200" b="0">
+                <a:latin typeface="Arial"/>
+              </a:defRPr>
+            </a:pPr>
+            <a:r>
+              <a:t>MAE pré-treinado, arquitetura Vision Transformer (ViT)</a:t>
+            </a:r>
+          </a:p>
+          <a:p>
+            <a:pPr>
+              <a:defRPr sz="1200" b="0">
+                <a:latin typeface="Arial"/>
+              </a:defRPr>
+            </a:pPr>
+            <a:r>
+              <a:t>Entrada de 224x224 pixels, patches de 16x16</a:t>
+            </a:r>
+          </a:p>
+          <a:p>
+            <a:pPr>
+              <a:defRPr sz="1200" b="0">
+                <a:latin typeface="Arial"/>
+              </a:defRPr>
+            </a:pPr>
+            <a:r>
+              <a:t>Taxas avaliadas: 25%, 50%, 75% e 90%</a:t>
+            </a:r>
+          </a:p>
+          <a:p>
+            <a:pPr>
+              <a:defRPr sz="1200" b="0">
+                <a:latin typeface="Arial"/>
+              </a:defRPr>
+            </a:pPr>
+            <a:r>
+              <a:t>MSEs documentados pelo colega:</a:t>
+            </a:r>
+          </a:p>
+          <a:p>
+            <a:pPr>
+              <a:defRPr sz="1200" b="0">
+                <a:latin typeface="Arial"/>
+              </a:defRPr>
+            </a:pPr>
+            <a:r>
+              <a:t>25%: 0,0476 | 75%: 0,1403 | 90%: 0,3117</a:t>
+            </a:r>
+          </a:p>
+          <a:p>
+            <a:pPr>
+              <a:defRPr sz="1200" b="0">
+                <a:latin typeface="Arial"/>
+              </a:defRPr>
+            </a:pPr>
+            <a:r>
+              <a:t>Menos informação visível torna a reconstrução mais desafiadora</a:t>
+            </a:r>
+          </a:p>
+        </p:txBody>
+      </p:sp>
+      <p:pic>
+        <p:nvPicPr>
+          <p:cNvPr id="7" name="Picture 6" descr="vitmae-grade-taxas.png"/>
+          <p:cNvPicPr>
+            <a:picLocks noChangeAspect="1"/>
+          </p:cNvPicPr>
+          <p:nvPr/>
+        </p:nvPicPr>
+        <p:blipFill>
+          <a:blip r:embed="rId3"/>
+          <a:stretch>
+            <a:fillRect/>
+          </a:stretch>
+        </p:blipFill>
+        <p:spPr>
+          <a:xfrm>
+            <a:off x="794535" y="3703320"/>
+            <a:ext cx="1748488" cy="2103120"/>
+          </a:xfrm>
+          <a:prstGeom prst="rect">
+            <a:avLst/>
+          </a:prstGeom>
+        </p:spPr>
+      </p:pic>
+      <p:pic>
+        <p:nvPicPr>
+          <p:cNvPr id="8" name="Picture 7" descr="vitmae-grafico-mse.png"/>
+          <p:cNvPicPr>
+            <a:picLocks noChangeAspect="1"/>
+          </p:cNvPicPr>
+          <p:nvPr/>
+        </p:nvPicPr>
+        <p:blipFill>
+          <a:blip r:embed="rId4"/>
+          <a:stretch>
+            <a:fillRect/>
+          </a:stretch>
+        </p:blipFill>
+        <p:spPr>
+          <a:xfrm>
+            <a:off x="6014596" y="3703320"/>
+            <a:ext cx="3561327" cy="2377440"/>
+          </a:xfrm>
+          <a:prstGeom prst="rect">
+            <a:avLst/>
+          </a:prstGeom>
+        </p:spPr>
+      </p:pic>
+      <p:sp>
+        <p:nvSpPr>
+          <p:cNvPr id="9" name="TextBox 8"/>
+          <p:cNvSpPr txBox="1"/>
+          <p:nvPr/>
+        </p:nvSpPr>
+        <p:spPr>
+          <a:xfrm>
+            <a:off x="612648" y="6217920"/>
+            <a:ext cx="10972800" cy="566928"/>
+          </a:xfrm>
+          <a:prstGeom prst="rect">
+            <a:avLst/>
+          </a:prstGeom>
+          <a:noFill/>
+        </p:spPr>
+        <p:txBody>
+          <a:bodyPr wrap="square">
+            <a:spAutoFit/>
+          </a:bodyPr>
+          <a:lstStyle/>
+          <a:p>
+            <a:pPr>
+              <a:defRPr sz="1100" b="0">
+                <a:latin typeface="Arial"/>
+              </a:defRPr>
+            </a:pPr>
+            <a:r>
+              <a:t>Imagem superior: fluxo do experimento com MAE pré-treinado. Fonte: apresentação do colega do grupo; implementação pública: Hugging Face Transformers, ViTMAE, modelo facebook/vit-mae-base (Meta AI).</a:t>
+            </a:r>
+          </a:p>
+          <a:p>
+            <a:pPr>
+              <a:defRPr sz="1100" b="0">
+                <a:latin typeface="Arial"/>
+              </a:defRPr>
+            </a:pPr>
+            <a:r>
+              <a:t>Código do experimento do colega: https://colab.research.google.com/drive/11BkUg8lzF079vWErYh5plimEVcF16gXN</a:t>
             </a:r>
           </a:p>
         </p:txBody>
@@ -5730,7 +6049,7 @@
               <a:defRPr sz="3000"/>
             </a:pPr>
             <a:r>
-              <a:t>Experimento: máscara de 50% contra 75%</a:t>
+              <a:t>Aplicações por domínio (colega)</a:t>
             </a:r>
           </a:p>
         </p:txBody>
@@ -5754,7 +6073,7 @@
               <a:defRPr sz="1700"/>
             </a:pPr>
             <a:r>
-              <a:t>Mesmo treino nas duas condições: 200 épocas, batch 256, lr 3.0e-04 (AdamW)</a:t>
+              <a:t>Pré-treinar com grandes volumes de dados não rotulados e transferir as representações</a:t>
             </a:r>
           </a:p>
           <a:p>
@@ -5762,7 +6081,7 @@
               <a:defRPr sz="1700"/>
             </a:pPr>
             <a:r>
-              <a:t>O custo computacional por época diverge: a 75% o encoder vê 4 tokens, a 50% vê 8</a:t>
+              <a:t>Visão computacional: classificação, detecção de objetos, segmentação semântica, reconhecimento visual</a:t>
             </a:r>
           </a:p>
           <a:p>
@@ -5770,7 +6089,7 @@
               <a:defRPr sz="1700"/>
             </a:pPr>
             <a:r>
-              <a:t>Tempo medido por época (na condição 75%): 0.58 s</a:t>
+              <a:t>Imagens médicas: radiografias, tomografias e ressonâncias; pré-treinamento sem anotação; extração de características para diagnóstico</a:t>
             </a:r>
           </a:p>
           <a:p>
@@ -5778,7 +6097,7 @@
               <a:defRPr sz="1700"/>
             </a:pPr>
             <a:r>
-              <a:t>Orçamento previsto: 30 minutos para as duas condições somadas</a:t>
+              <a:t>Sensoriamento remoto: uso e cobertura do solo, detecção de mudanças, imagens de satélite, monitoramento ambiental e agrícola</a:t>
             </a:r>
           </a:p>
           <a:p>
@@ -5786,7 +6105,7 @@
               <a:defRPr sz="1700"/>
             </a:pPr>
             <a:r>
-              <a:t>MSE de teste nos ocultos: 50% = 0.0608 | 75% = 0.0717</a:t>
+              <a:t>Outras modalidades: linguagem natural, vídeos, áudio e aprendizado multimodal</a:t>
             </a:r>
           </a:p>
         </p:txBody>

</xml_diff>

<commit_message>
feat(mesclar-apresentacoes): apresentação fundida em 12 slides com material do colega e segundo experimento (#4)
Fusão das duas apresentações em 12 slides com abertura da ideia-chave.
Tabela comparativa BERT × MAE × SimMIM, diagrama de 8 etapas,
equação e pseudocódigo do mecanismo masked autoencoding.
Experimento próprio CIFAR-10 com taxas 50 e 75 (semente 42)
e experimento complementar ViT-MAE de 25 a 90 com três imagens
creditadas e MSEs 0,0476 / 0,1403 / 0,3117.
Aplicações por domínio, pos-MAE e downstream, referências
completas e zip de entrega com md5.
</commit_message>
<xml_diff>
--- a/slides/seminario_masked_modeling.pptx
+++ b/slides/seminario_masked_modeling.pptx
@@ -3192,154 +3192,71 @@
               <a:defRPr sz="3000"/>
             </a:pPr>
             <a:r>
-              <a:t>Resultados: reconstruções e curva de perda</a:t>
-            </a:r>
-          </a:p>
-        </p:txBody>
-      </p:sp>
-      <p:sp>
-        <p:nvSpPr>
-          <p:cNvPr id="3" name="TextBox 2"/>
-          <p:cNvSpPr txBox="1"/>
-          <p:nvPr/>
-        </p:nvSpPr>
-        <p:spPr>
-          <a:xfrm>
-            <a:off x="612648" y="1325880"/>
-            <a:ext cx="10972800" cy="310896"/>
-          </a:xfrm>
-          <a:prstGeom prst="rect">
-            <a:avLst/>
-          </a:prstGeom>
-          <a:noFill/>
-        </p:spPr>
-        <p:txBody>
-          <a:bodyPr wrap="square">
-            <a:spAutoFit/>
-          </a:bodyPr>
-          <a:lstStyle/>
-          <a:p>
-            <a:pPr>
-              <a:defRPr sz="1300" b="1">
-                <a:latin typeface="Arial"/>
-              </a:defRPr>
-            </a:pPr>
-            <a:r>
-              <a:t>Reconstruções: 8 imagens fixas do teste (seed 42)</a:t>
-            </a:r>
-          </a:p>
-        </p:txBody>
-      </p:sp>
-      <p:pic>
-        <p:nvPicPr>
-          <p:cNvPr id="4" name="Picture 3" descr="reconstrucoes.png"/>
-          <p:cNvPicPr>
-            <a:picLocks noChangeAspect="1"/>
-          </p:cNvPicPr>
-          <p:nvPr/>
-        </p:nvPicPr>
-        <p:blipFill>
-          <a:blip r:embed="rId2"/>
-          <a:stretch>
-            <a:fillRect/>
-          </a:stretch>
-        </p:blipFill>
-        <p:spPr>
-          <a:xfrm>
-            <a:off x="1295247" y="1876182"/>
-            <a:ext cx="9601200" cy="2182090"/>
-          </a:xfrm>
-          <a:prstGeom prst="rect">
-            <a:avLst/>
-          </a:prstGeom>
-        </p:spPr>
-      </p:pic>
-      <p:sp>
-        <p:nvSpPr>
-          <p:cNvPr id="5" name="TextBox 4"/>
-          <p:cNvSpPr txBox="1"/>
-          <p:nvPr/>
-        </p:nvSpPr>
-        <p:spPr>
-          <a:xfrm>
-            <a:off x="612648" y="4251959"/>
-            <a:ext cx="10972800" cy="310896"/>
-          </a:xfrm>
-          <a:prstGeom prst="rect">
-            <a:avLst/>
-          </a:prstGeom>
-          <a:noFill/>
-        </p:spPr>
-        <p:txBody>
-          <a:bodyPr wrap="square">
-            <a:spAutoFit/>
-          </a:bodyPr>
-          <a:lstStyle/>
-          <a:p>
-            <a:pPr>
-              <a:defRPr sz="1300" b="1">
-                <a:latin typeface="Arial"/>
-              </a:defRPr>
-            </a:pPr>
-            <a:r>
-              <a:t>Curva de perda de validação: MSE nos patches ocultos por época</a:t>
-            </a:r>
-          </a:p>
-        </p:txBody>
-      </p:sp>
-      <p:pic>
-        <p:nvPicPr>
-          <p:cNvPr id="6" name="Picture 5" descr="curva_perda.png"/>
-          <p:cNvPicPr>
-            <a:picLocks noChangeAspect="1"/>
-          </p:cNvPicPr>
-          <p:nvPr/>
-        </p:nvPicPr>
-        <p:blipFill>
-          <a:blip r:embed="rId3"/>
-          <a:stretch>
-            <a:fillRect/>
-          </a:stretch>
-        </p:blipFill>
-        <p:spPr>
-          <a:xfrm>
-            <a:off x="4669383" y="4590288"/>
-            <a:ext cx="2852927" cy="1783080"/>
-          </a:xfrm>
-          <a:prstGeom prst="rect">
-            <a:avLst/>
-          </a:prstGeom>
-        </p:spPr>
-      </p:pic>
-      <p:sp>
-        <p:nvSpPr>
-          <p:cNvPr id="7" name="TextBox 6"/>
-          <p:cNvSpPr txBox="1"/>
-          <p:nvPr/>
-        </p:nvSpPr>
-        <p:spPr>
-          <a:xfrm>
-            <a:off x="612648" y="6400800"/>
-            <a:ext cx="10972800" cy="384048"/>
-          </a:xfrm>
-          <a:prstGeom prst="rect">
-            <a:avLst/>
-          </a:prstGeom>
-          <a:noFill/>
-        </p:spPr>
-        <p:txBody>
-          <a:bodyPr wrap="square">
-            <a:spAutoFit/>
-          </a:bodyPr>
-          <a:lstStyle/>
-          <a:p>
-            <a:pPr>
-              <a:defRPr sz="1300" b="0">
-                <a:latin typeface="Arial"/>
-              </a:defRPr>
-            </a:pPr>
-            <a:r>
-              <a:t>Esquerda: original, mascarada e reconstrução por condição; direita: as duas condições no mesmo eixo</a:t>
+              <a:t>Pós MAE e tarefas downstream (colega)</a:t>
+            </a:r>
+          </a:p>
+        </p:txBody>
+      </p:sp>
+      <p:sp>
+        <p:nvSpPr>
+          <p:cNvPr id="3" name="Content Placeholder 2"/>
+          <p:cNvSpPr>
+            <a:spLocks noGrp="1"/>
+          </p:cNvSpPr>
+          <p:nvPr>
+            <p:ph idx="1"/>
+          </p:nvPr>
+        </p:nvSpPr>
+        <p:spPr/>
+        <p:txBody>
+          <a:bodyPr/>
+          <a:lstStyle/>
+          <a:p>
+            <a:pPr>
+              <a:defRPr sz="1700"/>
+            </a:pPr>
+            <a:r>
+              <a:t>Pré-treinamento: o MAE usa grandes volumes de imagens não rotuladas; parte dos patches é mascarada e o modelo aprende a reconstruir</a:t>
+            </a:r>
+          </a:p>
+          <a:p>
+            <a:pPr>
+              <a:defRPr sz="1700"/>
+            </a:pPr>
+            <a:r>
+              <a:t>Nesse processo, o encoder ViT aprende representações visuais das imagens</a:t>
+            </a:r>
+          </a:p>
+          <a:p>
+            <a:pPr>
+              <a:defRPr sz="1700"/>
+            </a:pPr>
+            <a:r>
+              <a:t>Depois do pré-treinamento, o decoder pode ser descartado: sua função principal era auxiliar a reconstrução</a:t>
+            </a:r>
+          </a:p>
+          <a:p>
+            <a:pPr>
+              <a:defRPr sz="1700"/>
+            </a:pPr>
+            <a:r>
+              <a:t>O encoder pré-treinado é reutilizado em tarefas downstream: classificação de imagens, detecção de objetos e segmentação semântica</a:t>
+            </a:r>
+          </a:p>
+          <a:p>
+            <a:pPr>
+              <a:defRPr sz="1700"/>
+            </a:pPr>
+            <a:r>
+              <a:t>Uso do encoder: extrator de características ou pesos ajustados por fine-tuning para a nova tarefa</a:t>
+            </a:r>
+          </a:p>
+          <a:p>
+            <a:pPr>
+              <a:defRPr sz="1700"/>
+            </a:pPr>
+            <a:r>
+              <a:t>Eco do nosso diagrama: o decoder leve sai e o encoder pesado fica</a:t>
             </a:r>
           </a:p>
         </p:txBody>
@@ -3381,7 +3298,7 @@
               <a:defRPr sz="3000"/>
             </a:pPr>
             <a:r>
-              <a:t>Resultados, críticas e próximos passos</a:t>
+              <a:t>Conclusões</a:t>
             </a:r>
           </a:p>
         </p:txBody>
@@ -3405,7 +3322,7 @@
               <a:defRPr sz="1700"/>
             </a:pPr>
             <a:r>
-              <a:t>75% oculta mais e é mais difícil: MSE 0.0717 contra 0.0608 a 50% (+17.8%)</a:t>
+              <a:t>Reconstruir o que foi escondido não é o objetivo final: é o mecanismo para o modelo aprender boas representações</a:t>
             </a:r>
           </a:p>
           <a:p>
@@ -3413,7 +3330,7 @@
               <a:defRPr sz="1700"/>
             </a:pPr>
             <a:r>
-              <a:t>Épocas, batch e lr igualados; a computação por época diverge (4 contra 8 tokens no encoder)</a:t>
+              <a:t>O mascaramento aproveita dados não rotulados, em texto (BERT) e em imagens (MAE)</a:t>
             </a:r>
           </a:p>
           <a:p>
@@ -3421,7 +3338,7 @@
               <a:defRPr sz="1700"/>
             </a:pPr>
             <a:r>
-              <a:t>Máscara aninhada isola o efeito da taxa: os patches ocultos a 50% também estão a 75%</a:t>
+              <a:t>No experimento próprio, 75% mascarado errou mais que 50%: nesta configuração, mascarar mais elevou o erro (semente única 42)</a:t>
             </a:r>
           </a:p>
           <a:p>
@@ -3429,7 +3346,7 @@
               <a:defRPr sz="1700"/>
             </a:pPr>
             <a:r>
-              <a:t>Evidência desta configuração: semente única 42, teste fixo de 1.000 imagens e máscara aninhada</a:t>
+              <a:t>No experimento do colega com MAE pré-treinado público, as taxas maiores de mascaramento elevaram o MSE registrado no material dele</a:t>
             </a:r>
           </a:p>
           <a:p>
@@ -3437,7 +3354,7 @@
               <a:defRPr sz="1700"/>
             </a:pPr>
             <a:r>
-              <a:t>Não generalizar: repetir com mais sementes e avaliar downstream antes de concluir</a:t>
+              <a:t>Leitura delimitada: qualidade visual da reconstrução não é prova de representações melhores</a:t>
             </a:r>
           </a:p>
           <a:p>
@@ -3445,23 +3362,7 @@
               <a:defRPr sz="1700"/>
             </a:pPr>
             <a:r>
-              <a:t>Qualidade visual da reconstrução não é prova de representações melhores</a:t>
-            </a:r>
-          </a:p>
-          <a:p>
-            <a:pPr>
-              <a:defRPr sz="1700"/>
-            </a:pPr>
-            <a:r>
-              <a:t>Dataset pequeno e didático: qualidade absoluta menor que a do paper</a:t>
-            </a:r>
-          </a:p>
-          <a:p>
-            <a:pPr>
-              <a:defRPr sz="1700"/>
-            </a:pPr>
-            <a:r>
-              <a:t>Linear probing e classificação downstream fora do escopo; próximo passo: linear probing em mais sementes</a:t>
+              <a:t>Repetição com mais sementes e avaliação downstream continuam necessárias antes de generalizar</a:t>
             </a:r>
           </a:p>
         </p:txBody>
@@ -3503,7 +3404,7 @@
               <a:defRPr sz="3000"/>
             </a:pPr>
             <a:r>
-              <a:t>Aplicações e referências</a:t>
+              <a:t>Referências</a:t>
             </a:r>
           </a:p>
         </p:txBody>
@@ -3517,7 +3418,7 @@
         <p:spPr>
           <a:xfrm>
             <a:off x="612648" y="1371600"/>
-            <a:ext cx="10972800" cy="2103120"/>
+            <a:ext cx="10972800" cy="5303520"/>
           </a:xfrm>
           <a:prstGeom prst="rect">
             <a:avLst/>
@@ -3531,75 +3432,72 @@
           <a:lstStyle/>
           <a:p>
             <a:pPr>
-              <a:defRPr sz="1500" b="1">
+              <a:defRPr sz="1300" b="0">
                 <a:latin typeface="Arial"/>
               </a:defRPr>
             </a:pPr>
             <a:r>
-              <a:t>Aplicações das representações aprendidas:</a:t>
-            </a:r>
-          </a:p>
-          <a:p>
-            <a:pPr>
-              <a:defRPr sz="1400" b="0">
+              <a:t>Devlin, J.; Chang, M.; Lee, K.; Toutanova, K. (2019). BERT: Pre-training of Deep Bidirectional Transformers for Language Understanding. NAACL-HLT.</a:t>
+            </a:r>
+          </a:p>
+          <a:p>
+            <a:pPr>
+              <a:defRPr sz="1300" b="0">
                 <a:latin typeface="Arial"/>
               </a:defRPr>
             </a:pPr>
             <a:r>
-              <a:t>BERT: compreensão de linguagem (busca, classificação e diálogo)</a:t>
-            </a:r>
-          </a:p>
-          <a:p>
-            <a:pPr>
-              <a:defRPr sz="1400" b="0">
+              <a:t>Dosovitskiy, A. et al. (2021). An Image is Worth 16x16 Words: Transformers for Image Recognition at Scale. ICLR.</a:t>
+            </a:r>
+          </a:p>
+          <a:p>
+            <a:pPr>
+              <a:defRPr sz="1300" b="0">
                 <a:latin typeface="Arial"/>
               </a:defRPr>
             </a:pPr>
             <a:r>
-              <a:t>MAE: classificação, detecção e segmentação de imagens</a:t>
-            </a:r>
-          </a:p>
-          <a:p>
-            <a:pPr>
-              <a:defRPr sz="1400" b="0">
+              <a:t>He, K.; Chen, X.; Xie, S.; Li, Y.; Dollár, P.; Girshick, R. (2022). Masked Autoencoders Are Scalable Vision Learners. CVPR.</a:t>
+            </a:r>
+          </a:p>
+          <a:p>
+            <a:pPr>
+              <a:defRPr sz="1300" b="0">
                 <a:latin typeface="Arial"/>
               </a:defRPr>
             </a:pPr>
             <a:r>
-              <a:t>SimMIM: classificação, detecção e segmentação em imagens</a:t>
-            </a:r>
-          </a:p>
-        </p:txBody>
-      </p:sp>
-      <p:sp>
-        <p:nvSpPr>
-          <p:cNvPr id="4" name="TextBox 3"/>
-          <p:cNvSpPr txBox="1"/>
-          <p:nvPr/>
-        </p:nvSpPr>
-        <p:spPr>
-          <a:xfrm>
-            <a:off x="612648" y="3063240"/>
-            <a:ext cx="10972800" cy="3200400"/>
-          </a:xfrm>
-          <a:prstGeom prst="rect">
-            <a:avLst/>
-          </a:prstGeom>
-          <a:noFill/>
-        </p:spPr>
-        <p:txBody>
-          <a:bodyPr wrap="square">
-            <a:spAutoFit/>
-          </a:bodyPr>
-          <a:lstStyle/>
-          <a:p>
-            <a:pPr>
-              <a:defRPr sz="1500" b="1">
+              <a:t>Bao, H. et al. (2022). BEiT: BERT Pre-Training of Image Transformers. ICLR.</a:t>
+            </a:r>
+          </a:p>
+          <a:p>
+            <a:pPr>
+              <a:defRPr sz="1300" b="0">
                 <a:latin typeface="Arial"/>
               </a:defRPr>
             </a:pPr>
             <a:r>
-              <a:t>Referências:</a:t>
+              <a:t>Xie, Z.; Zhang, Z.; Lin, Y.; Bian, J.; Lin, L.; Zeng, D. (2022). SimMIM: A Simple Framework for Masked Image Modeling. CVPR.</a:t>
+            </a:r>
+          </a:p>
+          <a:p>
+            <a:pPr>
+              <a:defRPr sz="1300" b="0">
+                <a:latin typeface="Arial"/>
+              </a:defRPr>
+            </a:pPr>
+            <a:r>
+              <a:t>Krizhevsky, A.; Nair, V.; Hinton, G. (2009). CIFAR-10 (Canadian Institute for Advanced Research). Fonte dos dados deste trabalho, verificado por md5.</a:t>
+            </a:r>
+          </a:p>
+          <a:p>
+            <a:pPr>
+              <a:defRPr sz="1300" b="0">
+                <a:latin typeface="Arial"/>
+              </a:defRPr>
+            </a:pPr>
+            <a:r>
+              <a:t>Crédito do experimento complementar: material do colega do grupo, com a implementação pública Hugging Face Transformers, ViTMAE, modelo facebook/vit-mae-base (Meta AI).</a:t>
             </a:r>
           </a:p>
           <a:p>
@@ -3609,37 +3507,7 @@
               </a:defRPr>
             </a:pPr>
             <a:r>
-              <a:t>Devlin, J.; Chang, M.; Lee, K.; Toutanova, K. (2019). BERT: Pre-training of Deep Bidirectional Transformers for Language Understanding. NAACL-HLT.</a:t>
-            </a:r>
-          </a:p>
-          <a:p>
-            <a:pPr>
-              <a:defRPr sz="1200" b="0">
-                <a:latin typeface="Arial"/>
-              </a:defRPr>
-            </a:pPr>
-            <a:r>
-              <a:t>He, K.; Chen, X.; Xie, S.; Li, Y.; Dollár, P.; Girshick, R. (2022). Masked Autoencoders Are Scalable Vision Learners. CVPR.</a:t>
-            </a:r>
-          </a:p>
-          <a:p>
-            <a:pPr>
-              <a:defRPr sz="1200" b="0">
-                <a:latin typeface="Arial"/>
-              </a:defRPr>
-            </a:pPr>
-            <a:r>
-              <a:t>Xie, Z.; Zhang, Z.; Lin, Y.; Bian, J.; Lin, L.; Zeng, D. (2022). SimMIM: A Simple Framework for Masked Image Modeling. CVPR.</a:t>
-            </a:r>
-          </a:p>
-          <a:p>
-            <a:pPr>
-              <a:defRPr sz="1200" b="0">
-                <a:latin typeface="Arial"/>
-              </a:defRPr>
-            </a:pPr>
-            <a:r>
-              <a:t>Krizhevsky, A.; Nair, V.; Hinton, G. (2009). CIFAR-10 (Canadian Institute for Advanced Research). Fonte dos dados, verificado por md5.</a:t>
+              <a:t>Código do experimento do colega: https://colab.research.google.com/drive/11BkUg8lzF079vWErYh5plimEVcF16gXN</a:t>
             </a:r>
           </a:p>
         </p:txBody>
@@ -3681,7 +3549,7 @@
               <a:defRPr sz="3000"/>
             </a:pPr>
             <a:r>
-              <a:t>Roteiro</a:t>
+              <a:t>O que é Masked Modeling</a:t>
             </a:r>
           </a:p>
         </p:txBody>
@@ -3705,7 +3573,7 @@
               <a:defRPr sz="1700"/>
             </a:pPr>
             <a:r>
-              <a:t>O problema: aprender representações com conteúdo incompleto</a:t>
+              <a:t>Estratégia de aprendizado em que parte dos dados de entrada é propositalmente ocultada (mascarada)</a:t>
             </a:r>
           </a:p>
           <a:p>
@@ -3713,7 +3581,7 @@
               <a:defRPr sz="1700"/>
             </a:pPr>
             <a:r>
-              <a:t>Panorama: BERT, MAE e SimMIM</a:t>
+              <a:t>O modelo é treinado para prever ou reconstruir a informação ausente</a:t>
             </a:r>
           </a:p>
           <a:p>
@@ -3721,7 +3589,7 @@
               <a:defRPr sz="1700"/>
             </a:pPr>
             <a:r>
-              <a:t>Fluxo do MAE: diagrama, equação da perda e pseudocódigo</a:t>
+              <a:t>Ideia-chave (material do colega): o próprio dado fornece a supervisão</a:t>
             </a:r>
           </a:p>
           <a:p>
@@ -3729,7 +3597,7 @@
               <a:defRPr sz="1700"/>
             </a:pPr>
             <a:r>
-              <a:t>Arquitetura e nossa implementação</a:t>
+              <a:t>A parte original funciona como referência para verificar o que o modelo previu ou reconstruiu</a:t>
             </a:r>
           </a:p>
           <a:p>
@@ -3737,7 +3605,7 @@
               <a:defRPr sz="1700"/>
             </a:pPr>
             <a:r>
-              <a:t>Protocolo e orçamento de treino</a:t>
+              <a:t>Quatro etapas: ocultar uma parte da entrada, usar o visível como contexto,</a:t>
             </a:r>
           </a:p>
           <a:p>
@@ -3745,23 +3613,7 @@
               <a:defRPr sz="1700"/>
             </a:pPr>
             <a:r>
-              <a:t>Experimento: máscara de 50% contra 75%</a:t>
-            </a:r>
-          </a:p>
-          <a:p>
-            <a:pPr>
-              <a:defRPr sz="1700"/>
-            </a:pPr>
-            <a:r>
-              <a:t>Resultados, críticas e próximos passos</a:t>
-            </a:r>
-          </a:p>
-          <a:p>
-            <a:pPr>
-              <a:defRPr sz="1700"/>
-            </a:pPr>
-            <a:r>
-              <a:t>Aplicações e referências</a:t>
+              <a:t>prever ou reconstruir o conteúdo mascarado e aprender representações úteis dos dados</a:t>
             </a:r>
           </a:p>
         </p:txBody>
@@ -3803,7 +3655,7 @@
               <a:defRPr sz="3000"/>
             </a:pPr>
             <a:r>
-              <a:t>O problema</a:t>
+              <a:t>Por que usar: motivações</a:t>
             </a:r>
           </a:p>
         </p:txBody>
@@ -3827,7 +3679,7 @@
               <a:defRPr sz="1700"/>
             </a:pPr>
             <a:r>
-              <a:t>Supervisão cara: rotular milhões de imagens é custoso</a:t>
+              <a:t>Treino de deep learning depende de grandes quantidades de dados rotulados, caros e demorados de obter</a:t>
             </a:r>
           </a:p>
           <a:p>
@@ -3835,7 +3687,7 @@
               <a:defRPr sz="1700"/>
             </a:pPr>
             <a:r>
-              <a:t>Auto-supervisão: a própria imagem fornece o alvo</a:t>
+              <a:t>Masked modeling aproveita dados não rotulados: a tarefa de aprendizado nasce do próprio dado</a:t>
             </a:r>
           </a:p>
           <a:p>
@@ -3843,7 +3695,7 @@
               <a:defRPr sz="1700"/>
             </a:pPr>
             <a:r>
-              <a:t>BERT: prever palavras ocultas do texto</a:t>
+              <a:t>Reduz a dependência de dados rotulados</a:t>
             </a:r>
           </a:p>
           <a:p>
@@ -3851,7 +3703,7 @@
               <a:defRPr sz="1700"/>
             </a:pPr>
             <a:r>
-              <a:t>Ideia do vision masking: ocultar partes da imagem e reconstruir</a:t>
+              <a:t>Aprende representações relevantes dos dados</a:t>
             </a:r>
           </a:p>
           <a:p>
@@ -3859,7 +3711,15 @@
               <a:defRPr sz="1700"/>
             </a:pPr>
             <a:r>
-              <a:t>A hipótese (He et al., 2022): reconstruir obrigaria o modelo a representar objetos; exigiria avaliação downstream para confirmar</a:t>
+              <a:t>Explora o contexto e as relações entre as partes da entrada</a:t>
+            </a:r>
+          </a:p>
+          <a:p>
+            <a:pPr>
+              <a:defRPr sz="1700"/>
+            </a:pPr>
+            <a:r>
+              <a:t>Serve de pré-treinamento para modelos adaptados a outras tarefas depois</a:t>
             </a:r>
           </a:p>
         </p:txBody>
@@ -5526,83 +5386,316 @@
               <a:defRPr sz="3000"/>
             </a:pPr>
             <a:r>
-              <a:t>Arquitetura e implementação</a:t>
-            </a:r>
-          </a:p>
-        </p:txBody>
-      </p:sp>
-      <p:sp>
-        <p:nvSpPr>
-          <p:cNvPr id="3" name="Content Placeholder 2"/>
-          <p:cNvSpPr>
-            <a:spLocks noGrp="1"/>
-          </p:cNvSpPr>
-          <p:nvPr>
-            <p:ph idx="1"/>
-          </p:nvPr>
-        </p:nvSpPr>
-        <p:spPr/>
-        <p:txBody>
-          <a:bodyPr/>
-          <a:lstStyle/>
-          <a:p>
-            <a:pPr>
-              <a:defRPr sz="1700"/>
-            </a:pPr>
-            <a:r>
-              <a:t>Patchify: imagem 32x32x3 em 16 patches de 8x8 (192 valores cada)</a:t>
-            </a:r>
-          </a:p>
-          <a:p>
-            <a:pPr>
-              <a:defRPr sz="1700"/>
-            </a:pPr>
-            <a:r>
-              <a:t>Encoder: somente os patches visíveis entram (ViT dim 128, 4 blocos, 4 heads)</a:t>
-            </a:r>
-          </a:p>
-          <a:p>
-            <a:pPr>
-              <a:defRPr sz="1700"/>
-            </a:pPr>
-            <a:r>
-              <a:t>Decoder leve: dim 64, 2 blocos, tokens de máscara + embedding posicional</a:t>
-            </a:r>
-          </a:p>
-          <a:p>
-            <a:pPr>
-              <a:defRPr sz="1700"/>
-            </a:pPr>
-            <a:r>
-              <a:t>Saída: 192 valores por patch oculto; o decoder é descartado em tarefas posteriores</a:t>
-            </a:r>
-          </a:p>
-          <a:p>
-            <a:pPr>
-              <a:defRPr sz="1700"/>
-            </a:pPr>
-            <a:r>
-              <a:t>MAE próprio em PyTorch puro (sem código de terceiros), validado contra oráculo fora do pacote</a:t>
-            </a:r>
-          </a:p>
-          <a:p>
-            <a:pPr>
-              <a:defRPr sz="1700"/>
-            </a:pPr>
-            <a:r>
-              <a:t>Máscara aninhada: permutação fixa por imagem com seed 42</a:t>
-            </a:r>
-          </a:p>
-          <a:p>
-            <a:pPr>
-              <a:defRPr sz="1700"/>
-            </a:pPr>
-            <a:r>
-              <a:t>50% oculta 8 patches; 75% oculta 12 (todos os da 50% também)</a:t>
-            </a:r>
-          </a:p>
-        </p:txBody>
-      </p:sp>
+              <a:t>Experimento próprio no CIFAR-10</a:t>
+            </a:r>
+          </a:p>
+        </p:txBody>
+      </p:sp>
+      <p:sp>
+        <p:nvSpPr>
+          <p:cNvPr id="3" name="TextBox 2"/>
+          <p:cNvSpPr txBox="1"/>
+          <p:nvPr/>
+        </p:nvSpPr>
+        <p:spPr>
+          <a:xfrm>
+            <a:off x="612648" y="1325880"/>
+            <a:ext cx="6309360" cy="2743200"/>
+          </a:xfrm>
+          <a:prstGeom prst="rect">
+            <a:avLst/>
+          </a:prstGeom>
+          <a:noFill/>
+        </p:spPr>
+        <p:txBody>
+          <a:bodyPr wrap="square">
+            <a:spAutoFit/>
+          </a:bodyPr>
+          <a:lstStyle/>
+          <a:p>
+            <a:pPr>
+              <a:defRPr sz="1400" b="0">
+                <a:latin typeface="Arial"/>
+              </a:defRPr>
+            </a:pPr>
+            <a:r>
+              <a:t>MAE próprio, escrito do zero em PyTorch puro (sem código de terceiros)</a:t>
+            </a:r>
+          </a:p>
+          <a:p>
+            <a:pPr>
+              <a:defRPr sz="1400" b="0">
+                <a:latin typeface="Arial"/>
+              </a:defRPr>
+            </a:pPr>
+            <a:r>
+              <a:t>Mesmo protocolo nas duas condições: 200 épocas, batch 256, lr 3.0e-04 (AdamW)</a:t>
+            </a:r>
+          </a:p>
+          <a:p>
+            <a:pPr>
+              <a:defRPr sz="1400" b="0">
+                <a:latin typeface="Arial"/>
+              </a:defRPr>
+            </a:pPr>
+            <a:r>
+              <a:t>Semente única 42; subset balanceado verificado por md5; teste fixo de 1.000 imagens</a:t>
+            </a:r>
+          </a:p>
+          <a:p>
+            <a:pPr>
+              <a:defRPr sz="1400" b="0">
+                <a:latin typeface="Arial"/>
+              </a:defRPr>
+            </a:pPr>
+            <a:r>
+              <a:t>Máscara aninhada: os patches ocultos a 50% também estão a 75%, isolando o efeito da taxa</a:t>
+            </a:r>
+          </a:p>
+          <a:p>
+            <a:pPr>
+              <a:defRPr sz="1400" b="0">
+                <a:latin typeface="Arial"/>
+              </a:defRPr>
+            </a:pPr>
+            <a:r>
+              <a:t>50% oculta 8 dos 16 patches; 75% oculta 12 (custo por época diverge: 8 contra 4 tokens no encoder)</a:t>
+            </a:r>
+          </a:p>
+          <a:p>
+            <a:pPr>
+              <a:defRPr sz="1400" b="0">
+                <a:latin typeface="Arial"/>
+              </a:defRPr>
+            </a:pPr>
+            <a:r>
+              <a:t>MSE de 75% é +17.8% maior que o de 50%: nesta configuração, mascarar mais elevou o erro</a:t>
+            </a:r>
+          </a:p>
+          <a:p>
+            <a:pPr>
+              <a:defRPr sz="1400" b="0">
+                <a:latin typeface="Arial"/>
+              </a:defRPr>
+            </a:pPr>
+            <a:r>
+              <a:t>Delimitação: evidência desta configuração, semente única; repetir com mais sementes e avaliar downstream antes de generalizar</a:t>
+            </a:r>
+          </a:p>
+        </p:txBody>
+      </p:sp>
+      <p:graphicFrame>
+        <p:nvGraphicFramePr>
+          <p:cNvPr id="4" name="Table 3"/>
+          <p:cNvGraphicFramePr>
+            <a:graphicFrameLocks noGrp="1"/>
+          </p:cNvGraphicFramePr>
+          <p:nvPr/>
+        </p:nvGraphicFramePr>
+        <p:xfrm>
+          <a:off x="7315200" y="1463040"/>
+          <a:ext cx="4114800" cy="1508760"/>
+        </p:xfrm>
+        <a:graphic>
+          <a:graphicData uri="http://schemas.openxmlformats.org/drawingml/2006/table">
+            <a:tbl>
+              <a:tblPr firstRow="1" bandRow="1">
+                <a:tableStyleId>{5C22544A-7EE6-4342-B048-85BDC9FD1C3A}</a:tableStyleId>
+              </a:tblPr>
+              <a:tblGrid>
+                <a:gridCol w="2057400"/>
+                <a:gridCol w="2057400"/>
+              </a:tblGrid>
+              <a:tr h="502920">
+                <a:tc>
+                  <a:txBody>
+                    <a:bodyPr/>
+                    <a:lstStyle/>
+                    <a:p>
+                      <a:pPr>
+                        <a:defRPr sz="1300" b="1"/>
+                      </a:pPr>
+                      <a:r>
+                        <a:t>Condição</a:t>
+                      </a:r>
+                    </a:p>
+                  </a:txBody>
+                  <a:tcPr/>
+                </a:tc>
+                <a:tc>
+                  <a:txBody>
+                    <a:bodyPr/>
+                    <a:lstStyle/>
+                    <a:p>
+                      <a:pPr>
+                        <a:defRPr sz="1300" b="1"/>
+                      </a:pPr>
+                      <a:r>
+                        <a:t>MSE de teste (ocultos)</a:t>
+                      </a:r>
+                    </a:p>
+                  </a:txBody>
+                  <a:tcPr/>
+                </a:tc>
+              </a:tr>
+              <a:tr h="502920">
+                <a:tc>
+                  <a:txBody>
+                    <a:bodyPr/>
+                    <a:lstStyle/>
+                    <a:p>
+                      <a:pPr>
+                        <a:defRPr sz="1300" b="1"/>
+                      </a:pPr>
+                      <a:r>
+                        <a:t>Máscara 50%</a:t>
+                      </a:r>
+                    </a:p>
+                  </a:txBody>
+                  <a:tcPr/>
+                </a:tc>
+                <a:tc>
+                  <a:txBody>
+                    <a:bodyPr/>
+                    <a:lstStyle/>
+                    <a:p>
+                      <a:pPr>
+                        <a:defRPr sz="1300" b="0"/>
+                      </a:pPr>
+                      <a:r>
+                        <a:t>0.0608</a:t>
+                      </a:r>
+                    </a:p>
+                  </a:txBody>
+                  <a:tcPr/>
+                </a:tc>
+              </a:tr>
+              <a:tr h="502920">
+                <a:tc>
+                  <a:txBody>
+                    <a:bodyPr/>
+                    <a:lstStyle/>
+                    <a:p>
+                      <a:pPr>
+                        <a:defRPr sz="1300" b="1"/>
+                      </a:pPr>
+                      <a:r>
+                        <a:t>Máscara 75%</a:t>
+                      </a:r>
+                    </a:p>
+                  </a:txBody>
+                  <a:tcPr/>
+                </a:tc>
+                <a:tc>
+                  <a:txBody>
+                    <a:bodyPr/>
+                    <a:lstStyle/>
+                    <a:p>
+                      <a:pPr>
+                        <a:defRPr sz="1300" b="0"/>
+                      </a:pPr>
+                      <a:r>
+                        <a:t>0.0717</a:t>
+                      </a:r>
+                    </a:p>
+                  </a:txBody>
+                  <a:tcPr/>
+                </a:tc>
+              </a:tr>
+            </a:tbl>
+          </a:graphicData>
+        </a:graphic>
+      </p:graphicFrame>
+      <p:sp>
+        <p:nvSpPr>
+          <p:cNvPr id="5" name="TextBox 4"/>
+          <p:cNvSpPr txBox="1"/>
+          <p:nvPr/>
+        </p:nvSpPr>
+        <p:spPr>
+          <a:xfrm>
+            <a:off x="7315200" y="3063240"/>
+            <a:ext cx="4114800" cy="457200"/>
+          </a:xfrm>
+          <a:prstGeom prst="rect">
+            <a:avLst/>
+          </a:prstGeom>
+          <a:noFill/>
+        </p:spPr>
+        <p:txBody>
+          <a:bodyPr wrap="square">
+            <a:spAutoFit/>
+          </a:bodyPr>
+          <a:lstStyle/>
+          <a:p>
+            <a:pPr>
+              <a:defRPr sz="1100" b="0">
+                <a:latin typeface="Arial"/>
+              </a:defRPr>
+            </a:pPr>
+            <a:r>
+              <a:t>Fonte: resultados/metricas.csv (semente 42)</a:t>
+            </a:r>
+          </a:p>
+        </p:txBody>
+      </p:sp>
+      <p:sp>
+        <p:nvSpPr>
+          <p:cNvPr id="6" name="TextBox 5"/>
+          <p:cNvSpPr txBox="1"/>
+          <p:nvPr/>
+        </p:nvSpPr>
+        <p:spPr>
+          <a:xfrm>
+            <a:off x="612648" y="4224528"/>
+            <a:ext cx="10972800" cy="274320"/>
+          </a:xfrm>
+          <a:prstGeom prst="rect">
+            <a:avLst/>
+          </a:prstGeom>
+          <a:noFill/>
+        </p:spPr>
+        <p:txBody>
+          <a:bodyPr wrap="square">
+            <a:spAutoFit/>
+          </a:bodyPr>
+          <a:lstStyle/>
+          <a:p>
+            <a:pPr>
+              <a:defRPr sz="1200" b="1">
+                <a:latin typeface="Arial"/>
+              </a:defRPr>
+            </a:pPr>
+            <a:r>
+              <a:t>Reconstruções: 8 imagens fixas do teste (semente 42)</a:t>
+            </a:r>
+          </a:p>
+        </p:txBody>
+      </p:sp>
+      <p:pic>
+        <p:nvPicPr>
+          <p:cNvPr id="7" name="Picture 6" descr="reconstrucoes.png"/>
+          <p:cNvPicPr>
+            <a:picLocks noChangeAspect="1"/>
+          </p:cNvPicPr>
+          <p:nvPr/>
+        </p:nvPicPr>
+        <p:blipFill>
+          <a:blip r:embed="rId2"/>
+          <a:stretch>
+            <a:fillRect/>
+          </a:stretch>
+        </p:blipFill>
+        <p:spPr>
+          <a:xfrm>
+            <a:off x="1252728" y="4526280"/>
+            <a:ext cx="9656063" cy="2194560"/>
+          </a:xfrm>
+          <a:prstGeom prst="rect">
+            <a:avLst/>
+          </a:prstGeom>
+        </p:spPr>
+      </p:pic>
     </p:spTree>
   </p:cSld>
   <p:clrMapOvr>
@@ -5640,55 +5733,281 @@
               <a:defRPr sz="3000"/>
             </a:pPr>
             <a:r>
-              <a:t>Protocolo e orçamento de treino</a:t>
-            </a:r>
-          </a:p>
-        </p:txBody>
-      </p:sp>
-      <p:sp>
-        <p:nvSpPr>
-          <p:cNvPr id="3" name="Content Placeholder 2"/>
-          <p:cNvSpPr>
-            <a:spLocks noGrp="1"/>
-          </p:cNvSpPr>
-          <p:nvPr>
-            <p:ph idx="1"/>
-          </p:nvPr>
-        </p:nvSpPr>
-        <p:spPr/>
-        <p:txBody>
-          <a:bodyPr/>
-          <a:lstStyle/>
-          <a:p>
-            <a:pPr>
-              <a:defRPr sz="1700"/>
-            </a:pPr>
-            <a:r>
-              <a:t>CIFAR-10 verificado por md5 antes de qualquer uso</a:t>
-            </a:r>
-          </a:p>
-          <a:p>
-            <a:pPr>
-              <a:defRPr sz="1700"/>
-            </a:pPr>
-            <a:r>
-              <a:t>Subset seed 42, balanceado: 500 treino, 100 validação e 100 teste por classe</a:t>
-            </a:r>
-          </a:p>
-          <a:p>
-            <a:pPr>
-              <a:defRPr sz="1700"/>
-            </a:pPr>
-            <a:r>
-              <a:t>Validação disjunta do treino; teste sai do split oficial e é usado só no fim</a:t>
-            </a:r>
-          </a:p>
-          <a:p>
-            <a:pPr>
-              <a:defRPr sz="1700"/>
-            </a:pPr>
-            <a:r>
-              <a:t>Métrica: MSE nos patches ocultos do conjunto de teste</a:t>
+              <a:t>Experimento complementar: ViT-MAE</a:t>
+            </a:r>
+          </a:p>
+        </p:txBody>
+      </p:sp>
+      <p:pic>
+        <p:nvPicPr>
+          <p:cNvPr id="3" name="Picture 2" descr="vitmae-fluxo-experimento.png"/>
+          <p:cNvPicPr>
+            <a:picLocks noChangeAspect="1"/>
+          </p:cNvPicPr>
+          <p:nvPr/>
+        </p:nvPicPr>
+        <p:blipFill>
+          <a:blip r:embed="rId2"/>
+          <a:stretch>
+            <a:fillRect/>
+          </a:stretch>
+        </p:blipFill>
+        <p:spPr>
+          <a:xfrm>
+            <a:off x="798437" y="1143000"/>
+            <a:ext cx="10601221" cy="2057400"/>
+          </a:xfrm>
+          <a:prstGeom prst="rect">
+            <a:avLst/>
+          </a:prstGeom>
+        </p:spPr>
+      </p:pic>
+      <p:sp>
+        <p:nvSpPr>
+          <p:cNvPr id="4" name="TextBox 3"/>
+          <p:cNvSpPr txBox="1"/>
+          <p:nvPr/>
+        </p:nvSpPr>
+        <p:spPr>
+          <a:xfrm>
+            <a:off x="612648" y="3273552"/>
+            <a:ext cx="2194560" cy="402336"/>
+          </a:xfrm>
+          <a:prstGeom prst="rect">
+            <a:avLst/>
+          </a:prstGeom>
+          <a:noFill/>
+        </p:spPr>
+        <p:txBody>
+          <a:bodyPr wrap="square">
+            <a:spAutoFit/>
+          </a:bodyPr>
+          <a:lstStyle/>
+          <a:p>
+            <a:pPr>
+              <a:defRPr sz="1100" b="1">
+                <a:latin typeface="Arial"/>
+              </a:defRPr>
+            </a:pPr>
+            <a:r>
+              <a:t>Mascarado e reconstruído em cada taxa</a:t>
+            </a:r>
+          </a:p>
+        </p:txBody>
+      </p:sp>
+      <p:sp>
+        <p:nvSpPr>
+          <p:cNvPr id="5" name="TextBox 4"/>
+          <p:cNvSpPr txBox="1"/>
+          <p:nvPr/>
+        </p:nvSpPr>
+        <p:spPr>
+          <a:xfrm>
+            <a:off x="5897880" y="3273552"/>
+            <a:ext cx="3840480" cy="402336"/>
+          </a:xfrm>
+          <a:prstGeom prst="rect">
+            <a:avLst/>
+          </a:prstGeom>
+          <a:noFill/>
+        </p:spPr>
+        <p:txBody>
+          <a:bodyPr wrap="square">
+            <a:spAutoFit/>
+          </a:bodyPr>
+          <a:lstStyle/>
+          <a:p>
+            <a:pPr>
+              <a:defRPr sz="1100" b="1">
+                <a:latin typeface="Arial"/>
+              </a:defRPr>
+            </a:pPr>
+            <a:r>
+              <a:t>Erro de reconstrução por taxa (colega)</a:t>
+            </a:r>
+          </a:p>
+        </p:txBody>
+      </p:sp>
+      <p:sp>
+        <p:nvSpPr>
+          <p:cNvPr id="6" name="TextBox 5"/>
+          <p:cNvSpPr txBox="1"/>
+          <p:nvPr/>
+        </p:nvSpPr>
+        <p:spPr>
+          <a:xfrm>
+            <a:off x="2788920" y="3611880"/>
+            <a:ext cx="3017520" cy="2560320"/>
+          </a:xfrm>
+          <a:prstGeom prst="rect">
+            <a:avLst/>
+          </a:prstGeom>
+          <a:noFill/>
+        </p:spPr>
+        <p:txBody>
+          <a:bodyPr wrap="square">
+            <a:spAutoFit/>
+          </a:bodyPr>
+          <a:lstStyle/>
+          <a:p>
+            <a:pPr>
+              <a:defRPr sz="1200" b="0">
+                <a:latin typeface="Arial"/>
+              </a:defRPr>
+            </a:pPr>
+            <a:r>
+              <a:t>Configuração do material do colega:</a:t>
+            </a:r>
+          </a:p>
+          <a:p>
+            <a:pPr>
+              <a:defRPr sz="1200" b="0">
+                <a:latin typeface="Arial"/>
+              </a:defRPr>
+            </a:pPr>
+            <a:r>
+              <a:t>MAE pré-treinado, arquitetura Vision Transformer (ViT)</a:t>
+            </a:r>
+          </a:p>
+          <a:p>
+            <a:pPr>
+              <a:defRPr sz="1200" b="0">
+                <a:latin typeface="Arial"/>
+              </a:defRPr>
+            </a:pPr>
+            <a:r>
+              <a:t>Entrada de 224x224 pixels, patches de 16x16</a:t>
+            </a:r>
+          </a:p>
+          <a:p>
+            <a:pPr>
+              <a:defRPr sz="1200" b="0">
+                <a:latin typeface="Arial"/>
+              </a:defRPr>
+            </a:pPr>
+            <a:r>
+              <a:t>Taxas avaliadas: 25%, 50%, 75% e 90%</a:t>
+            </a:r>
+          </a:p>
+          <a:p>
+            <a:pPr>
+              <a:defRPr sz="1200" b="0">
+                <a:latin typeface="Arial"/>
+              </a:defRPr>
+            </a:pPr>
+            <a:r>
+              <a:t>MSEs documentados pelo colega:</a:t>
+            </a:r>
+          </a:p>
+          <a:p>
+            <a:pPr>
+              <a:defRPr sz="1200" b="0">
+                <a:latin typeface="Arial"/>
+              </a:defRPr>
+            </a:pPr>
+            <a:r>
+              <a:t>25%: 0,0476 | 75%: 0,1403 | 90%: 0,3117</a:t>
+            </a:r>
+          </a:p>
+          <a:p>
+            <a:pPr>
+              <a:defRPr sz="1200" b="0">
+                <a:latin typeface="Arial"/>
+              </a:defRPr>
+            </a:pPr>
+            <a:r>
+              <a:t>Menos informação visível torna a reconstrução mais desafiadora</a:t>
+            </a:r>
+          </a:p>
+        </p:txBody>
+      </p:sp>
+      <p:pic>
+        <p:nvPicPr>
+          <p:cNvPr id="7" name="Picture 6" descr="vitmae-grade-taxas.png"/>
+          <p:cNvPicPr>
+            <a:picLocks noChangeAspect="1"/>
+          </p:cNvPicPr>
+          <p:nvPr/>
+        </p:nvPicPr>
+        <p:blipFill>
+          <a:blip r:embed="rId3"/>
+          <a:stretch>
+            <a:fillRect/>
+          </a:stretch>
+        </p:blipFill>
+        <p:spPr>
+          <a:xfrm>
+            <a:off x="794535" y="3703320"/>
+            <a:ext cx="1748488" cy="2103120"/>
+          </a:xfrm>
+          <a:prstGeom prst="rect">
+            <a:avLst/>
+          </a:prstGeom>
+        </p:spPr>
+      </p:pic>
+      <p:pic>
+        <p:nvPicPr>
+          <p:cNvPr id="8" name="Picture 7" descr="vitmae-grafico-mse.png"/>
+          <p:cNvPicPr>
+            <a:picLocks noChangeAspect="1"/>
+          </p:cNvPicPr>
+          <p:nvPr/>
+        </p:nvPicPr>
+        <p:blipFill>
+          <a:blip r:embed="rId4"/>
+          <a:stretch>
+            <a:fillRect/>
+          </a:stretch>
+        </p:blipFill>
+        <p:spPr>
+          <a:xfrm>
+            <a:off x="6014596" y="3703320"/>
+            <a:ext cx="3561327" cy="2377440"/>
+          </a:xfrm>
+          <a:prstGeom prst="rect">
+            <a:avLst/>
+          </a:prstGeom>
+        </p:spPr>
+      </p:pic>
+      <p:sp>
+        <p:nvSpPr>
+          <p:cNvPr id="9" name="TextBox 8"/>
+          <p:cNvSpPr txBox="1"/>
+          <p:nvPr/>
+        </p:nvSpPr>
+        <p:spPr>
+          <a:xfrm>
+            <a:off x="612648" y="6217920"/>
+            <a:ext cx="10972800" cy="566928"/>
+          </a:xfrm>
+          <a:prstGeom prst="rect">
+            <a:avLst/>
+          </a:prstGeom>
+          <a:noFill/>
+        </p:spPr>
+        <p:txBody>
+          <a:bodyPr wrap="square">
+            <a:spAutoFit/>
+          </a:bodyPr>
+          <a:lstStyle/>
+          <a:p>
+            <a:pPr>
+              <a:defRPr sz="1100" b="0">
+                <a:latin typeface="Arial"/>
+              </a:defRPr>
+            </a:pPr>
+            <a:r>
+              <a:t>Imagem superior: fluxo do experimento com MAE pré-treinado. Fonte: apresentação do colega do grupo; implementação pública: Hugging Face Transformers, ViTMAE, modelo facebook/vit-mae-base (Meta AI).</a:t>
+            </a:r>
+          </a:p>
+          <a:p>
+            <a:pPr>
+              <a:defRPr sz="1100" b="0">
+                <a:latin typeface="Arial"/>
+              </a:defRPr>
+            </a:pPr>
+            <a:r>
+              <a:t>Código do experimento do colega: https://colab.research.google.com/drive/11BkUg8lzF079vWErYh5plimEVcF16gXN</a:t>
             </a:r>
           </a:p>
         </p:txBody>
@@ -5730,7 +6049,7 @@
               <a:defRPr sz="3000"/>
             </a:pPr>
             <a:r>
-              <a:t>Experimento: máscara de 50% contra 75%</a:t>
+              <a:t>Aplicações por domínio (colega)</a:t>
             </a:r>
           </a:p>
         </p:txBody>
@@ -5754,7 +6073,7 @@
               <a:defRPr sz="1700"/>
             </a:pPr>
             <a:r>
-              <a:t>Mesmo treino nas duas condições: 200 épocas, batch 256, lr 3.0e-04 (AdamW)</a:t>
+              <a:t>Pré-treinar com grandes volumes de dados não rotulados e transferir as representações</a:t>
             </a:r>
           </a:p>
           <a:p>
@@ -5762,7 +6081,7 @@
               <a:defRPr sz="1700"/>
             </a:pPr>
             <a:r>
-              <a:t>O custo computacional por época diverge: a 75% o encoder vê 4 tokens, a 50% vê 8</a:t>
+              <a:t>Visão computacional: classificação, detecção de objetos, segmentação semântica, reconhecimento visual</a:t>
             </a:r>
           </a:p>
           <a:p>
@@ -5770,7 +6089,7 @@
               <a:defRPr sz="1700"/>
             </a:pPr>
             <a:r>
-              <a:t>Tempo medido por época (na condição 75%): 0.58 s</a:t>
+              <a:t>Imagens médicas: radiografias, tomografias e ressonâncias; pré-treinamento sem anotação; extração de características para diagnóstico</a:t>
             </a:r>
           </a:p>
           <a:p>
@@ -5778,7 +6097,7 @@
               <a:defRPr sz="1700"/>
             </a:pPr>
             <a:r>
-              <a:t>Orçamento previsto: 30 minutos para as duas condições somadas</a:t>
+              <a:t>Sensoriamento remoto: uso e cobertura do solo, detecção de mudanças, imagens de satélite, monitoramento ambiental e agrícola</a:t>
             </a:r>
           </a:p>
           <a:p>
@@ -5786,7 +6105,7 @@
               <a:defRPr sz="1700"/>
             </a:pPr>
             <a:r>
-              <a:t>MSE de teste nos ocultos: 50% = 0.0608 | 75% = 0.0717</a:t>
+              <a:t>Outras modalidades: linguagem natural, vídeos, áudio e aprendizado multimodal</a:t>
             </a:r>
           </a:p>
         </p:txBody>

</xml_diff>

<commit_message>
fix: ajustar nomenclatura de recursos e créditos nos textos da apresentação
</commit_message>
<xml_diff>
--- a/slides/seminario_masked_modeling.pptx
+++ b/slides/seminario_masked_modeling.pptx
@@ -3192,7 +3192,7 @@
               <a:defRPr sz="3000"/>
             </a:pPr>
             <a:r>
-              <a:t>Pós MAE e tarefas downstream (colega)</a:t>
+              <a:t>Pós MAE e tarefas downstream</a:t>
             </a:r>
           </a:p>
         </p:txBody>
@@ -3346,7 +3346,7 @@
               <a:defRPr sz="1700"/>
             </a:pPr>
             <a:r>
-              <a:t>No experimento do colega com MAE pré-treinado público, as taxas maiores de mascaramento elevaram o MSE registrado no material dele</a:t>
+              <a:t>No experimento complementar com MAE pré-treinado público, as taxas maiores de mascaramento elevaram o MSE registrado no material complementar</a:t>
             </a:r>
           </a:p>
           <a:p>
@@ -3497,7 +3497,7 @@
               </a:defRPr>
             </a:pPr>
             <a:r>
-              <a:t>Crédito do experimento complementar: material do colega do grupo, com a implementação pública Hugging Face Transformers, ViTMAE, modelo facebook/vit-mae-base (Meta AI).</a:t>
+              <a:t>Crédito do experimento complementar do grupo: implementação pública Hugging Face Transformers, ViTMAE, modelo facebook/vit-mae-base (Meta AI).</a:t>
             </a:r>
           </a:p>
           <a:p>
@@ -3507,7 +3507,7 @@
               </a:defRPr>
             </a:pPr>
             <a:r>
-              <a:t>Código do experimento do colega: https://colab.research.google.com/drive/11BkUg8lzF079vWErYh5plimEVcF16gXN</a:t>
+              <a:t>Código do experimento complementar: https://colab.research.google.com/drive/11BkUg8lzF079vWErYh5plimEVcF16gXN</a:t>
             </a:r>
           </a:p>
         </p:txBody>
@@ -3589,7 +3589,7 @@
               <a:defRPr sz="1700"/>
             </a:pPr>
             <a:r>
-              <a:t>Ideia-chave (material do colega): o próprio dado fornece a supervisão</a:t>
+              <a:t>Ideia-chave: o próprio dado fornece a supervisão</a:t>
             </a:r>
           </a:p>
           <a:p>
@@ -5823,7 +5823,7 @@
               </a:defRPr>
             </a:pPr>
             <a:r>
-              <a:t>Erro de reconstrução por taxa (colega)</a:t>
+              <a:t>Erro de reconstrução por taxa</a:t>
             </a:r>
           </a:p>
         </p:txBody>
@@ -5856,7 +5856,7 @@
               </a:defRPr>
             </a:pPr>
             <a:r>
-              <a:t>Configuração do material do colega:</a:t>
+              <a:t>Configuração do experimento complementar:</a:t>
             </a:r>
           </a:p>
           <a:p>
@@ -5896,7 +5896,7 @@
               </a:defRPr>
             </a:pPr>
             <a:r>
-              <a:t>MSEs documentados pelo colega:</a:t>
+              <a:t>MSEs documentados (experimento complementar):</a:t>
             </a:r>
           </a:p>
           <a:p>
@@ -5997,7 +5997,7 @@
               </a:defRPr>
             </a:pPr>
             <a:r>
-              <a:t>Imagem superior: fluxo do experimento com MAE pré-treinado. Fonte: apresentação do colega do grupo; implementação pública: Hugging Face Transformers, ViTMAE, modelo facebook/vit-mae-base (Meta AI).</a:t>
+              <a:t>Imagem superior: fluxo do experimento com MAE pré-treinado. Experimento complementar do grupo; implementação pública: Hugging Face Transformers, ViTMAE, modelo facebook/vit-mae-base (Meta AI).</a:t>
             </a:r>
           </a:p>
           <a:p>
@@ -6007,7 +6007,7 @@
               </a:defRPr>
             </a:pPr>
             <a:r>
-              <a:t>Código do experimento do colega: https://colab.research.google.com/drive/11BkUg8lzF079vWErYh5plimEVcF16gXN</a:t>
+              <a:t>Código do experimento complementar: https://colab.research.google.com/drive/11BkUg8lzF079vWErYh5plimEVcF16gXN</a:t>
             </a:r>
           </a:p>
         </p:txBody>
@@ -6049,7 +6049,7 @@
               <a:defRPr sz="3000"/>
             </a:pPr>
             <a:r>
-              <a:t>Aplicações por domínio (colega)</a:t>
+              <a:t>Aplicações por domínio</a:t>
             </a:r>
           </a:p>
         </p:txBody>

</xml_diff>

<commit_message>
feat(mae): fortalecer protocolo de reconstruções
</commit_message>
<xml_diff>
--- a/slides/seminario_masked_modeling.pptx
+++ b/slides/seminario_masked_modeling.pptx
@@ -17,6 +17,7 @@
     <p:sldId id="265" r:id="rId16"/>
     <p:sldId id="266" r:id="rId17"/>
     <p:sldId id="267" r:id="rId18"/>
+    <p:sldId id="268" r:id="rId19"/>
   </p:sldIdLst>
   <p:sldSz cx="12191695" cy="6858000" type="screen4x3"/>
   <p:notesSz cx="6858000" cy="9144000"/>
@@ -3192,7 +3193,7 @@
               <a:defRPr sz="3000"/>
             </a:pPr>
             <a:r>
-              <a:t>Pós MAE e tarefas downstream</a:t>
+              <a:t>Aplicações por domínio</a:t>
             </a:r>
           </a:p>
         </p:txBody>
@@ -3216,7 +3217,7 @@
               <a:defRPr sz="1700"/>
             </a:pPr>
             <a:r>
-              <a:t>Pré-treinamento: o MAE usa grandes volumes de imagens não rotuladas; parte dos patches é mascarada e o modelo aprende a reconstruir</a:t>
+              <a:t>Pré-treinar com grandes volumes de dados não rotulados e transferir as representações</a:t>
             </a:r>
           </a:p>
           <a:p>
@@ -3224,7 +3225,7 @@
               <a:defRPr sz="1700"/>
             </a:pPr>
             <a:r>
-              <a:t>Nesse processo, o encoder ViT aprende representações visuais das imagens</a:t>
+              <a:t>Visão computacional: classificação, detecção de objetos, segmentação semântica, reconhecimento visual</a:t>
             </a:r>
           </a:p>
           <a:p>
@@ -3232,7 +3233,7 @@
               <a:defRPr sz="1700"/>
             </a:pPr>
             <a:r>
-              <a:t>Depois do pré-treinamento, o decoder pode ser descartado: sua função principal era auxiliar a reconstrução</a:t>
+              <a:t>Imagens médicas: radiografias, tomografias e ressonâncias; pré-treinamento sem anotação; extração de características para diagnóstico</a:t>
             </a:r>
           </a:p>
           <a:p>
@@ -3240,7 +3241,7 @@
               <a:defRPr sz="1700"/>
             </a:pPr>
             <a:r>
-              <a:t>O encoder pré-treinado é reutilizado em tarefas downstream: classificação de imagens, detecção de objetos e segmentação semântica</a:t>
+              <a:t>Sensoriamento remoto: uso e cobertura do solo, detecção de mudanças, imagens de satélite, monitoramento ambiental e agrícola</a:t>
             </a:r>
           </a:p>
           <a:p>
@@ -3248,15 +3249,7 @@
               <a:defRPr sz="1700"/>
             </a:pPr>
             <a:r>
-              <a:t>Uso do encoder: extrator de características ou pesos ajustados por fine-tuning para a nova tarefa</a:t>
-            </a:r>
-          </a:p>
-          <a:p>
-            <a:pPr>
-              <a:defRPr sz="1700"/>
-            </a:pPr>
-            <a:r>
-              <a:t>Eco do nosso diagrama: o decoder leve sai e o encoder pesado fica</a:t>
+              <a:t>Outras modalidades: linguagem natural, vídeos, áudio e aprendizado multimodal</a:t>
             </a:r>
           </a:p>
         </p:txBody>
@@ -3298,7 +3291,7 @@
               <a:defRPr sz="3000"/>
             </a:pPr>
             <a:r>
-              <a:t>Conclusões</a:t>
+              <a:t>Pós MAE e tarefas downstream</a:t>
             </a:r>
           </a:p>
         </p:txBody>
@@ -3322,7 +3315,7 @@
               <a:defRPr sz="1700"/>
             </a:pPr>
             <a:r>
-              <a:t>Reconstruir o que foi escondido não é o objetivo final: é o mecanismo para o modelo aprender boas representações</a:t>
+              <a:t>Pré-treinamento: o MAE usa grandes volumes de imagens não rotuladas; parte dos patches é mascarada e o modelo aprende a reconstruir</a:t>
             </a:r>
           </a:p>
           <a:p>
@@ -3330,7 +3323,7 @@
               <a:defRPr sz="1700"/>
             </a:pPr>
             <a:r>
-              <a:t>O mascaramento aproveita dados não rotulados, em texto (BERT) e em imagens (MAE)</a:t>
+              <a:t>Nesse processo, o encoder ViT aprende representações visuais das imagens</a:t>
             </a:r>
           </a:p>
           <a:p>
@@ -3338,7 +3331,7 @@
               <a:defRPr sz="1700"/>
             </a:pPr>
             <a:r>
-              <a:t>No experimento próprio, 75% mascarado errou mais que 50%: nesta configuração, mascarar mais elevou o erro (semente única 42)</a:t>
+              <a:t>Depois do pré-treinamento, o decoder pode ser descartado: sua função principal era auxiliar a reconstrução</a:t>
             </a:r>
           </a:p>
           <a:p>
@@ -3346,7 +3339,7 @@
               <a:defRPr sz="1700"/>
             </a:pPr>
             <a:r>
-              <a:t>No experimento complementar com MAE pré-treinado público, as taxas maiores de mascaramento elevaram o MSE registrado no material complementar</a:t>
+              <a:t>O encoder pré-treinado é reutilizado em tarefas downstream: classificação de imagens, detecção de objetos e segmentação semântica</a:t>
             </a:r>
           </a:p>
           <a:p>
@@ -3354,7 +3347,7 @@
               <a:defRPr sz="1700"/>
             </a:pPr>
             <a:r>
-              <a:t>Leitura delimitada: qualidade visual da reconstrução não é prova de representações melhores</a:t>
+              <a:t>Uso do encoder: extrator de características ou pesos ajustados por fine-tuning para a nova tarefa</a:t>
             </a:r>
           </a:p>
           <a:p>
@@ -3362,7 +3355,7 @@
               <a:defRPr sz="1700"/>
             </a:pPr>
             <a:r>
-              <a:t>Repetição com mais sementes e avaliação downstream continuam necessárias antes de generalizar</a:t>
+              <a:t>Eco do nosso diagrama: o decoder leve sai e o encoder pesado fica</a:t>
             </a:r>
           </a:p>
         </p:txBody>
@@ -3376,6 +3369,112 @@
 </file>
 
 <file path=ppt/slides/slide12.xml><?xml version="1.0" encoding="utf-8"?>
+<p:sld xmlns:a="http://schemas.openxmlformats.org/drawingml/2006/main" xmlns:p="http://schemas.openxmlformats.org/presentationml/2006/main" xmlns:r="http://schemas.openxmlformats.org/officeDocument/2006/relationships">
+  <p:cSld>
+    <p:spTree>
+      <p:nvGrpSpPr>
+        <p:cNvPr id="1" name=""/>
+        <p:cNvGrpSpPr/>
+        <p:nvPr/>
+      </p:nvGrpSpPr>
+      <p:grpSpPr/>
+      <p:sp>
+        <p:nvSpPr>
+          <p:cNvPr id="2" name="Title 1"/>
+          <p:cNvSpPr>
+            <a:spLocks noGrp="1"/>
+          </p:cNvSpPr>
+          <p:nvPr>
+            <p:ph type="title"/>
+          </p:nvPr>
+        </p:nvSpPr>
+        <p:spPr/>
+        <p:txBody>
+          <a:bodyPr/>
+          <a:lstStyle/>
+          <a:p>
+            <a:pPr>
+              <a:defRPr sz="3000"/>
+            </a:pPr>
+            <a:r>
+              <a:t>Conclusões</a:t>
+            </a:r>
+          </a:p>
+        </p:txBody>
+      </p:sp>
+      <p:sp>
+        <p:nvSpPr>
+          <p:cNvPr id="3" name="Content Placeholder 2"/>
+          <p:cNvSpPr>
+            <a:spLocks noGrp="1"/>
+          </p:cNvSpPr>
+          <p:nvPr>
+            <p:ph idx="1"/>
+          </p:nvPr>
+        </p:nvSpPr>
+        <p:spPr/>
+        <p:txBody>
+          <a:bodyPr/>
+          <a:lstStyle/>
+          <a:p>
+            <a:pPr>
+              <a:defRPr sz="1700"/>
+            </a:pPr>
+            <a:r>
+              <a:t>Reconstruir o que foi escondido não é o objetivo final: é o mecanismo para o modelo aprender boas representações</a:t>
+            </a:r>
+          </a:p>
+          <a:p>
+            <a:pPr>
+              <a:defRPr sz="1700"/>
+            </a:pPr>
+            <a:r>
+              <a:t>O mascaramento aproveita dados não rotulados, em texto (BERT) e em imagens (MAE)</a:t>
+            </a:r>
+          </a:p>
+          <a:p>
+            <a:pPr>
+              <a:defRPr sz="1700"/>
+            </a:pPr>
+            <a:r>
+              <a:t>No experimento próprio, 75% mascarado errou mais que 50%: nesta configuração, mascarar mais elevou o erro (semente única 42)</a:t>
+            </a:r>
+          </a:p>
+          <a:p>
+            <a:pPr>
+              <a:defRPr sz="1700"/>
+            </a:pPr>
+            <a:r>
+              <a:t>No experimento complementar com MAE pré-treinado público, as taxas maiores de mascaramento elevaram o MSE registrado no material complementar</a:t>
+            </a:r>
+          </a:p>
+          <a:p>
+            <a:pPr>
+              <a:defRPr sz="1700"/>
+            </a:pPr>
+            <a:r>
+              <a:t>Leitura delimitada: qualidade visual da reconstrução não é prova de representações melhores</a:t>
+            </a:r>
+          </a:p>
+          <a:p>
+            <a:pPr>
+              <a:defRPr sz="1700"/>
+            </a:pPr>
+            <a:r>
+              <a:t>Repetição com mais sementes e avaliação downstream continuam necessárias antes de generalizar</a:t>
+            </a:r>
+          </a:p>
+        </p:txBody>
+      </p:sp>
+    </p:spTree>
+  </p:cSld>
+  <p:clrMapOvr>
+    <a:masterClrMapping/>
+  </p:clrMapOvr>
+</p:sld>
+</file>
+
+<file path=ppt/slides/slide13.xml><?xml version="1.0" encoding="utf-8"?>
 <p:sld xmlns:a="http://schemas.openxmlformats.org/drawingml/2006/main" xmlns:p="http://schemas.openxmlformats.org/presentationml/2006/main" xmlns:r="http://schemas.openxmlformats.org/officeDocument/2006/relationships">
   <p:cSld>
     <p:spTree>
@@ -6049,63 +6148,443 @@
               <a:defRPr sz="3000"/>
             </a:pPr>
             <a:r>
-              <a:t>Aplicações por domínio</a:t>
-            </a:r>
-          </a:p>
-        </p:txBody>
-      </p:sp>
-      <p:sp>
-        <p:nvSpPr>
-          <p:cNvPr id="3" name="Content Placeholder 2"/>
-          <p:cNvSpPr>
-            <a:spLocks noGrp="1"/>
-          </p:cNvSpPr>
-          <p:nvPr>
-            <p:ph idx="1"/>
-          </p:nvPr>
-        </p:nvSpPr>
-        <p:spPr/>
-        <p:txBody>
-          <a:bodyPr/>
-          <a:lstStyle/>
-          <a:p>
-            <a:pPr>
-              <a:defRPr sz="1700"/>
-            </a:pPr>
-            <a:r>
-              <a:t>Pré-treinar com grandes volumes de dados não rotulados e transferir as representações</a:t>
-            </a:r>
-          </a:p>
-          <a:p>
-            <a:pPr>
-              <a:defRPr sz="1700"/>
-            </a:pPr>
-            <a:r>
-              <a:t>Visão computacional: classificação, detecção de objetos, segmentação semântica, reconhecimento visual</a:t>
-            </a:r>
-          </a:p>
-          <a:p>
-            <a:pPr>
-              <a:defRPr sz="1700"/>
-            </a:pPr>
-            <a:r>
-              <a:t>Imagens médicas: radiografias, tomografias e ressonâncias; pré-treinamento sem anotação; extração de características para diagnóstico</a:t>
-            </a:r>
-          </a:p>
-          <a:p>
-            <a:pPr>
-              <a:defRPr sz="1700"/>
-            </a:pPr>
-            <a:r>
-              <a:t>Sensoriamento remoto: uso e cobertura do solo, detecção de mudanças, imagens de satélite, monitoramento ambiental e agrícola</a:t>
-            </a:r>
-          </a:p>
-          <a:p>
-            <a:pPr>
-              <a:defRPr sz="1700"/>
-            </a:pPr>
-            <a:r>
-              <a:t>Outras modalidades: linguagem natural, vídeos, áudio e aprendizado multimodal</a:t>
+              <a:t>Estudo de retreinamento: protocolo por identidade, época e seed</a:t>
+            </a:r>
+          </a:p>
+        </p:txBody>
+      </p:sp>
+      <p:graphicFrame>
+        <p:nvGraphicFramePr>
+          <p:cNvPr id="3" name="Table 2"/>
+          <p:cNvGraphicFramePr>
+            <a:graphicFrameLocks noGrp="1"/>
+          </p:cNvGraphicFramePr>
+          <p:nvPr/>
+        </p:nvGraphicFramePr>
+        <p:xfrm>
+          <a:off x="502920" y="1371600"/>
+          <a:ext cx="11247120" cy="4023360"/>
+        </p:xfrm>
+        <a:graphic>
+          <a:graphicData uri="http://schemas.openxmlformats.org/drawingml/2006/table">
+            <a:tbl>
+              <a:tblPr firstRow="1" bandRow="1">
+                <a:tableStyleId>{5C22544A-7EE6-4342-B048-85BDC9FD1C3A}</a:tableStyleId>
+              </a:tblPr>
+              <a:tblGrid>
+                <a:gridCol w="1737360"/>
+                <a:gridCol w="4754880"/>
+                <a:gridCol w="4754880"/>
+              </a:tblGrid>
+              <a:tr h="502920">
+                <a:tc>
+                  <a:txBody>
+                    <a:bodyPr/>
+                    <a:lstStyle/>
+                    <a:p>
+                      <a:pPr>
+                        <a:defRPr sz="1500" b="1"/>
+                      </a:pPr>
+                      <a:r>
+                        <a:t>registro</a:t>
+                      </a:r>
+                    </a:p>
+                  </a:txBody>
+                  <a:tcPr/>
+                </a:tc>
+                <a:tc>
+                  <a:txBody>
+                    <a:bodyPr/>
+                    <a:lstStyle/>
+                    <a:p>
+                      <a:pPr>
+                        <a:defRPr sz="1500" b="1"/>
+                      </a:pPr>
+                      <a:r>
+                        <a:t>taxa 50%</a:t>
+                      </a:r>
+                    </a:p>
+                  </a:txBody>
+                  <a:tcPr/>
+                </a:tc>
+                <a:tc>
+                  <a:txBody>
+                    <a:bodyPr/>
+                    <a:lstStyle/>
+                    <a:p>
+                      <a:pPr>
+                        <a:defRPr sz="1500" b="1"/>
+                      </a:pPr>
+                      <a:r>
+                        <a:t>taxa 75%</a:t>
+                      </a:r>
+                    </a:p>
+                  </a:txBody>
+                  <a:tcPr/>
+                </a:tc>
+              </a:tr>
+              <a:tr h="502920">
+                <a:tc>
+                  <a:txBody>
+                    <a:bodyPr/>
+                    <a:lstStyle/>
+                    <a:p>
+                      <a:pPr>
+                        <a:defRPr sz="1200" b="1"/>
+                      </a:pPr>
+                      <a:r>
+                        <a:t>C0: época piloto (s)</a:t>
+                      </a:r>
+                    </a:p>
+                  </a:txBody>
+                  <a:tcPr/>
+                </a:tc>
+                <a:tc>
+                  <a:txBody>
+                    <a:bodyPr/>
+                    <a:lstStyle/>
+                    <a:p>
+                      <a:pPr>
+                        <a:defRPr sz="1200" b="0"/>
+                      </a:pPr>
+                      <a:r>
+                        <a:t>1,22 s (&gt; limiar; candidato inviável)</a:t>
+                      </a:r>
+                    </a:p>
+                  </a:txBody>
+                  <a:tcPr/>
+                </a:tc>
+                <a:tc>
+                  <a:txBody>
+                    <a:bodyPr/>
+                    <a:lstStyle/>
+                    <a:p>
+                      <a:pPr>
+                        <a:defRPr sz="1200" b="0"/>
+                      </a:pPr>
+                      <a:r>
+                        <a:t>0,89 s</a:t>
+                      </a:r>
+                    </a:p>
+                  </a:txBody>
+                  <a:tcPr/>
+                </a:tc>
+              </a:tr>
+              <a:tr h="502920">
+                <a:tc>
+                  <a:txBody>
+                    <a:bodyPr/>
+                    <a:lstStyle/>
+                    <a:p>
+                      <a:pPr>
+                        <a:defRPr sz="1200" b="1"/>
+                      </a:pPr>
+                      <a:r>
+                        <a:t>C1: piloto (s)</a:t>
+                      </a:r>
+                    </a:p>
+                  </a:txBody>
+                  <a:tcPr/>
+                </a:tc>
+                <a:tc>
+                  <a:txBody>
+                    <a:bodyPr/>
+                    <a:lstStyle/>
+                    <a:p>
+                      <a:pPr>
+                        <a:defRPr sz="1200" b="0"/>
+                      </a:pPr>
+                      <a:r>
+                        <a:t>1,03 s</a:t>
+                      </a:r>
+                    </a:p>
+                  </a:txBody>
+                  <a:tcPr/>
+                </a:tc>
+                <a:tc>
+                  <a:txBody>
+                    <a:bodyPr/>
+                    <a:lstStyle/>
+                    <a:p>
+                      <a:pPr>
+                        <a:defRPr sz="1200" b="0"/>
+                      </a:pPr>
+                      <a:r>
+                        <a:t>1,16 s</a:t>
+                      </a:r>
+                    </a:p>
+                  </a:txBody>
+                  <a:tcPr/>
+                </a:tc>
+              </a:tr>
+              <a:tr h="502920">
+                <a:tc>
+                  <a:txBody>
+                    <a:bodyPr/>
+                    <a:lstStyle/>
+                    <a:p>
+                      <a:pPr>
+                        <a:defRPr sz="1200" b="1"/>
+                      </a:pPr>
+                      <a:r>
+                        <a:t>C2: piloto (s)</a:t>
+                      </a:r>
+                    </a:p>
+                  </a:txBody>
+                  <a:tcPr/>
+                </a:tc>
+                <a:tc>
+                  <a:txBody>
+                    <a:bodyPr/>
+                    <a:lstStyle/>
+                    <a:p>
+                      <a:pPr>
+                        <a:defRPr sz="1200" b="0"/>
+                      </a:pPr>
+                      <a:r>
+                        <a:t>1,03 s</a:t>
+                      </a:r>
+                    </a:p>
+                  </a:txBody>
+                  <a:tcPr/>
+                </a:tc>
+                <a:tc>
+                  <a:txBody>
+                    <a:bodyPr/>
+                    <a:lstStyle/>
+                    <a:p>
+                      <a:pPr>
+                        <a:defRPr sz="1200" b="0"/>
+                      </a:pPr>
+                      <a:r>
+                        <a:t>0,99 s</a:t>
+                      </a:r>
+                    </a:p>
+                  </a:txBody>
+                  <a:tcPr/>
+                </a:tc>
+              </a:tr>
+              <a:tr h="502920">
+                <a:tc>
+                  <a:txBody>
+                    <a:bodyPr/>
+                    <a:lstStyle/>
+                    <a:p>
+                      <a:pPr>
+                        <a:defRPr sz="1200" b="1"/>
+                      </a:pPr>
+                      <a:r>
+                        <a:t>C1: MSE mediano na melhor validação</a:t>
+                      </a:r>
+                    </a:p>
+                  </a:txBody>
+                  <a:tcPr/>
+                </a:tc>
+                <a:tc>
+                  <a:txBody>
+                    <a:bodyPr/>
+                    <a:lstStyle/>
+                    <a:p>
+                      <a:pPr>
+                        <a:defRPr sz="1200" b="0"/>
+                      </a:pPr>
+                      <a:r>
+                        <a:t>0,0336</a:t>
+                      </a:r>
+                    </a:p>
+                  </a:txBody>
+                  <a:tcPr/>
+                </a:tc>
+                <a:tc>
+                  <a:txBody>
+                    <a:bodyPr/>
+                    <a:lstStyle/>
+                    <a:p>
+                      <a:pPr>
+                        <a:defRPr sz="1200" b="0"/>
+                      </a:pPr>
+                      <a:r>
+                        <a:t>0,0418</a:t>
+                      </a:r>
+                    </a:p>
+                  </a:txBody>
+                  <a:tcPr/>
+                </a:tc>
+              </a:tr>
+              <a:tr h="502920">
+                <a:tc>
+                  <a:txBody>
+                    <a:bodyPr/>
+                    <a:lstStyle/>
+                    <a:p>
+                      <a:pPr>
+                        <a:defRPr sz="1200" b="1"/>
+                      </a:pPr>
+                      <a:r>
+                        <a:t>C2: MSE mediano na melhor validação</a:t>
+                      </a:r>
+                    </a:p>
+                  </a:txBody>
+                  <a:tcPr/>
+                </a:tc>
+                <a:tc>
+                  <a:txBody>
+                    <a:bodyPr/>
+                    <a:lstStyle/>
+                    <a:p>
+                      <a:pPr>
+                        <a:defRPr sz="1200" b="0"/>
+                      </a:pPr>
+                      <a:r>
+                        <a:t>0,0371</a:t>
+                      </a:r>
+                    </a:p>
+                  </a:txBody>
+                  <a:tcPr/>
+                </a:tc>
+                <a:tc>
+                  <a:txBody>
+                    <a:bodyPr/>
+                    <a:lstStyle/>
+                    <a:p>
+                      <a:pPr>
+                        <a:defRPr sz="1200" b="0"/>
+                      </a:pPr>
+                      <a:r>
+                        <a:t>0,0440</a:t>
+                      </a:r>
+                    </a:p>
+                  </a:txBody>
+                  <a:tcPr/>
+                </a:tc>
+              </a:tr>
+              <a:tr h="502920">
+                <a:tc>
+                  <a:txBody>
+                    <a:bodyPr/>
+                    <a:lstStyle/>
+                    <a:p>
+                      <a:pPr>
+                        <a:defRPr sz="1200" b="1"/>
+                      </a:pPr>
+                      <a:r>
+                        <a:t>controle média RGB (validação)</a:t>
+                      </a:r>
+                    </a:p>
+                  </a:txBody>
+                  <a:tcPr/>
+                </a:tc>
+                <a:tc>
+                  <a:txBody>
+                    <a:bodyPr/>
+                    <a:lstStyle/>
+                    <a:p>
+                      <a:pPr>
+                        <a:defRPr sz="1200" b="0"/>
+                      </a:pPr>
+                      <a:r>
+                        <a:t>0,0491</a:t>
+                      </a:r>
+                    </a:p>
+                  </a:txBody>
+                  <a:tcPr/>
+                </a:tc>
+                <a:tc>
+                  <a:txBody>
+                    <a:bodyPr/>
+                    <a:lstStyle/>
+                    <a:p>
+                      <a:pPr>
+                        <a:defRPr sz="1200" b="0"/>
+                      </a:pPr>
+                      <a:r>
+                        <a:t>0,0517</a:t>
+                      </a:r>
+                    </a:p>
+                  </a:txBody>
+                  <a:tcPr/>
+                </a:tc>
+              </a:tr>
+              <a:tr h="502920">
+                <a:tc>
+                  <a:txBody>
+                    <a:bodyPr/>
+                    <a:lstStyle/>
+                    <a:p>
+                      <a:pPr>
+                        <a:defRPr sz="1200" b="1"/>
+                      </a:pPr>
+                      <a:r>
+                        <a:t>controle interpolação (validação)</a:t>
+                      </a:r>
+                    </a:p>
+                  </a:txBody>
+                  <a:tcPr/>
+                </a:tc>
+                <a:tc>
+                  <a:txBody>
+                    <a:bodyPr/>
+                    <a:lstStyle/>
+                    <a:p>
+                      <a:pPr>
+                        <a:defRPr sz="1200" b="0"/>
+                      </a:pPr>
+                      <a:r>
+                        <a:t>0,0447</a:t>
+                      </a:r>
+                    </a:p>
+                  </a:txBody>
+                  <a:tcPr/>
+                </a:tc>
+                <a:tc>
+                  <a:txBody>
+                    <a:bodyPr/>
+                    <a:lstStyle/>
+                    <a:p>
+                      <a:pPr>
+                        <a:defRPr sz="1200" b="0"/>
+                      </a:pPr>
+                      <a:r>
+                        <a:t>0,0545</a:t>
+                      </a:r>
+                    </a:p>
+                  </a:txBody>
+                  <a:tcPr/>
+                </a:tc>
+              </a:tr>
+            </a:tbl>
+          </a:graphicData>
+        </a:graphic>
+      </p:graphicFrame>
+      <p:sp>
+        <p:nvSpPr>
+          <p:cNvPr id="4" name="TextBox 3"/>
+          <p:cNvSpPr txBox="1"/>
+          <p:nvPr/>
+        </p:nvSpPr>
+        <p:spPr>
+          <a:xfrm>
+            <a:off x="502920" y="5623560"/>
+            <a:ext cx="11247120" cy="1005840"/>
+          </a:xfrm>
+          <a:prstGeom prst="rect">
+            <a:avLst/>
+          </a:prstGeom>
+          <a:noFill/>
+        </p:spPr>
+        <p:txBody>
+          <a:bodyPr wrap="square">
+            <a:spAutoFit/>
+          </a:bodyPr>
+          <a:lstStyle/>
+          <a:p>
+            <a:pPr>
+              <a:defRPr sz="1300" b="0">
+                <a:latin typeface="Arial"/>
+              </a:defRPr>
+            </a:pPr>
+            <a:r>
+              <a:t>Rodada v1: seeds 10, 20 e 30; máximo planejado de 200 épocas por taxa. C1, seed 10 a 75%: 185 épocas efetivas. Sem C0 treinado, não há ganho demonstrado contra C0. V1: 41,1 min principais, reserva intocada naquela rodada. V2: pilotos inviáveis, seis treinos não iniciados; reserva consumida 0,209334139 min; total v1 + v2: 41,270848124 min. Avaliação visual aberta de um avaliador humano: ruim nas duas taxas, objetivo visual não atingido. Fichas não cegas (cabeçalho revela métodos). Exploratório, sem confirmação ou superioridade universal. Fontes: histórico v1, contador v2, notas-finais.md e retificacao-validacao.json (controles com estado=validacao).</a:t>
             </a:r>
           </a:p>
         </p:txBody>

</xml_diff>

<commit_message>
feat(mae): fortalecer protocolo de reconstruções (#6)
</commit_message>
<xml_diff>
--- a/slides/seminario_masked_modeling.pptx
+++ b/slides/seminario_masked_modeling.pptx
@@ -17,6 +17,7 @@
     <p:sldId id="265" r:id="rId16"/>
     <p:sldId id="266" r:id="rId17"/>
     <p:sldId id="267" r:id="rId18"/>
+    <p:sldId id="268" r:id="rId19"/>
   </p:sldIdLst>
   <p:sldSz cx="12191695" cy="6858000" type="screen4x3"/>
   <p:notesSz cx="6858000" cy="9144000"/>
@@ -3192,7 +3193,7 @@
               <a:defRPr sz="3000"/>
             </a:pPr>
             <a:r>
-              <a:t>Pós MAE e tarefas downstream</a:t>
+              <a:t>Aplicações por domínio</a:t>
             </a:r>
           </a:p>
         </p:txBody>
@@ -3216,7 +3217,7 @@
               <a:defRPr sz="1700"/>
             </a:pPr>
             <a:r>
-              <a:t>Pré-treinamento: o MAE usa grandes volumes de imagens não rotuladas; parte dos patches é mascarada e o modelo aprende a reconstruir</a:t>
+              <a:t>Pré-treinar com grandes volumes de dados não rotulados e transferir as representações</a:t>
             </a:r>
           </a:p>
           <a:p>
@@ -3224,7 +3225,7 @@
               <a:defRPr sz="1700"/>
             </a:pPr>
             <a:r>
-              <a:t>Nesse processo, o encoder ViT aprende representações visuais das imagens</a:t>
+              <a:t>Visão computacional: classificação, detecção de objetos, segmentação semântica, reconhecimento visual</a:t>
             </a:r>
           </a:p>
           <a:p>
@@ -3232,7 +3233,7 @@
               <a:defRPr sz="1700"/>
             </a:pPr>
             <a:r>
-              <a:t>Depois do pré-treinamento, o decoder pode ser descartado: sua função principal era auxiliar a reconstrução</a:t>
+              <a:t>Imagens médicas: radiografias, tomografias e ressonâncias; pré-treinamento sem anotação; extração de características para diagnóstico</a:t>
             </a:r>
           </a:p>
           <a:p>
@@ -3240,7 +3241,7 @@
               <a:defRPr sz="1700"/>
             </a:pPr>
             <a:r>
-              <a:t>O encoder pré-treinado é reutilizado em tarefas downstream: classificação de imagens, detecção de objetos e segmentação semântica</a:t>
+              <a:t>Sensoriamento remoto: uso e cobertura do solo, detecção de mudanças, imagens de satélite, monitoramento ambiental e agrícola</a:t>
             </a:r>
           </a:p>
           <a:p>
@@ -3248,15 +3249,7 @@
               <a:defRPr sz="1700"/>
             </a:pPr>
             <a:r>
-              <a:t>Uso do encoder: extrator de características ou pesos ajustados por fine-tuning para a nova tarefa</a:t>
-            </a:r>
-          </a:p>
-          <a:p>
-            <a:pPr>
-              <a:defRPr sz="1700"/>
-            </a:pPr>
-            <a:r>
-              <a:t>Eco do nosso diagrama: o decoder leve sai e o encoder pesado fica</a:t>
+              <a:t>Outras modalidades: linguagem natural, vídeos, áudio e aprendizado multimodal</a:t>
             </a:r>
           </a:p>
         </p:txBody>
@@ -3298,7 +3291,7 @@
               <a:defRPr sz="3000"/>
             </a:pPr>
             <a:r>
-              <a:t>Conclusões</a:t>
+              <a:t>Pós MAE e tarefas downstream</a:t>
             </a:r>
           </a:p>
         </p:txBody>
@@ -3322,7 +3315,7 @@
               <a:defRPr sz="1700"/>
             </a:pPr>
             <a:r>
-              <a:t>Reconstruir o que foi escondido não é o objetivo final: é o mecanismo para o modelo aprender boas representações</a:t>
+              <a:t>Pré-treinamento: o MAE usa grandes volumes de imagens não rotuladas; parte dos patches é mascarada e o modelo aprende a reconstruir</a:t>
             </a:r>
           </a:p>
           <a:p>
@@ -3330,7 +3323,7 @@
               <a:defRPr sz="1700"/>
             </a:pPr>
             <a:r>
-              <a:t>O mascaramento aproveita dados não rotulados, em texto (BERT) e em imagens (MAE)</a:t>
+              <a:t>Nesse processo, o encoder ViT aprende representações visuais das imagens</a:t>
             </a:r>
           </a:p>
           <a:p>
@@ -3338,7 +3331,7 @@
               <a:defRPr sz="1700"/>
             </a:pPr>
             <a:r>
-              <a:t>No experimento próprio, 75% mascarado errou mais que 50%: nesta configuração, mascarar mais elevou o erro (semente única 42)</a:t>
+              <a:t>Depois do pré-treinamento, o decoder pode ser descartado: sua função principal era auxiliar a reconstrução</a:t>
             </a:r>
           </a:p>
           <a:p>
@@ -3346,7 +3339,7 @@
               <a:defRPr sz="1700"/>
             </a:pPr>
             <a:r>
-              <a:t>No experimento complementar com MAE pré-treinado público, as taxas maiores de mascaramento elevaram o MSE registrado no material complementar</a:t>
+              <a:t>O encoder pré-treinado é reutilizado em tarefas downstream: classificação de imagens, detecção de objetos e segmentação semântica</a:t>
             </a:r>
           </a:p>
           <a:p>
@@ -3354,7 +3347,7 @@
               <a:defRPr sz="1700"/>
             </a:pPr>
             <a:r>
-              <a:t>Leitura delimitada: qualidade visual da reconstrução não é prova de representações melhores</a:t>
+              <a:t>Uso do encoder: extrator de características ou pesos ajustados por fine-tuning para a nova tarefa</a:t>
             </a:r>
           </a:p>
           <a:p>
@@ -3362,7 +3355,7 @@
               <a:defRPr sz="1700"/>
             </a:pPr>
             <a:r>
-              <a:t>Repetição com mais sementes e avaliação downstream continuam necessárias antes de generalizar</a:t>
+              <a:t>Eco do nosso diagrama: o decoder leve sai e o encoder pesado fica</a:t>
             </a:r>
           </a:p>
         </p:txBody>
@@ -3376,6 +3369,112 @@
 </file>
 
 <file path=ppt/slides/slide12.xml><?xml version="1.0" encoding="utf-8"?>
+<p:sld xmlns:a="http://schemas.openxmlformats.org/drawingml/2006/main" xmlns:p="http://schemas.openxmlformats.org/presentationml/2006/main" xmlns:r="http://schemas.openxmlformats.org/officeDocument/2006/relationships">
+  <p:cSld>
+    <p:spTree>
+      <p:nvGrpSpPr>
+        <p:cNvPr id="1" name=""/>
+        <p:cNvGrpSpPr/>
+        <p:nvPr/>
+      </p:nvGrpSpPr>
+      <p:grpSpPr/>
+      <p:sp>
+        <p:nvSpPr>
+          <p:cNvPr id="2" name="Title 1"/>
+          <p:cNvSpPr>
+            <a:spLocks noGrp="1"/>
+          </p:cNvSpPr>
+          <p:nvPr>
+            <p:ph type="title"/>
+          </p:nvPr>
+        </p:nvSpPr>
+        <p:spPr/>
+        <p:txBody>
+          <a:bodyPr/>
+          <a:lstStyle/>
+          <a:p>
+            <a:pPr>
+              <a:defRPr sz="3000"/>
+            </a:pPr>
+            <a:r>
+              <a:t>Conclusões</a:t>
+            </a:r>
+          </a:p>
+        </p:txBody>
+      </p:sp>
+      <p:sp>
+        <p:nvSpPr>
+          <p:cNvPr id="3" name="Content Placeholder 2"/>
+          <p:cNvSpPr>
+            <a:spLocks noGrp="1"/>
+          </p:cNvSpPr>
+          <p:nvPr>
+            <p:ph idx="1"/>
+          </p:nvPr>
+        </p:nvSpPr>
+        <p:spPr/>
+        <p:txBody>
+          <a:bodyPr/>
+          <a:lstStyle/>
+          <a:p>
+            <a:pPr>
+              <a:defRPr sz="1700"/>
+            </a:pPr>
+            <a:r>
+              <a:t>Reconstruir o que foi escondido não é o objetivo final: é o mecanismo para o modelo aprender boas representações</a:t>
+            </a:r>
+          </a:p>
+          <a:p>
+            <a:pPr>
+              <a:defRPr sz="1700"/>
+            </a:pPr>
+            <a:r>
+              <a:t>O mascaramento aproveita dados não rotulados, em texto (BERT) e em imagens (MAE)</a:t>
+            </a:r>
+          </a:p>
+          <a:p>
+            <a:pPr>
+              <a:defRPr sz="1700"/>
+            </a:pPr>
+            <a:r>
+              <a:t>No experimento próprio, 75% mascarado errou mais que 50%: nesta configuração, mascarar mais elevou o erro (semente única 42)</a:t>
+            </a:r>
+          </a:p>
+          <a:p>
+            <a:pPr>
+              <a:defRPr sz="1700"/>
+            </a:pPr>
+            <a:r>
+              <a:t>No experimento complementar com MAE pré-treinado público, as taxas maiores de mascaramento elevaram o MSE registrado no material complementar</a:t>
+            </a:r>
+          </a:p>
+          <a:p>
+            <a:pPr>
+              <a:defRPr sz="1700"/>
+            </a:pPr>
+            <a:r>
+              <a:t>Leitura delimitada: qualidade visual da reconstrução não é prova de representações melhores</a:t>
+            </a:r>
+          </a:p>
+          <a:p>
+            <a:pPr>
+              <a:defRPr sz="1700"/>
+            </a:pPr>
+            <a:r>
+              <a:t>Repetição com mais sementes e avaliação downstream continuam necessárias antes de generalizar</a:t>
+            </a:r>
+          </a:p>
+        </p:txBody>
+      </p:sp>
+    </p:spTree>
+  </p:cSld>
+  <p:clrMapOvr>
+    <a:masterClrMapping/>
+  </p:clrMapOvr>
+</p:sld>
+</file>
+
+<file path=ppt/slides/slide13.xml><?xml version="1.0" encoding="utf-8"?>
 <p:sld xmlns:a="http://schemas.openxmlformats.org/drawingml/2006/main" xmlns:p="http://schemas.openxmlformats.org/presentationml/2006/main" xmlns:r="http://schemas.openxmlformats.org/officeDocument/2006/relationships">
   <p:cSld>
     <p:spTree>
@@ -6049,63 +6148,443 @@
               <a:defRPr sz="3000"/>
             </a:pPr>
             <a:r>
-              <a:t>Aplicações por domínio</a:t>
-            </a:r>
-          </a:p>
-        </p:txBody>
-      </p:sp>
-      <p:sp>
-        <p:nvSpPr>
-          <p:cNvPr id="3" name="Content Placeholder 2"/>
-          <p:cNvSpPr>
-            <a:spLocks noGrp="1"/>
-          </p:cNvSpPr>
-          <p:nvPr>
-            <p:ph idx="1"/>
-          </p:nvPr>
-        </p:nvSpPr>
-        <p:spPr/>
-        <p:txBody>
-          <a:bodyPr/>
-          <a:lstStyle/>
-          <a:p>
-            <a:pPr>
-              <a:defRPr sz="1700"/>
-            </a:pPr>
-            <a:r>
-              <a:t>Pré-treinar com grandes volumes de dados não rotulados e transferir as representações</a:t>
-            </a:r>
-          </a:p>
-          <a:p>
-            <a:pPr>
-              <a:defRPr sz="1700"/>
-            </a:pPr>
-            <a:r>
-              <a:t>Visão computacional: classificação, detecção de objetos, segmentação semântica, reconhecimento visual</a:t>
-            </a:r>
-          </a:p>
-          <a:p>
-            <a:pPr>
-              <a:defRPr sz="1700"/>
-            </a:pPr>
-            <a:r>
-              <a:t>Imagens médicas: radiografias, tomografias e ressonâncias; pré-treinamento sem anotação; extração de características para diagnóstico</a:t>
-            </a:r>
-          </a:p>
-          <a:p>
-            <a:pPr>
-              <a:defRPr sz="1700"/>
-            </a:pPr>
-            <a:r>
-              <a:t>Sensoriamento remoto: uso e cobertura do solo, detecção de mudanças, imagens de satélite, monitoramento ambiental e agrícola</a:t>
-            </a:r>
-          </a:p>
-          <a:p>
-            <a:pPr>
-              <a:defRPr sz="1700"/>
-            </a:pPr>
-            <a:r>
-              <a:t>Outras modalidades: linguagem natural, vídeos, áudio e aprendizado multimodal</a:t>
+              <a:t>Estudo de retreinamento: protocolo por identidade, época e seed</a:t>
+            </a:r>
+          </a:p>
+        </p:txBody>
+      </p:sp>
+      <p:graphicFrame>
+        <p:nvGraphicFramePr>
+          <p:cNvPr id="3" name="Table 2"/>
+          <p:cNvGraphicFramePr>
+            <a:graphicFrameLocks noGrp="1"/>
+          </p:cNvGraphicFramePr>
+          <p:nvPr/>
+        </p:nvGraphicFramePr>
+        <p:xfrm>
+          <a:off x="502920" y="1371600"/>
+          <a:ext cx="11247120" cy="4023360"/>
+        </p:xfrm>
+        <a:graphic>
+          <a:graphicData uri="http://schemas.openxmlformats.org/drawingml/2006/table">
+            <a:tbl>
+              <a:tblPr firstRow="1" bandRow="1">
+                <a:tableStyleId>{5C22544A-7EE6-4342-B048-85BDC9FD1C3A}</a:tableStyleId>
+              </a:tblPr>
+              <a:tblGrid>
+                <a:gridCol w="1737360"/>
+                <a:gridCol w="4754880"/>
+                <a:gridCol w="4754880"/>
+              </a:tblGrid>
+              <a:tr h="502920">
+                <a:tc>
+                  <a:txBody>
+                    <a:bodyPr/>
+                    <a:lstStyle/>
+                    <a:p>
+                      <a:pPr>
+                        <a:defRPr sz="1500" b="1"/>
+                      </a:pPr>
+                      <a:r>
+                        <a:t>registro</a:t>
+                      </a:r>
+                    </a:p>
+                  </a:txBody>
+                  <a:tcPr/>
+                </a:tc>
+                <a:tc>
+                  <a:txBody>
+                    <a:bodyPr/>
+                    <a:lstStyle/>
+                    <a:p>
+                      <a:pPr>
+                        <a:defRPr sz="1500" b="1"/>
+                      </a:pPr>
+                      <a:r>
+                        <a:t>taxa 50%</a:t>
+                      </a:r>
+                    </a:p>
+                  </a:txBody>
+                  <a:tcPr/>
+                </a:tc>
+                <a:tc>
+                  <a:txBody>
+                    <a:bodyPr/>
+                    <a:lstStyle/>
+                    <a:p>
+                      <a:pPr>
+                        <a:defRPr sz="1500" b="1"/>
+                      </a:pPr>
+                      <a:r>
+                        <a:t>taxa 75%</a:t>
+                      </a:r>
+                    </a:p>
+                  </a:txBody>
+                  <a:tcPr/>
+                </a:tc>
+              </a:tr>
+              <a:tr h="502920">
+                <a:tc>
+                  <a:txBody>
+                    <a:bodyPr/>
+                    <a:lstStyle/>
+                    <a:p>
+                      <a:pPr>
+                        <a:defRPr sz="1200" b="1"/>
+                      </a:pPr>
+                      <a:r>
+                        <a:t>C0: época piloto (s)</a:t>
+                      </a:r>
+                    </a:p>
+                  </a:txBody>
+                  <a:tcPr/>
+                </a:tc>
+                <a:tc>
+                  <a:txBody>
+                    <a:bodyPr/>
+                    <a:lstStyle/>
+                    <a:p>
+                      <a:pPr>
+                        <a:defRPr sz="1200" b="0"/>
+                      </a:pPr>
+                      <a:r>
+                        <a:t>1,22 s (&gt; limiar; candidato inviável)</a:t>
+                      </a:r>
+                    </a:p>
+                  </a:txBody>
+                  <a:tcPr/>
+                </a:tc>
+                <a:tc>
+                  <a:txBody>
+                    <a:bodyPr/>
+                    <a:lstStyle/>
+                    <a:p>
+                      <a:pPr>
+                        <a:defRPr sz="1200" b="0"/>
+                      </a:pPr>
+                      <a:r>
+                        <a:t>0,89 s</a:t>
+                      </a:r>
+                    </a:p>
+                  </a:txBody>
+                  <a:tcPr/>
+                </a:tc>
+              </a:tr>
+              <a:tr h="502920">
+                <a:tc>
+                  <a:txBody>
+                    <a:bodyPr/>
+                    <a:lstStyle/>
+                    <a:p>
+                      <a:pPr>
+                        <a:defRPr sz="1200" b="1"/>
+                      </a:pPr>
+                      <a:r>
+                        <a:t>C1: piloto (s)</a:t>
+                      </a:r>
+                    </a:p>
+                  </a:txBody>
+                  <a:tcPr/>
+                </a:tc>
+                <a:tc>
+                  <a:txBody>
+                    <a:bodyPr/>
+                    <a:lstStyle/>
+                    <a:p>
+                      <a:pPr>
+                        <a:defRPr sz="1200" b="0"/>
+                      </a:pPr>
+                      <a:r>
+                        <a:t>1,03 s</a:t>
+                      </a:r>
+                    </a:p>
+                  </a:txBody>
+                  <a:tcPr/>
+                </a:tc>
+                <a:tc>
+                  <a:txBody>
+                    <a:bodyPr/>
+                    <a:lstStyle/>
+                    <a:p>
+                      <a:pPr>
+                        <a:defRPr sz="1200" b="0"/>
+                      </a:pPr>
+                      <a:r>
+                        <a:t>1,16 s</a:t>
+                      </a:r>
+                    </a:p>
+                  </a:txBody>
+                  <a:tcPr/>
+                </a:tc>
+              </a:tr>
+              <a:tr h="502920">
+                <a:tc>
+                  <a:txBody>
+                    <a:bodyPr/>
+                    <a:lstStyle/>
+                    <a:p>
+                      <a:pPr>
+                        <a:defRPr sz="1200" b="1"/>
+                      </a:pPr>
+                      <a:r>
+                        <a:t>C2: piloto (s)</a:t>
+                      </a:r>
+                    </a:p>
+                  </a:txBody>
+                  <a:tcPr/>
+                </a:tc>
+                <a:tc>
+                  <a:txBody>
+                    <a:bodyPr/>
+                    <a:lstStyle/>
+                    <a:p>
+                      <a:pPr>
+                        <a:defRPr sz="1200" b="0"/>
+                      </a:pPr>
+                      <a:r>
+                        <a:t>1,03 s</a:t>
+                      </a:r>
+                    </a:p>
+                  </a:txBody>
+                  <a:tcPr/>
+                </a:tc>
+                <a:tc>
+                  <a:txBody>
+                    <a:bodyPr/>
+                    <a:lstStyle/>
+                    <a:p>
+                      <a:pPr>
+                        <a:defRPr sz="1200" b="0"/>
+                      </a:pPr>
+                      <a:r>
+                        <a:t>0,99 s</a:t>
+                      </a:r>
+                    </a:p>
+                  </a:txBody>
+                  <a:tcPr/>
+                </a:tc>
+              </a:tr>
+              <a:tr h="502920">
+                <a:tc>
+                  <a:txBody>
+                    <a:bodyPr/>
+                    <a:lstStyle/>
+                    <a:p>
+                      <a:pPr>
+                        <a:defRPr sz="1200" b="1"/>
+                      </a:pPr>
+                      <a:r>
+                        <a:t>C1: MSE mediano na melhor validação</a:t>
+                      </a:r>
+                    </a:p>
+                  </a:txBody>
+                  <a:tcPr/>
+                </a:tc>
+                <a:tc>
+                  <a:txBody>
+                    <a:bodyPr/>
+                    <a:lstStyle/>
+                    <a:p>
+                      <a:pPr>
+                        <a:defRPr sz="1200" b="0"/>
+                      </a:pPr>
+                      <a:r>
+                        <a:t>0,0336</a:t>
+                      </a:r>
+                    </a:p>
+                  </a:txBody>
+                  <a:tcPr/>
+                </a:tc>
+                <a:tc>
+                  <a:txBody>
+                    <a:bodyPr/>
+                    <a:lstStyle/>
+                    <a:p>
+                      <a:pPr>
+                        <a:defRPr sz="1200" b="0"/>
+                      </a:pPr>
+                      <a:r>
+                        <a:t>0,0418</a:t>
+                      </a:r>
+                    </a:p>
+                  </a:txBody>
+                  <a:tcPr/>
+                </a:tc>
+              </a:tr>
+              <a:tr h="502920">
+                <a:tc>
+                  <a:txBody>
+                    <a:bodyPr/>
+                    <a:lstStyle/>
+                    <a:p>
+                      <a:pPr>
+                        <a:defRPr sz="1200" b="1"/>
+                      </a:pPr>
+                      <a:r>
+                        <a:t>C2: MSE mediano na melhor validação</a:t>
+                      </a:r>
+                    </a:p>
+                  </a:txBody>
+                  <a:tcPr/>
+                </a:tc>
+                <a:tc>
+                  <a:txBody>
+                    <a:bodyPr/>
+                    <a:lstStyle/>
+                    <a:p>
+                      <a:pPr>
+                        <a:defRPr sz="1200" b="0"/>
+                      </a:pPr>
+                      <a:r>
+                        <a:t>0,0371</a:t>
+                      </a:r>
+                    </a:p>
+                  </a:txBody>
+                  <a:tcPr/>
+                </a:tc>
+                <a:tc>
+                  <a:txBody>
+                    <a:bodyPr/>
+                    <a:lstStyle/>
+                    <a:p>
+                      <a:pPr>
+                        <a:defRPr sz="1200" b="0"/>
+                      </a:pPr>
+                      <a:r>
+                        <a:t>0,0440</a:t>
+                      </a:r>
+                    </a:p>
+                  </a:txBody>
+                  <a:tcPr/>
+                </a:tc>
+              </a:tr>
+              <a:tr h="502920">
+                <a:tc>
+                  <a:txBody>
+                    <a:bodyPr/>
+                    <a:lstStyle/>
+                    <a:p>
+                      <a:pPr>
+                        <a:defRPr sz="1200" b="1"/>
+                      </a:pPr>
+                      <a:r>
+                        <a:t>controle média RGB (validação)</a:t>
+                      </a:r>
+                    </a:p>
+                  </a:txBody>
+                  <a:tcPr/>
+                </a:tc>
+                <a:tc>
+                  <a:txBody>
+                    <a:bodyPr/>
+                    <a:lstStyle/>
+                    <a:p>
+                      <a:pPr>
+                        <a:defRPr sz="1200" b="0"/>
+                      </a:pPr>
+                      <a:r>
+                        <a:t>0,0491</a:t>
+                      </a:r>
+                    </a:p>
+                  </a:txBody>
+                  <a:tcPr/>
+                </a:tc>
+                <a:tc>
+                  <a:txBody>
+                    <a:bodyPr/>
+                    <a:lstStyle/>
+                    <a:p>
+                      <a:pPr>
+                        <a:defRPr sz="1200" b="0"/>
+                      </a:pPr>
+                      <a:r>
+                        <a:t>0,0517</a:t>
+                      </a:r>
+                    </a:p>
+                  </a:txBody>
+                  <a:tcPr/>
+                </a:tc>
+              </a:tr>
+              <a:tr h="502920">
+                <a:tc>
+                  <a:txBody>
+                    <a:bodyPr/>
+                    <a:lstStyle/>
+                    <a:p>
+                      <a:pPr>
+                        <a:defRPr sz="1200" b="1"/>
+                      </a:pPr>
+                      <a:r>
+                        <a:t>controle interpolação (validação)</a:t>
+                      </a:r>
+                    </a:p>
+                  </a:txBody>
+                  <a:tcPr/>
+                </a:tc>
+                <a:tc>
+                  <a:txBody>
+                    <a:bodyPr/>
+                    <a:lstStyle/>
+                    <a:p>
+                      <a:pPr>
+                        <a:defRPr sz="1200" b="0"/>
+                      </a:pPr>
+                      <a:r>
+                        <a:t>0,0447</a:t>
+                      </a:r>
+                    </a:p>
+                  </a:txBody>
+                  <a:tcPr/>
+                </a:tc>
+                <a:tc>
+                  <a:txBody>
+                    <a:bodyPr/>
+                    <a:lstStyle/>
+                    <a:p>
+                      <a:pPr>
+                        <a:defRPr sz="1200" b="0"/>
+                      </a:pPr>
+                      <a:r>
+                        <a:t>0,0545</a:t>
+                      </a:r>
+                    </a:p>
+                  </a:txBody>
+                  <a:tcPr/>
+                </a:tc>
+              </a:tr>
+            </a:tbl>
+          </a:graphicData>
+        </a:graphic>
+      </p:graphicFrame>
+      <p:sp>
+        <p:nvSpPr>
+          <p:cNvPr id="4" name="TextBox 3"/>
+          <p:cNvSpPr txBox="1"/>
+          <p:nvPr/>
+        </p:nvSpPr>
+        <p:spPr>
+          <a:xfrm>
+            <a:off x="502920" y="5623560"/>
+            <a:ext cx="11247120" cy="1005840"/>
+          </a:xfrm>
+          <a:prstGeom prst="rect">
+            <a:avLst/>
+          </a:prstGeom>
+          <a:noFill/>
+        </p:spPr>
+        <p:txBody>
+          <a:bodyPr wrap="square">
+            <a:spAutoFit/>
+          </a:bodyPr>
+          <a:lstStyle/>
+          <a:p>
+            <a:pPr>
+              <a:defRPr sz="1300" b="0">
+                <a:latin typeface="Arial"/>
+              </a:defRPr>
+            </a:pPr>
+            <a:r>
+              <a:t>Rodada v1: seeds 10, 20 e 30; máximo planejado de 200 épocas por taxa. C1, seed 10 a 75%: 185 épocas efetivas. Sem C0 treinado, não há ganho demonstrado contra C0. V1: 41,1 min principais, reserva intocada naquela rodada. V2: pilotos inviáveis, seis treinos não iniciados; reserva consumida 0,209334139 min; total v1 + v2: 41,270848124 min. Avaliação visual aberta de um avaliador humano: ruim nas duas taxas, objetivo visual não atingido. Fichas não cegas (cabeçalho revela métodos). Exploratório, sem confirmação ou superioridade universal. Fontes: histórico v1, contador v2, notas-finais.md e retificacao-validacao.json (controles com estado=validacao).</a:t>
             </a:r>
           </a:p>
         </p:txBody>

</xml_diff>